<commit_message>
Update SmartCourse presentation for project-only content
</commit_message>
<xml_diff>
--- a/project-documents/SmartCourse_FYP_Viva_Guide_Updated.pptx
+++ b/project-documents/SmartCourse_FYP_Viva_Guide_Updated.pptx
@@ -2,26 +2,26 @@
 <file path=ppt/presentation.xml><?xml version="1.0" encoding="utf-8"?>
 <p:presentation xmlns:p="http://schemas.openxmlformats.org/presentationml/2006/main">
   <p:sldMasterIdLst>
-    <p:sldMasterId xmlns:r="http://schemas.openxmlformats.org/officeDocument/2006/relationships" id="2147483648" r:id="R28a698d2178c4689"/>
+    <p:sldMasterId xmlns:r="http://schemas.openxmlformats.org/officeDocument/2006/relationships" id="2147483648" r:id="R28330f5c128340c7"/>
   </p:sldMasterIdLst>
   <p:notesMasterIdLst>
-    <p:notesMasterId xmlns:r="http://schemas.openxmlformats.org/officeDocument/2006/relationships" r:id="R6df1b1786cf44695"/>
+    <p:notesMasterId xmlns:r="http://schemas.openxmlformats.org/officeDocument/2006/relationships" r:id="Rd68704f5d0b54d12"/>
   </p:notesMasterIdLst>
   <p:sldIdLst>
-    <p:sldId xmlns:r="http://schemas.openxmlformats.org/officeDocument/2006/relationships" id="256" r:id="R3f045a5d65664d8e"/>
-    <p:sldId xmlns:r="http://schemas.openxmlformats.org/officeDocument/2006/relationships" id="257" r:id="Rbe6e9f1f539545b3"/>
-    <p:sldId xmlns:r="http://schemas.openxmlformats.org/officeDocument/2006/relationships" id="258" r:id="Re37af337b084495a"/>
-    <p:sldId xmlns:r="http://schemas.openxmlformats.org/officeDocument/2006/relationships" id="259" r:id="R12b8b9ad290a4afd"/>
-    <p:sldId xmlns:r="http://schemas.openxmlformats.org/officeDocument/2006/relationships" id="260" r:id="R86e54330fae44ca9"/>
-    <p:sldId xmlns:r="http://schemas.openxmlformats.org/officeDocument/2006/relationships" id="261" r:id="R7e835828bfc34f8a"/>
-    <p:sldId xmlns:r="http://schemas.openxmlformats.org/officeDocument/2006/relationships" id="262" r:id="R82cc7fb03bf14dce"/>
-    <p:sldId xmlns:r="http://schemas.openxmlformats.org/officeDocument/2006/relationships" id="263" r:id="R155abe86a8424c1f"/>
-    <p:sldId xmlns:r="http://schemas.openxmlformats.org/officeDocument/2006/relationships" id="264" r:id="R3ead33c8f1c84423"/>
-    <p:sldId xmlns:r="http://schemas.openxmlformats.org/officeDocument/2006/relationships" id="265" r:id="R6c0b9de44615482f"/>
-    <p:sldId xmlns:r="http://schemas.openxmlformats.org/officeDocument/2006/relationships" id="266" r:id="Raa0b9f5a0c9f4738"/>
-    <p:sldId xmlns:r="http://schemas.openxmlformats.org/officeDocument/2006/relationships" id="267" r:id="Rf2255377bca5456b"/>
-    <p:sldId xmlns:r="http://schemas.openxmlformats.org/officeDocument/2006/relationships" id="268" r:id="R7afc0352e6214a04"/>
-    <p:sldId xmlns:r="http://schemas.openxmlformats.org/officeDocument/2006/relationships" id="269" r:id="R6b5f51206a714ab5"/>
+    <p:sldId xmlns:r="http://schemas.openxmlformats.org/officeDocument/2006/relationships" id="256" r:id="R09991c399d024f60"/>
+    <p:sldId xmlns:r="http://schemas.openxmlformats.org/officeDocument/2006/relationships" id="257" r:id="Rb13c6f0fa9da4005"/>
+    <p:sldId xmlns:r="http://schemas.openxmlformats.org/officeDocument/2006/relationships" id="258" r:id="R40cd0f585ed64398"/>
+    <p:sldId xmlns:r="http://schemas.openxmlformats.org/officeDocument/2006/relationships" id="259" r:id="R6fb5a687a3c8468d"/>
+    <p:sldId xmlns:r="http://schemas.openxmlformats.org/officeDocument/2006/relationships" id="260" r:id="R747a550319764ab3"/>
+    <p:sldId xmlns:r="http://schemas.openxmlformats.org/officeDocument/2006/relationships" id="261" r:id="R8fb93db3e2d64367"/>
+    <p:sldId xmlns:r="http://schemas.openxmlformats.org/officeDocument/2006/relationships" id="262" r:id="R091e6962c4c546ab"/>
+    <p:sldId xmlns:r="http://schemas.openxmlformats.org/officeDocument/2006/relationships" id="263" r:id="R45705edfec0d4221"/>
+    <p:sldId xmlns:r="http://schemas.openxmlformats.org/officeDocument/2006/relationships" id="264" r:id="Rf6d4ff25cb6f4fe3"/>
+    <p:sldId xmlns:r="http://schemas.openxmlformats.org/officeDocument/2006/relationships" id="265" r:id="Rd7a68e8692de4f78"/>
+    <p:sldId xmlns:r="http://schemas.openxmlformats.org/officeDocument/2006/relationships" id="266" r:id="R32ae681f02b44549"/>
+    <p:sldId xmlns:r="http://schemas.openxmlformats.org/officeDocument/2006/relationships" id="267" r:id="Rd7d00b1da6f048c9"/>
+    <p:sldId xmlns:r="http://schemas.openxmlformats.org/officeDocument/2006/relationships" id="268" r:id="Rd0fc89fc60bb4eda"/>
+    <p:sldId xmlns:r="http://schemas.openxmlformats.org/officeDocument/2006/relationships" id="269" r:id="Rb8fab43cc1b14f49"/>
   </p:sldIdLst>
   <p:sldSz cx="12192000" cy="6858000"/>
   <p:notesSz cx="6858000" cy="9144000"/>
@@ -650,7 +650,7 @@
           <a:lstStyle xmlns:a="http://schemas.openxmlformats.org/drawingml/2006/main"/>
           <a:p xmlns:a="http://schemas.openxmlformats.org/drawingml/2006/main">
             <a:r>
-              <a:t>Do not invent metric values during the viva. Explain the definitions and the evaluation procedure. If asked for results, show the output after running the script in the correct environment.</a:t>
+              <a:t>The evaluation slide defines the metrics and the test procedure. Report measured values only after running the evaluation script in the correct environment.</a:t>
             </a:r>
           </a:p>
           <a:p xmlns:a="http://schemas.openxmlformats.org/drawingml/2006/main">
@@ -675,7 +675,7 @@
           </a:p>
           <a:p xmlns:a="http://schemas.openxmlformats.org/drawingml/2006/main">
             <a:r>
-              <a:t>- project-documents/SmartCourse_FYP_Viva_Guide.pdf</a:t>
+              <a:t>- project-documents/FinalDeliverables_F25PROJECTEC4D8/2-FinalReport_SmartCourse_F25PROJECTEC4D8.docx</a:t>
             </a:r>
           </a:p>
         </p:txBody>
@@ -745,7 +745,7 @@
           <a:lstStyle xmlns:a="http://schemas.openxmlformats.org/drawingml/2006/main"/>
           <a:p xmlns:a="http://schemas.openxmlformats.org/drawingml/2006/main">
             <a:r>
-              <a:t>Use these as concise answers. Always describe the current prototype honestly, then connect the limitation to a concrete future improvement.</a:t>
+              <a:t>Explain each design choice in relation to the current prototype, then connect the listed limitations to concrete future improvements.</a:t>
             </a:r>
           </a:p>
           <a:p xmlns:a="http://schemas.openxmlformats.org/drawingml/2006/main">
@@ -850,7 +850,7 @@
           <a:lstStyle xmlns:a="http://schemas.openxmlformats.org/drawingml/2006/main"/>
           <a:p xmlns:a="http://schemas.openxmlformats.org/drawingml/2006/main">
             <a:r>
-              <a:t>Use this slide as the presenter checklist. Keep the demo under control: one query, one saved course, one dashboard view. If a model is slow to load, explain lazy loading and precomputed artifacts.</a:t>
+              <a:t>Demonstrate one query, one saved course, and one dashboard view. The request flow connects browser interaction, API validation, model ranking, persistence, and rendering.</a:t>
             </a:r>
           </a:p>
           <a:p xmlns:a="http://schemas.openxmlformats.org/drawingml/2006/main">
@@ -950,7 +950,7 @@
           <a:lstStyle xmlns:a="http://schemas.openxmlformats.org/drawingml/2006/main"/>
           <a:p xmlns:a="http://schemas.openxmlformats.org/drawingml/2006/main">
             <a:r>
-              <a:t>Close by restating the system in one sentence, then invite questions. If the first question is technical, return to the separation between data preparation, model ranking, API orchestration, and persistence.</a:t>
+              <a:t>Summarize the system through its problem, two ranking methods, application flow, and persistent learner history. Technical discussion can return to data preparation, model ranking, API orchestration, and persistence.</a:t>
             </a:r>
           </a:p>
           <a:p xmlns:a="http://schemas.openxmlformats.org/drawingml/2006/main">
@@ -1838,7 +1838,7 @@
   </p:cSld>
   <p:clrMap bg1="lt1" tx1="dk1" bg2="lt2" tx2="dk2" accent1="accent1" accent2="accent2" accent3="accent3" accent4="accent4" accent5="accent5" accent6="accent6" hlink="hlink" folHlink="folHlink"/>
   <p:sldLayoutIdLst>
-    <p:sldLayoutId xmlns:r="http://schemas.openxmlformats.org/officeDocument/2006/relationships" id="2147483649" r:id="Rbf2ad196675a45f7"/>
+    <p:sldLayoutId xmlns:r="http://schemas.openxmlformats.org/officeDocument/2006/relationships" id="2147483649" r:id="R2320c45f3bf04d17"/>
   </p:sldLayoutIdLst>
   <p:txStyles>
     <p:titleStyle>
@@ -2397,10 +2397,10 @@
       </p:grpSpPr>
       <p:sp>
         <p:nvSpPr>
-          <p:cNvPr id="25" name="">
-            <a:extLst xmlns:a="http://schemas.openxmlformats.org/drawingml/2006/main">
-              <a:ext uri="{FF2B5EF4-FFF2-40B4-BE49-F238E27FC236}">
-                <a16:creationId xmlns:a16="http://schemas.microsoft.com/office/drawing/2014/main" id="{B028C419-87A7-496A-A0BD-41EDE05F1AD9}"/>
+          <p:cNvPr id="24" name="">
+            <a:extLst xmlns:a="http://schemas.openxmlformats.org/drawingml/2006/main">
+              <a:ext uri="{FF2B5EF4-FFF2-40B4-BE49-F238E27FC236}">
+                <a16:creationId xmlns:a16="http://schemas.microsoft.com/office/drawing/2014/main" id="{22C289D2-B865-4E22-B454-7623851CC399}"/>
               </a:ext>
             </a:extLst>
           </p:cNvPr>
@@ -2431,7 +2431,7 @@
           <p:cNvPr id="2" name="">
             <a:extLst xmlns:a="http://schemas.openxmlformats.org/drawingml/2006/main">
               <a:ext uri="{FF2B5EF4-FFF2-40B4-BE49-F238E27FC236}">
-                <a16:creationId xmlns:a16="http://schemas.microsoft.com/office/drawing/2014/main" id="{C6F70A91-7B93-4BC1-ACD2-BA2E000D6421}"/>
+                <a16:creationId xmlns:a16="http://schemas.microsoft.com/office/drawing/2014/main" id="{AEB613C3-9145-4F71-82DD-6C61DCD6F9A2}"/>
               </a:ext>
             </a:extLst>
           </p:cNvPr>
@@ -2489,7 +2489,7 @@
           <p:cNvPr id="3" name="title">
             <a:extLst xmlns:a="http://schemas.openxmlformats.org/drawingml/2006/main">
               <a:ext uri="{FF2B5EF4-FFF2-40B4-BE49-F238E27FC236}">
-                <a16:creationId xmlns:a16="http://schemas.microsoft.com/office/drawing/2014/main" id="{3D140ED8-78B1-4662-8E54-95715ED99AE1}"/>
+                <a16:creationId xmlns:a16="http://schemas.microsoft.com/office/drawing/2014/main" id="{BCDC2602-2822-4FE6-AA77-0DDD780D5B6D}"/>
               </a:ext>
             </a:extLst>
           </p:cNvPr>
@@ -2570,7 +2570,7 @@
           <p:cNvPr id="4" name="">
             <a:extLst xmlns:a="http://schemas.openxmlformats.org/drawingml/2006/main">
               <a:ext uri="{FF2B5EF4-FFF2-40B4-BE49-F238E27FC236}">
-                <a16:creationId xmlns:a16="http://schemas.microsoft.com/office/drawing/2014/main" id="{212F3437-4389-42C1-89E6-BCD66DFF8798}"/>
+                <a16:creationId xmlns:a16="http://schemas.microsoft.com/office/drawing/2014/main" id="{16DA6506-63BD-4C6B-BEA2-77B746EC94D3}"/>
               </a:ext>
             </a:extLst>
           </p:cNvPr>
@@ -2618,7 +2618,7 @@
                 <a:ea typeface="Aptos"/>
                 <a:cs typeface="Aptos"/>
               </a:rPr>
-              <a:t>A viva-ready look at the problem, the models, and the product flow.</a:t>
+              <a:t>Project overview: problem, models, architecture, and product flow.</a:t>
             </a:r>
           </a:p>
         </p:txBody>
@@ -2628,7 +2628,7 @@
           <p:cNvPr id="5" name="">
             <a:extLst xmlns:a="http://schemas.openxmlformats.org/drawingml/2006/main">
               <a:ext uri="{FF2B5EF4-FFF2-40B4-BE49-F238E27FC236}">
-                <a16:creationId xmlns:a16="http://schemas.microsoft.com/office/drawing/2014/main" id="{7DC7A8D4-484C-4BCE-B485-18697BEA3214}"/>
+                <a16:creationId xmlns:a16="http://schemas.microsoft.com/office/drawing/2014/main" id="{F5099B58-C449-4233-93FC-3C0E34E08C71}"/>
               </a:ext>
             </a:extLst>
           </p:cNvPr>
@@ -2659,7 +2659,7 @@
           <p:cNvPr id="6" name="">
             <a:extLst xmlns:a="http://schemas.openxmlformats.org/drawingml/2006/main">
               <a:ext uri="{FF2B5EF4-FFF2-40B4-BE49-F238E27FC236}">
-                <a16:creationId xmlns:a16="http://schemas.microsoft.com/office/drawing/2014/main" id="{00F84004-1867-4EED-9CA2-51A5CC2A1CD4}"/>
+                <a16:creationId xmlns:a16="http://schemas.microsoft.com/office/drawing/2014/main" id="{05A987AF-314F-4149-A3BB-5F3D26519525}"/>
               </a:ext>
             </a:extLst>
           </p:cNvPr>
@@ -2707,7 +2707,7 @@
                 <a:ea typeface="Aptos"/>
                 <a:cs typeface="Aptos"/>
               </a:rPr>
-              <a:t>Final Year Project Viva</a:t>
+              <a:t>Final Year Project</a:t>
             </a:r>
           </a:p>
         </p:txBody>
@@ -2717,99 +2717,18 @@
           <p:cNvPr id="7" name="">
             <a:extLst xmlns:a="http://schemas.openxmlformats.org/drawingml/2006/main">
               <a:ext uri="{FF2B5EF4-FFF2-40B4-BE49-F238E27FC236}">
-                <a16:creationId xmlns:a16="http://schemas.microsoft.com/office/drawing/2014/main" id="{E087A084-EA3A-4AF1-8607-20668C23DAB5}"/>
-              </a:ext>
-            </a:extLst>
-          </p:cNvPr>
-          <p:cNvSpPr>
-            <a:spLocks xmlns:a="http://schemas.openxmlformats.org/drawingml/2006/main" noGrp="1"/>
-          </p:cNvSpPr>
-          <p:nvPr/>
-        </p:nvSpPr>
-        <p:spPr>
-          <a:xfrm xmlns:a="http://schemas.openxmlformats.org/drawingml/2006/main">
-            <a:off x="914400" y="4248150"/>
-            <a:ext cx="4762500" cy="495300"/>
-          </a:xfrm>
-          <a:prstGeom xmlns:a="http://schemas.openxmlformats.org/drawingml/2006/main" prst="rect">
-            <a:avLst/>
-          </a:prstGeom>
-          <a:noFill xmlns:a="http://schemas.openxmlformats.org/drawingml/2006/main"/>
-          <a:ln xmlns:a="http://schemas.openxmlformats.org/drawingml/2006/main" w="0">
-            <a:noFill/>
-            <a:prstDash val="solid"/>
-          </a:ln>
-        </p:spPr>
-        <p:txBody>
-          <a:bodyPr xmlns:a="http://schemas.openxmlformats.org/drawingml/2006/main" wrap="square" lIns="0" tIns="0" rIns="0" bIns="0" anchor="t">
-            <a:normAutofit fontScale="100000"/>
-          </a:bodyPr>
-          <a:lstStyle xmlns:a="http://schemas.openxmlformats.org/drawingml/2006/main"/>
-          <a:p xmlns:a="http://schemas.openxmlformats.org/drawingml/2006/main">
-            <a:pPr algn="l">
-              <a:defRPr sz="1200" b="0">
-                <a:solidFill>
-                  <a:srgbClr val="A7B7C9"/>
-                </a:solidFill>
-                <a:latin typeface="Aptos"/>
-                <a:ea typeface="Aptos"/>
-                <a:cs typeface="Aptos"/>
-              </a:defRPr>
-            </a:pPr>
-            <a:r>
-              <a:rPr sz="1200" b="0">
-                <a:solidFill>
-                  <a:srgbClr val="A7B7C9"/>
-                </a:solidFill>
-                <a:latin typeface="Aptos"/>
-                <a:ea typeface="Aptos"/>
-                <a:cs typeface="Aptos"/>
-              </a:rPr>
-              <a:t>20 August 2026  ·  3:45 PM</a:t>
-            </a:r>
-          </a:p>
-          <a:p xmlns:a="http://schemas.openxmlformats.org/drawingml/2006/main">
-            <a:pPr algn="l">
-              <a:defRPr sz="1200" b="0">
-                <a:solidFill>
-                  <a:srgbClr val="A7B7C9"/>
-                </a:solidFill>
-                <a:latin typeface="Aptos"/>
-                <a:ea typeface="Aptos"/>
-                <a:cs typeface="Aptos"/>
-              </a:defRPr>
-            </a:pPr>
-            <a:r>
-              <a:rPr sz="1200" b="0">
-                <a:solidFill>
-                  <a:srgbClr val="A7B7C9"/>
-                </a:solidFill>
-                <a:latin typeface="Aptos"/>
-                <a:ea typeface="Aptos"/>
-                <a:cs typeface="Aptos"/>
-              </a:rPr>
-              <a:t>Peshawar Institute VU Campus  ·  Board Bazar</a:t>
-            </a:r>
-          </a:p>
-        </p:txBody>
-      </p:sp>
-      <p:sp>
-        <p:nvSpPr>
-          <p:cNvPr id="8" name="">
-            <a:extLst xmlns:a="http://schemas.openxmlformats.org/drawingml/2006/main">
-              <a:ext uri="{FF2B5EF4-FFF2-40B4-BE49-F238E27FC236}">
-                <a16:creationId xmlns:a16="http://schemas.microsoft.com/office/drawing/2014/main" id="{A7C325B0-5653-4FE6-B9E3-20112D645647}"/>
-              </a:ext>
-            </a:extLst>
-          </p:cNvPr>
-          <p:cNvSpPr>
-            <a:spLocks xmlns:a="http://schemas.openxmlformats.org/drawingml/2006/main" noGrp="1"/>
-          </p:cNvSpPr>
-          <p:nvPr/>
-        </p:nvSpPr>
-        <p:spPr>
-          <a:xfrm xmlns:a="http://schemas.openxmlformats.org/drawingml/2006/main">
-            <a:off x="914400" y="5734050"/>
+                <a16:creationId xmlns:a16="http://schemas.microsoft.com/office/drawing/2014/main" id="{53097B55-AC45-40B4-A2A1-B9A05C463A38}"/>
+              </a:ext>
+            </a:extLst>
+          </p:cNvPr>
+          <p:cNvSpPr>
+            <a:spLocks xmlns:a="http://schemas.openxmlformats.org/drawingml/2006/main" noGrp="1"/>
+          </p:cNvSpPr>
+          <p:nvPr/>
+        </p:nvSpPr>
+        <p:spPr>
+          <a:xfrm xmlns:a="http://schemas.openxmlformats.org/drawingml/2006/main">
+            <a:off x="914400" y="4953000"/>
             <a:ext cx="5143500" cy="400050"/>
           </a:xfrm>
           <a:prstGeom xmlns:a="http://schemas.openxmlformats.org/drawingml/2006/main" prst="rect">
@@ -2876,10 +2795,10 @@
       </p:sp>
       <p:sp>
         <p:nvSpPr>
-          <p:cNvPr id="9" name="">
-            <a:extLst xmlns:a="http://schemas.openxmlformats.org/drawingml/2006/main">
-              <a:ext uri="{FF2B5EF4-FFF2-40B4-BE49-F238E27FC236}">
-                <a16:creationId xmlns:a16="http://schemas.microsoft.com/office/drawing/2014/main" id="{97BEEBEF-4CBF-46E6-B93F-22BED7D2D851}"/>
+          <p:cNvPr id="8" name="">
+            <a:extLst xmlns:a="http://schemas.openxmlformats.org/drawingml/2006/main">
+              <a:ext uri="{FF2B5EF4-FFF2-40B4-BE49-F238E27FC236}">
+                <a16:creationId xmlns:a16="http://schemas.microsoft.com/office/drawing/2014/main" id="{FCD9E239-E270-42EB-ACCF-9B15BD382138}"/>
               </a:ext>
             </a:extLst>
           </p:cNvPr>
@@ -2907,10 +2826,10 @@
       </p:sp>
       <p:sp>
         <p:nvSpPr>
-          <p:cNvPr id="10" name="">
-            <a:extLst xmlns:a="http://schemas.openxmlformats.org/drawingml/2006/main">
-              <a:ext uri="{FF2B5EF4-FFF2-40B4-BE49-F238E27FC236}">
-                <a16:creationId xmlns:a16="http://schemas.microsoft.com/office/drawing/2014/main" id="{5954F456-9DE7-44E3-9A16-8B3B181CED40}"/>
+          <p:cNvPr id="9" name="">
+            <a:extLst xmlns:a="http://schemas.openxmlformats.org/drawingml/2006/main">
+              <a:ext uri="{FF2B5EF4-FFF2-40B4-BE49-F238E27FC236}">
+                <a16:creationId xmlns:a16="http://schemas.microsoft.com/office/drawing/2014/main" id="{A63021CD-6F8F-404F-B3CB-DC2CC63C7E90}"/>
               </a:ext>
             </a:extLst>
           </p:cNvPr>
@@ -2938,10 +2857,10 @@
       </p:sp>
       <p:sp>
         <p:nvSpPr>
-          <p:cNvPr id="11" name="">
-            <a:extLst xmlns:a="http://schemas.openxmlformats.org/drawingml/2006/main">
-              <a:ext uri="{FF2B5EF4-FFF2-40B4-BE49-F238E27FC236}">
-                <a16:creationId xmlns:a16="http://schemas.microsoft.com/office/drawing/2014/main" id="{35ADEB98-D6F9-489C-8D33-FAC723071D09}"/>
+          <p:cNvPr id="10" name="">
+            <a:extLst xmlns:a="http://schemas.openxmlformats.org/drawingml/2006/main">
+              <a:ext uri="{FF2B5EF4-FFF2-40B4-BE49-F238E27FC236}">
+                <a16:creationId xmlns:a16="http://schemas.microsoft.com/office/drawing/2014/main" id="{6BB954CC-42D4-47D8-B2B0-4BA6798E42E1}"/>
               </a:ext>
             </a:extLst>
           </p:cNvPr>
@@ -2969,10 +2888,10 @@
       </p:sp>
       <p:sp>
         <p:nvSpPr>
-          <p:cNvPr id="12" name="">
-            <a:extLst xmlns:a="http://schemas.openxmlformats.org/drawingml/2006/main">
-              <a:ext uri="{FF2B5EF4-FFF2-40B4-BE49-F238E27FC236}">
-                <a16:creationId xmlns:a16="http://schemas.microsoft.com/office/drawing/2014/main" id="{EA58F54C-0CEA-4D68-8480-95239D6AD9DE}"/>
+          <p:cNvPr id="11" name="">
+            <a:extLst xmlns:a="http://schemas.openxmlformats.org/drawingml/2006/main">
+              <a:ext uri="{FF2B5EF4-FFF2-40B4-BE49-F238E27FC236}">
+                <a16:creationId xmlns:a16="http://schemas.microsoft.com/office/drawing/2014/main" id="{363102B6-6F40-4C96-8A6E-63F86CA8BAD7}"/>
               </a:ext>
             </a:extLst>
           </p:cNvPr>
@@ -3000,10 +2919,10 @@
       </p:sp>
       <p:sp>
         <p:nvSpPr>
-          <p:cNvPr id="13" name="">
-            <a:extLst xmlns:a="http://schemas.openxmlformats.org/drawingml/2006/main">
-              <a:ext uri="{FF2B5EF4-FFF2-40B4-BE49-F238E27FC236}">
-                <a16:creationId xmlns:a16="http://schemas.microsoft.com/office/drawing/2014/main" id="{B0C13FF1-1467-4CB0-BE2B-A1733ABB381F}"/>
+          <p:cNvPr id="12" name="">
+            <a:extLst xmlns:a="http://schemas.openxmlformats.org/drawingml/2006/main">
+              <a:ext uri="{FF2B5EF4-FFF2-40B4-BE49-F238E27FC236}">
+                <a16:creationId xmlns:a16="http://schemas.microsoft.com/office/drawing/2014/main" id="{8AB3EC1C-7D66-42BD-9061-166EDD3926A9}"/>
               </a:ext>
             </a:extLst>
           </p:cNvPr>
@@ -3039,10 +2958,10 @@
       </p:sp>
       <p:sp>
         <p:nvSpPr>
-          <p:cNvPr id="14" name="">
-            <a:extLst xmlns:a="http://schemas.openxmlformats.org/drawingml/2006/main">
-              <a:ext uri="{FF2B5EF4-FFF2-40B4-BE49-F238E27FC236}">
-                <a16:creationId xmlns:a16="http://schemas.microsoft.com/office/drawing/2014/main" id="{83E5ABA4-01BC-47D3-8075-F8075F65AD59}"/>
+          <p:cNvPr id="13" name="">
+            <a:extLst xmlns:a="http://schemas.openxmlformats.org/drawingml/2006/main">
+              <a:ext uri="{FF2B5EF4-FFF2-40B4-BE49-F238E27FC236}">
+                <a16:creationId xmlns:a16="http://schemas.microsoft.com/office/drawing/2014/main" id="{D30F38BF-FB3E-408C-9234-5898543D2C0B}"/>
               </a:ext>
             </a:extLst>
           </p:cNvPr>
@@ -3097,10 +3016,10 @@
       </p:sp>
       <p:sp>
         <p:nvSpPr>
-          <p:cNvPr id="15" name="">
-            <a:extLst xmlns:a="http://schemas.openxmlformats.org/drawingml/2006/main">
-              <a:ext uri="{FF2B5EF4-FFF2-40B4-BE49-F238E27FC236}">
-                <a16:creationId xmlns:a16="http://schemas.microsoft.com/office/drawing/2014/main" id="{FF6E1CFB-C898-4BB3-80C7-6C9114597B8C}"/>
+          <p:cNvPr id="14" name="">
+            <a:extLst xmlns:a="http://schemas.openxmlformats.org/drawingml/2006/main">
+              <a:ext uri="{FF2B5EF4-FFF2-40B4-BE49-F238E27FC236}">
+                <a16:creationId xmlns:a16="http://schemas.microsoft.com/office/drawing/2014/main" id="{9EA83D8E-B0B2-491B-A2CA-5C67FEC7F383}"/>
               </a:ext>
             </a:extLst>
           </p:cNvPr>
@@ -3132,10 +3051,10 @@
       </p:sp>
       <p:sp>
         <p:nvSpPr>
-          <p:cNvPr id="16" name="">
-            <a:extLst xmlns:a="http://schemas.openxmlformats.org/drawingml/2006/main">
-              <a:ext uri="{FF2B5EF4-FFF2-40B4-BE49-F238E27FC236}">
-                <a16:creationId xmlns:a16="http://schemas.microsoft.com/office/drawing/2014/main" id="{89AE595F-882F-46A6-9D86-E6384B01BAC2}"/>
+          <p:cNvPr id="15" name="">
+            <a:extLst xmlns:a="http://schemas.openxmlformats.org/drawingml/2006/main">
+              <a:ext uri="{FF2B5EF4-FFF2-40B4-BE49-F238E27FC236}">
+                <a16:creationId xmlns:a16="http://schemas.microsoft.com/office/drawing/2014/main" id="{D941713E-D2B9-48BF-A681-30A93A0AE7AB}"/>
               </a:ext>
             </a:extLst>
           </p:cNvPr>
@@ -3190,10 +3109,10 @@
       </p:sp>
       <p:sp>
         <p:nvSpPr>
-          <p:cNvPr id="17" name="">
-            <a:extLst xmlns:a="http://schemas.openxmlformats.org/drawingml/2006/main">
-              <a:ext uri="{FF2B5EF4-FFF2-40B4-BE49-F238E27FC236}">
-                <a16:creationId xmlns:a16="http://schemas.microsoft.com/office/drawing/2014/main" id="{B15DD51D-96F1-4BCF-86A3-70219ECF65D5}"/>
+          <p:cNvPr id="16" name="">
+            <a:extLst xmlns:a="http://schemas.openxmlformats.org/drawingml/2006/main">
+              <a:ext uri="{FF2B5EF4-FFF2-40B4-BE49-F238E27FC236}">
+                <a16:creationId xmlns:a16="http://schemas.microsoft.com/office/drawing/2014/main" id="{A7127836-93CD-4292-9E51-D23D867C4478}"/>
               </a:ext>
             </a:extLst>
           </p:cNvPr>
@@ -3248,10 +3167,10 @@
       </p:sp>
       <p:sp>
         <p:nvSpPr>
-          <p:cNvPr id="18" name="">
-            <a:extLst xmlns:a="http://schemas.openxmlformats.org/drawingml/2006/main">
-              <a:ext uri="{FF2B5EF4-FFF2-40B4-BE49-F238E27FC236}">
-                <a16:creationId xmlns:a16="http://schemas.microsoft.com/office/drawing/2014/main" id="{C2F0116C-38B6-457E-B0D7-8410ABA52CF1}"/>
+          <p:cNvPr id="17" name="">
+            <a:extLst xmlns:a="http://schemas.openxmlformats.org/drawingml/2006/main">
+              <a:ext uri="{FF2B5EF4-FFF2-40B4-BE49-F238E27FC236}">
+                <a16:creationId xmlns:a16="http://schemas.microsoft.com/office/drawing/2014/main" id="{3BF13BF0-7375-4C5A-998F-8C3FDB9B36C8}"/>
               </a:ext>
             </a:extLst>
           </p:cNvPr>
@@ -3283,10 +3202,10 @@
       </p:sp>
       <p:sp>
         <p:nvSpPr>
-          <p:cNvPr id="19" name="">
-            <a:extLst xmlns:a="http://schemas.openxmlformats.org/drawingml/2006/main">
-              <a:ext uri="{FF2B5EF4-FFF2-40B4-BE49-F238E27FC236}">
-                <a16:creationId xmlns:a16="http://schemas.microsoft.com/office/drawing/2014/main" id="{9AAFCB7E-D128-4E41-8542-7EBD43F1D1F5}"/>
+          <p:cNvPr id="18" name="">
+            <a:extLst xmlns:a="http://schemas.openxmlformats.org/drawingml/2006/main">
+              <a:ext uri="{FF2B5EF4-FFF2-40B4-BE49-F238E27FC236}">
+                <a16:creationId xmlns:a16="http://schemas.microsoft.com/office/drawing/2014/main" id="{7A46D558-07BE-4D88-AC42-F5BFE3316B9F}"/>
               </a:ext>
             </a:extLst>
           </p:cNvPr>
@@ -3341,10 +3260,10 @@
       </p:sp>
       <p:sp>
         <p:nvSpPr>
-          <p:cNvPr id="20" name="">
-            <a:extLst xmlns:a="http://schemas.openxmlformats.org/drawingml/2006/main">
-              <a:ext uri="{FF2B5EF4-FFF2-40B4-BE49-F238E27FC236}">
-                <a16:creationId xmlns:a16="http://schemas.microsoft.com/office/drawing/2014/main" id="{55485DEC-D7F3-4B60-B417-523F2BBAD4A4}"/>
+          <p:cNvPr id="19" name="">
+            <a:extLst xmlns:a="http://schemas.openxmlformats.org/drawingml/2006/main">
+              <a:ext uri="{FF2B5EF4-FFF2-40B4-BE49-F238E27FC236}">
+                <a16:creationId xmlns:a16="http://schemas.microsoft.com/office/drawing/2014/main" id="{0A9D3A74-AD54-49B6-A598-86E3F7190D50}"/>
               </a:ext>
             </a:extLst>
           </p:cNvPr>
@@ -3399,10 +3318,10 @@
       </p:sp>
       <p:sp>
         <p:nvSpPr>
-          <p:cNvPr id="21" name="">
-            <a:extLst xmlns:a="http://schemas.openxmlformats.org/drawingml/2006/main">
-              <a:ext uri="{FF2B5EF4-FFF2-40B4-BE49-F238E27FC236}">
-                <a16:creationId xmlns:a16="http://schemas.microsoft.com/office/drawing/2014/main" id="{D891674B-4C1C-4B3A-B771-1B5D5B33A1F6}"/>
+          <p:cNvPr id="20" name="">
+            <a:extLst xmlns:a="http://schemas.openxmlformats.org/drawingml/2006/main">
+              <a:ext uri="{FF2B5EF4-FFF2-40B4-BE49-F238E27FC236}">
+                <a16:creationId xmlns:a16="http://schemas.microsoft.com/office/drawing/2014/main" id="{9D2E113D-4EFB-458C-A641-79F4468FB539}"/>
               </a:ext>
             </a:extLst>
           </p:cNvPr>
@@ -3432,10 +3351,10 @@
       </p:sp>
       <p:sp>
         <p:nvSpPr>
-          <p:cNvPr id="22" name="">
-            <a:extLst xmlns:a="http://schemas.openxmlformats.org/drawingml/2006/main">
-              <a:ext uri="{FF2B5EF4-FFF2-40B4-BE49-F238E27FC236}">
-                <a16:creationId xmlns:a16="http://schemas.microsoft.com/office/drawing/2014/main" id="{E030169C-29A6-4258-B635-43B23704F997}"/>
+          <p:cNvPr id="21" name="">
+            <a:extLst xmlns:a="http://schemas.openxmlformats.org/drawingml/2006/main">
+              <a:ext uri="{FF2B5EF4-FFF2-40B4-BE49-F238E27FC236}">
+                <a16:creationId xmlns:a16="http://schemas.microsoft.com/office/drawing/2014/main" id="{41975C93-DFCF-4AB9-8DD7-A24FA77C8442}"/>
               </a:ext>
             </a:extLst>
           </p:cNvPr>
@@ -3490,10 +3409,10 @@
       </p:sp>
       <p:sp>
         <p:nvSpPr>
-          <p:cNvPr id="23" name="">
-            <a:extLst xmlns:a="http://schemas.openxmlformats.org/drawingml/2006/main">
-              <a:ext uri="{FF2B5EF4-FFF2-40B4-BE49-F238E27FC236}">
-                <a16:creationId xmlns:a16="http://schemas.microsoft.com/office/drawing/2014/main" id="{985BA4AE-9108-4974-B449-66E665FD031E}"/>
+          <p:cNvPr id="22" name="">
+            <a:extLst xmlns:a="http://schemas.openxmlformats.org/drawingml/2006/main">
+              <a:ext uri="{FF2B5EF4-FFF2-40B4-BE49-F238E27FC236}">
+                <a16:creationId xmlns:a16="http://schemas.microsoft.com/office/drawing/2014/main" id="{C18B0092-62D1-4011-AF61-9EBE29AFA805}"/>
               </a:ext>
             </a:extLst>
           </p:cNvPr>
@@ -3541,17 +3460,17 @@
                 <a:ea typeface="Aptos"/>
                 <a:cs typeface="Aptos"/>
               </a:rPr>
-              <a:t>SMARTCOURSE  /  FYP VIVA</a:t>
-            </a:r>
-          </a:p>
-        </p:txBody>
-      </p:sp>
-      <p:sp>
-        <p:nvSpPr>
-          <p:cNvPr id="24" name="">
-            <a:extLst xmlns:a="http://schemas.openxmlformats.org/drawingml/2006/main">
-              <a:ext uri="{FF2B5EF4-FFF2-40B4-BE49-F238E27FC236}">
-                <a16:creationId xmlns:a16="http://schemas.microsoft.com/office/drawing/2014/main" id="{55D463C0-5E16-462D-9823-DA60BF217250}"/>
+              <a:t>SMARTCOURSE  /  PROJECT</a:t>
+            </a:r>
+          </a:p>
+        </p:txBody>
+      </p:sp>
+      <p:sp>
+        <p:nvSpPr>
+          <p:cNvPr id="23" name="">
+            <a:extLst xmlns:a="http://schemas.openxmlformats.org/drawingml/2006/main">
+              <a:ext uri="{FF2B5EF4-FFF2-40B4-BE49-F238E27FC236}">
+                <a16:creationId xmlns:a16="http://schemas.microsoft.com/office/drawing/2014/main" id="{CC797448-C77D-4C09-B46B-17F43E89D8F6}"/>
               </a:ext>
             </a:extLst>
           </p:cNvPr>
@@ -3607,7 +3526,7 @@
     </p:spTree>
     <p:extLst>
       <p:ext uri="{BB962C8B-B14F-4D97-AF65-F5344CB8AC3E}">
-        <p14:creationId xmlns:p14="http://schemas.microsoft.com/office/powerpoint/2010/main" val="1535595618"/>
+        <p14:creationId xmlns:p14="http://schemas.microsoft.com/office/powerpoint/2010/main" val="210941862"/>
       </p:ext>
     </p:extLst>
   </p:cSld>
@@ -3638,7 +3557,7 @@
           <p:cNvPr id="24" name="kicker">
             <a:extLst xmlns:a="http://schemas.openxmlformats.org/drawingml/2006/main">
               <a:ext uri="{FF2B5EF4-FFF2-40B4-BE49-F238E27FC236}">
-                <a16:creationId xmlns:a16="http://schemas.microsoft.com/office/drawing/2014/main" id="{52E5F2AF-F9CD-48DA-A725-E326F98FD50D}"/>
+                <a16:creationId xmlns:a16="http://schemas.microsoft.com/office/drawing/2014/main" id="{E71287A2-7D7A-4C81-AA4D-5004230A63FA}"/>
               </a:ext>
             </a:extLst>
           </p:cNvPr>
@@ -3696,7 +3615,7 @@
           <p:cNvPr id="2" name="title">
             <a:extLst xmlns:a="http://schemas.openxmlformats.org/drawingml/2006/main">
               <a:ext uri="{FF2B5EF4-FFF2-40B4-BE49-F238E27FC236}">
-                <a16:creationId xmlns:a16="http://schemas.microsoft.com/office/drawing/2014/main" id="{F5EBCFA3-B9D4-4400-999A-7A63E39BD1F7}"/>
+                <a16:creationId xmlns:a16="http://schemas.microsoft.com/office/drawing/2014/main" id="{D5CEF6C0-89B7-449D-B397-AAA794FB05BB}"/>
               </a:ext>
             </a:extLst>
           </p:cNvPr>
@@ -3754,7 +3673,7 @@
           <p:cNvPr id="3" name="subtitle">
             <a:extLst xmlns:a="http://schemas.openxmlformats.org/drawingml/2006/main">
               <a:ext uri="{FF2B5EF4-FFF2-40B4-BE49-F238E27FC236}">
-                <a16:creationId xmlns:a16="http://schemas.microsoft.com/office/drawing/2014/main" id="{5095C3BF-9211-426D-8380-2218182C8413}"/>
+                <a16:creationId xmlns:a16="http://schemas.microsoft.com/office/drawing/2014/main" id="{7E73C16C-3348-4B72-84FD-FD1394B16D6C}"/>
               </a:ext>
             </a:extLst>
           </p:cNvPr>
@@ -3812,7 +3731,7 @@
           <p:cNvPr id="4" name="">
             <a:extLst xmlns:a="http://schemas.openxmlformats.org/drawingml/2006/main">
               <a:ext uri="{FF2B5EF4-FFF2-40B4-BE49-F238E27FC236}">
-                <a16:creationId xmlns:a16="http://schemas.microsoft.com/office/drawing/2014/main" id="{2B4FFEE7-6AFB-4052-B3DF-2EB0820E3FA4}"/>
+                <a16:creationId xmlns:a16="http://schemas.microsoft.com/office/drawing/2014/main" id="{867A55FD-22AD-494A-8D3D-99A4E85EF2BA}"/>
               </a:ext>
             </a:extLst>
           </p:cNvPr>
@@ -3843,7 +3762,7 @@
           <p:cNvPr id="5" name="">
             <a:extLst xmlns:a="http://schemas.openxmlformats.org/drawingml/2006/main">
               <a:ext uri="{FF2B5EF4-FFF2-40B4-BE49-F238E27FC236}">
-                <a16:creationId xmlns:a16="http://schemas.microsoft.com/office/drawing/2014/main" id="{17D33214-6757-4180-A35C-F58CFA4F35FE}"/>
+                <a16:creationId xmlns:a16="http://schemas.microsoft.com/office/drawing/2014/main" id="{8826F620-3316-4674-9C1E-29AE70B533D2}"/>
               </a:ext>
             </a:extLst>
           </p:cNvPr>
@@ -3874,7 +3793,7 @@
           <p:cNvPr id="6" name="">
             <a:extLst xmlns:a="http://schemas.openxmlformats.org/drawingml/2006/main">
               <a:ext uri="{FF2B5EF4-FFF2-40B4-BE49-F238E27FC236}">
-                <a16:creationId xmlns:a16="http://schemas.microsoft.com/office/drawing/2014/main" id="{CE547824-9679-401C-8365-198A2914273B}"/>
+                <a16:creationId xmlns:a16="http://schemas.microsoft.com/office/drawing/2014/main" id="{BC81C11C-D7BE-4651-8AF1-1FF9CB02A091}"/>
               </a:ext>
             </a:extLst>
           </p:cNvPr>
@@ -3934,7 +3853,7 @@
           <p:cNvPr id="7" name="">
             <a:extLst xmlns:a="http://schemas.openxmlformats.org/drawingml/2006/main">
               <a:ext uri="{FF2B5EF4-FFF2-40B4-BE49-F238E27FC236}">
-                <a16:creationId xmlns:a16="http://schemas.microsoft.com/office/drawing/2014/main" id="{BCE2536A-0445-4172-8395-74CC19A03C66}"/>
+                <a16:creationId xmlns:a16="http://schemas.microsoft.com/office/drawing/2014/main" id="{195BDA47-609A-434E-9483-C2C7292A5C49}"/>
               </a:ext>
             </a:extLst>
           </p:cNvPr>
@@ -3992,7 +3911,7 @@
           <p:cNvPr id="8" name="">
             <a:extLst xmlns:a="http://schemas.openxmlformats.org/drawingml/2006/main">
               <a:ext uri="{FF2B5EF4-FFF2-40B4-BE49-F238E27FC236}">
-                <a16:creationId xmlns:a16="http://schemas.microsoft.com/office/drawing/2014/main" id="{4A1AE798-0224-4964-86F3-BDF2523AB9DF}"/>
+                <a16:creationId xmlns:a16="http://schemas.microsoft.com/office/drawing/2014/main" id="{3026B891-B853-41EE-9BC6-0BD93346F700}"/>
               </a:ext>
             </a:extLst>
           </p:cNvPr>
@@ -4050,7 +3969,7 @@
           <p:cNvPr id="9" name="">
             <a:extLst xmlns:a="http://schemas.openxmlformats.org/drawingml/2006/main">
               <a:ext uri="{FF2B5EF4-FFF2-40B4-BE49-F238E27FC236}">
-                <a16:creationId xmlns:a16="http://schemas.microsoft.com/office/drawing/2014/main" id="{3B554171-02D9-436B-9931-C0EEE085F46C}"/>
+                <a16:creationId xmlns:a16="http://schemas.microsoft.com/office/drawing/2014/main" id="{A2773374-ABAC-4DDE-BDB6-86707CC30203}"/>
               </a:ext>
             </a:extLst>
           </p:cNvPr>
@@ -4110,7 +4029,7 @@
           <p:cNvPr id="10" name="">
             <a:extLst xmlns:a="http://schemas.openxmlformats.org/drawingml/2006/main">
               <a:ext uri="{FF2B5EF4-FFF2-40B4-BE49-F238E27FC236}">
-                <a16:creationId xmlns:a16="http://schemas.microsoft.com/office/drawing/2014/main" id="{8E4A9F55-97F6-451E-92B0-6A946D5F6B73}"/>
+                <a16:creationId xmlns:a16="http://schemas.microsoft.com/office/drawing/2014/main" id="{D8BF3876-002A-42AE-9275-4336D3FDC370}"/>
               </a:ext>
             </a:extLst>
           </p:cNvPr>
@@ -4168,7 +4087,7 @@
           <p:cNvPr id="11" name="">
             <a:extLst xmlns:a="http://schemas.openxmlformats.org/drawingml/2006/main">
               <a:ext uri="{FF2B5EF4-FFF2-40B4-BE49-F238E27FC236}">
-                <a16:creationId xmlns:a16="http://schemas.microsoft.com/office/drawing/2014/main" id="{8B4C6101-6B94-4218-BB06-63B1C6795A31}"/>
+                <a16:creationId xmlns:a16="http://schemas.microsoft.com/office/drawing/2014/main" id="{5F8D0116-871D-4046-8127-B20CC858E0F4}"/>
               </a:ext>
             </a:extLst>
           </p:cNvPr>
@@ -4226,7 +4145,7 @@
           <p:cNvPr id="12" name="">
             <a:extLst xmlns:a="http://schemas.openxmlformats.org/drawingml/2006/main">
               <a:ext uri="{FF2B5EF4-FFF2-40B4-BE49-F238E27FC236}">
-                <a16:creationId xmlns:a16="http://schemas.microsoft.com/office/drawing/2014/main" id="{39F68F9C-9B0C-42CC-8A9F-DBFC6BF29C05}"/>
+                <a16:creationId xmlns:a16="http://schemas.microsoft.com/office/drawing/2014/main" id="{FB428AF5-B68A-4D29-9EF7-5D2A15FF0972}"/>
               </a:ext>
             </a:extLst>
           </p:cNvPr>
@@ -4286,7 +4205,7 @@
           <p:cNvPr id="13" name="">
             <a:extLst xmlns:a="http://schemas.openxmlformats.org/drawingml/2006/main">
               <a:ext uri="{FF2B5EF4-FFF2-40B4-BE49-F238E27FC236}">
-                <a16:creationId xmlns:a16="http://schemas.microsoft.com/office/drawing/2014/main" id="{B3E5F76D-6283-4360-A456-4BD6BEFB01FB}"/>
+                <a16:creationId xmlns:a16="http://schemas.microsoft.com/office/drawing/2014/main" id="{6E6768D5-8366-49A7-9D06-C4A41EF58D4F}"/>
               </a:ext>
             </a:extLst>
           </p:cNvPr>
@@ -4344,7 +4263,7 @@
           <p:cNvPr id="14" name="">
             <a:extLst xmlns:a="http://schemas.openxmlformats.org/drawingml/2006/main">
               <a:ext uri="{FF2B5EF4-FFF2-40B4-BE49-F238E27FC236}">
-                <a16:creationId xmlns:a16="http://schemas.microsoft.com/office/drawing/2014/main" id="{0633338E-1CA3-4FFA-A75D-C7FCB5075D88}"/>
+                <a16:creationId xmlns:a16="http://schemas.microsoft.com/office/drawing/2014/main" id="{99919048-6CC4-4BAF-BA3C-6A285C35AE90}"/>
               </a:ext>
             </a:extLst>
           </p:cNvPr>
@@ -4402,7 +4321,7 @@
           <p:cNvPr id="15" name="">
             <a:extLst xmlns:a="http://schemas.openxmlformats.org/drawingml/2006/main">
               <a:ext uri="{FF2B5EF4-FFF2-40B4-BE49-F238E27FC236}">
-                <a16:creationId xmlns:a16="http://schemas.microsoft.com/office/drawing/2014/main" id="{14770530-42EF-4C5F-B0F9-CC0C3123A2D5}"/>
+                <a16:creationId xmlns:a16="http://schemas.microsoft.com/office/drawing/2014/main" id="{622BD3C9-4F6B-444A-8905-057EE9BFCBFC}"/>
               </a:ext>
             </a:extLst>
           </p:cNvPr>
@@ -4462,7 +4381,7 @@
           <p:cNvPr id="16" name="">
             <a:extLst xmlns:a="http://schemas.openxmlformats.org/drawingml/2006/main">
               <a:ext uri="{FF2B5EF4-FFF2-40B4-BE49-F238E27FC236}">
-                <a16:creationId xmlns:a16="http://schemas.microsoft.com/office/drawing/2014/main" id="{A5B358EF-B67F-42D5-BD25-A7E6C11B1E63}"/>
+                <a16:creationId xmlns:a16="http://schemas.microsoft.com/office/drawing/2014/main" id="{C8FC42E3-01D0-4072-B6B1-74DE8C2D7F8A}"/>
               </a:ext>
             </a:extLst>
           </p:cNvPr>
@@ -4520,7 +4439,7 @@
           <p:cNvPr id="17" name="">
             <a:extLst xmlns:a="http://schemas.openxmlformats.org/drawingml/2006/main">
               <a:ext uri="{FF2B5EF4-FFF2-40B4-BE49-F238E27FC236}">
-                <a16:creationId xmlns:a16="http://schemas.microsoft.com/office/drawing/2014/main" id="{98A86BF3-6DCD-450E-9F98-CB4788A06841}"/>
+                <a16:creationId xmlns:a16="http://schemas.microsoft.com/office/drawing/2014/main" id="{02AC62C2-622C-4A06-A520-37349397AC02}"/>
               </a:ext>
             </a:extLst>
           </p:cNvPr>
@@ -4578,7 +4497,7 @@
           <p:cNvPr id="18" name="">
             <a:extLst xmlns:a="http://schemas.openxmlformats.org/drawingml/2006/main">
               <a:ext uri="{FF2B5EF4-FFF2-40B4-BE49-F238E27FC236}">
-                <a16:creationId xmlns:a16="http://schemas.microsoft.com/office/drawing/2014/main" id="{A5B79B5F-061D-4186-812D-EBDC15087EC1}"/>
+                <a16:creationId xmlns:a16="http://schemas.microsoft.com/office/drawing/2014/main" id="{BC14A6D2-C8CD-414B-AB58-9C7505D124D7}"/>
               </a:ext>
             </a:extLst>
           </p:cNvPr>
@@ -4613,7 +4532,7 @@
           <p:cNvPr id="19" name="">
             <a:extLst xmlns:a="http://schemas.openxmlformats.org/drawingml/2006/main">
               <a:ext uri="{FF2B5EF4-FFF2-40B4-BE49-F238E27FC236}">
-                <a16:creationId xmlns:a16="http://schemas.microsoft.com/office/drawing/2014/main" id="{47B96C7E-5ECA-446A-B274-65CC4F495CDA}"/>
+                <a16:creationId xmlns:a16="http://schemas.microsoft.com/office/drawing/2014/main" id="{988DC987-1792-44B8-BC21-D753B911B66F}"/>
               </a:ext>
             </a:extLst>
           </p:cNvPr>
@@ -4671,7 +4590,7 @@
           <p:cNvPr id="20" name="">
             <a:extLst xmlns:a="http://schemas.openxmlformats.org/drawingml/2006/main">
               <a:ext uri="{FF2B5EF4-FFF2-40B4-BE49-F238E27FC236}">
-                <a16:creationId xmlns:a16="http://schemas.microsoft.com/office/drawing/2014/main" id="{6CF74DE2-2684-4C2B-BBC1-CBF080D79BFC}"/>
+                <a16:creationId xmlns:a16="http://schemas.microsoft.com/office/drawing/2014/main" id="{5617EF6B-6F5B-478E-BA46-9B002D94AF06}"/>
               </a:ext>
             </a:extLst>
           </p:cNvPr>
@@ -4729,7 +4648,7 @@
           <p:cNvPr id="21" name="">
             <a:extLst xmlns:a="http://schemas.openxmlformats.org/drawingml/2006/main">
               <a:ext uri="{FF2B5EF4-FFF2-40B4-BE49-F238E27FC236}">
-                <a16:creationId xmlns:a16="http://schemas.microsoft.com/office/drawing/2014/main" id="{FD5C9028-813B-492E-8041-0C5DADBD8DD5}"/>
+                <a16:creationId xmlns:a16="http://schemas.microsoft.com/office/drawing/2014/main" id="{0816361F-CA8F-4B5D-BAAE-381FDF6BE126}"/>
               </a:ext>
             </a:extLst>
           </p:cNvPr>
@@ -4787,7 +4706,7 @@
           <p:cNvPr id="22" name="">
             <a:extLst xmlns:a="http://schemas.openxmlformats.org/drawingml/2006/main">
               <a:ext uri="{FF2B5EF4-FFF2-40B4-BE49-F238E27FC236}">
-                <a16:creationId xmlns:a16="http://schemas.microsoft.com/office/drawing/2014/main" id="{951B424E-B81B-4641-AF8E-0D8CE773330C}"/>
+                <a16:creationId xmlns:a16="http://schemas.microsoft.com/office/drawing/2014/main" id="{00CD7A27-1E1B-49B6-8B1B-7859F50160B4}"/>
               </a:ext>
             </a:extLst>
           </p:cNvPr>
@@ -4835,7 +4754,7 @@
                 <a:ea typeface="Aptos"/>
                 <a:cs typeface="Aptos"/>
               </a:rPr>
-              <a:t>SMARTCOURSE  /  FYP VIVA</a:t>
+              <a:t>SMARTCOURSE  /  PROJECT</a:t>
             </a:r>
           </a:p>
         </p:txBody>
@@ -4845,7 +4764,7 @@
           <p:cNvPr id="23" name="">
             <a:extLst xmlns:a="http://schemas.openxmlformats.org/drawingml/2006/main">
               <a:ext uri="{FF2B5EF4-FFF2-40B4-BE49-F238E27FC236}">
-                <a16:creationId xmlns:a16="http://schemas.microsoft.com/office/drawing/2014/main" id="{CF3D028A-5457-4EE9-A771-B05F9F401921}"/>
+                <a16:creationId xmlns:a16="http://schemas.microsoft.com/office/drawing/2014/main" id="{787603B3-C1FB-4111-969A-3644AC25AB01}"/>
               </a:ext>
             </a:extLst>
           </p:cNvPr>
@@ -4901,7 +4820,7 @@
     </p:spTree>
     <p:extLst>
       <p:ext uri="{BB962C8B-B14F-4D97-AF65-F5344CB8AC3E}">
-        <p14:creationId xmlns:p14="http://schemas.microsoft.com/office/powerpoint/2010/main" val="805209909"/>
+        <p14:creationId xmlns:p14="http://schemas.microsoft.com/office/powerpoint/2010/main" val="17570625"/>
       </p:ext>
     </p:extLst>
   </p:cSld>
@@ -4932,7 +4851,7 @@
           <p:cNvPr id="31" name="kicker">
             <a:extLst xmlns:a="http://schemas.openxmlformats.org/drawingml/2006/main">
               <a:ext uri="{FF2B5EF4-FFF2-40B4-BE49-F238E27FC236}">
-                <a16:creationId xmlns:a16="http://schemas.microsoft.com/office/drawing/2014/main" id="{F14E11C3-A826-4073-96AA-055BFF15ADA2}"/>
+                <a16:creationId xmlns:a16="http://schemas.microsoft.com/office/drawing/2014/main" id="{69C8EC7F-472E-4DEE-92B2-9B3DACD9951F}"/>
               </a:ext>
             </a:extLst>
           </p:cNvPr>
@@ -4990,7 +4909,7 @@
           <p:cNvPr id="2" name="title">
             <a:extLst xmlns:a="http://schemas.openxmlformats.org/drawingml/2006/main">
               <a:ext uri="{FF2B5EF4-FFF2-40B4-BE49-F238E27FC236}">
-                <a16:creationId xmlns:a16="http://schemas.microsoft.com/office/drawing/2014/main" id="{F1AEF699-C7C5-4C74-90D1-E435D7040D65}"/>
+                <a16:creationId xmlns:a16="http://schemas.microsoft.com/office/drawing/2014/main" id="{9DE0FFFF-BDBE-4D3E-8635-DD632E02E03A}"/>
               </a:ext>
             </a:extLst>
           </p:cNvPr>
@@ -5048,7 +4967,7 @@
           <p:cNvPr id="3" name="subtitle">
             <a:extLst xmlns:a="http://schemas.openxmlformats.org/drawingml/2006/main">
               <a:ext uri="{FF2B5EF4-FFF2-40B4-BE49-F238E27FC236}">
-                <a16:creationId xmlns:a16="http://schemas.microsoft.com/office/drawing/2014/main" id="{8489E9FF-7BBA-4EC9-A231-FA648BD0EAEB}"/>
+                <a16:creationId xmlns:a16="http://schemas.microsoft.com/office/drawing/2014/main" id="{4C4F6664-8347-4FEF-B1BD-F926F93537BA}"/>
               </a:ext>
             </a:extLst>
           </p:cNvPr>
@@ -5106,7 +5025,7 @@
           <p:cNvPr id="4" name="">
             <a:extLst xmlns:a="http://schemas.openxmlformats.org/drawingml/2006/main">
               <a:ext uri="{FF2B5EF4-FFF2-40B4-BE49-F238E27FC236}">
-                <a16:creationId xmlns:a16="http://schemas.microsoft.com/office/drawing/2014/main" id="{0619DC62-32E1-4845-A57E-64B6BDFD080D}"/>
+                <a16:creationId xmlns:a16="http://schemas.microsoft.com/office/drawing/2014/main" id="{6B758306-F211-460F-AD3B-2D6E60051B61}"/>
               </a:ext>
             </a:extLst>
           </p:cNvPr>
@@ -5137,7 +5056,7 @@
           <p:cNvPr id="5" name="">
             <a:extLst xmlns:a="http://schemas.openxmlformats.org/drawingml/2006/main">
               <a:ext uri="{FF2B5EF4-FFF2-40B4-BE49-F238E27FC236}">
-                <a16:creationId xmlns:a16="http://schemas.microsoft.com/office/drawing/2014/main" id="{0661F767-7216-4FDA-85E3-C532A427F1FE}"/>
+                <a16:creationId xmlns:a16="http://schemas.microsoft.com/office/drawing/2014/main" id="{F4F5ECCF-354E-46FB-9A8C-8470F5569AF8}"/>
               </a:ext>
             </a:extLst>
           </p:cNvPr>
@@ -5168,7 +5087,7 @@
           <p:cNvPr id="6" name="">
             <a:extLst xmlns:a="http://schemas.openxmlformats.org/drawingml/2006/main">
               <a:ext uri="{FF2B5EF4-FFF2-40B4-BE49-F238E27FC236}">
-                <a16:creationId xmlns:a16="http://schemas.microsoft.com/office/drawing/2014/main" id="{061026A3-9A10-468B-9168-17D4193F84AB}"/>
+                <a16:creationId xmlns:a16="http://schemas.microsoft.com/office/drawing/2014/main" id="{BE55DB31-8A55-425B-8F19-7B2DD7067F21}"/>
               </a:ext>
             </a:extLst>
           </p:cNvPr>
@@ -5226,7 +5145,7 @@
           <p:cNvPr id="7" name="">
             <a:extLst xmlns:a="http://schemas.openxmlformats.org/drawingml/2006/main">
               <a:ext uri="{FF2B5EF4-FFF2-40B4-BE49-F238E27FC236}">
-                <a16:creationId xmlns:a16="http://schemas.microsoft.com/office/drawing/2014/main" id="{3620715D-8505-4A9F-A123-A6754816159B}"/>
+                <a16:creationId xmlns:a16="http://schemas.microsoft.com/office/drawing/2014/main" id="{3A101E41-C18F-4845-903A-F656E768589A}"/>
               </a:ext>
             </a:extLst>
           </p:cNvPr>
@@ -5284,7 +5203,7 @@
           <p:cNvPr id="8" name="">
             <a:extLst xmlns:a="http://schemas.openxmlformats.org/drawingml/2006/main">
               <a:ext uri="{FF2B5EF4-FFF2-40B4-BE49-F238E27FC236}">
-                <a16:creationId xmlns:a16="http://schemas.microsoft.com/office/drawing/2014/main" id="{76B812D7-82AB-459D-9F62-5902575DBC7C}"/>
+                <a16:creationId xmlns:a16="http://schemas.microsoft.com/office/drawing/2014/main" id="{7867490F-2F79-4620-9F01-D696659FC135}"/>
               </a:ext>
             </a:extLst>
           </p:cNvPr>
@@ -5315,7 +5234,7 @@
           <p:cNvPr id="9" name="">
             <a:extLst xmlns:a="http://schemas.openxmlformats.org/drawingml/2006/main">
               <a:ext uri="{FF2B5EF4-FFF2-40B4-BE49-F238E27FC236}">
-                <a16:creationId xmlns:a16="http://schemas.microsoft.com/office/drawing/2014/main" id="{E8061740-685B-4C5F-BE78-B6CBA784D988}"/>
+                <a16:creationId xmlns:a16="http://schemas.microsoft.com/office/drawing/2014/main" id="{828B0548-B2E1-4153-9918-4ABBD29F60F6}"/>
               </a:ext>
             </a:extLst>
           </p:cNvPr>
@@ -5373,7 +5292,7 @@
           <p:cNvPr id="10" name="">
             <a:extLst xmlns:a="http://schemas.openxmlformats.org/drawingml/2006/main">
               <a:ext uri="{FF2B5EF4-FFF2-40B4-BE49-F238E27FC236}">
-                <a16:creationId xmlns:a16="http://schemas.microsoft.com/office/drawing/2014/main" id="{39BF9067-ACBA-49A0-BCAF-9A408DCE7321}"/>
+                <a16:creationId xmlns:a16="http://schemas.microsoft.com/office/drawing/2014/main" id="{661E5F0B-1E6E-4357-8829-CD2006448D87}"/>
               </a:ext>
             </a:extLst>
           </p:cNvPr>
@@ -5431,7 +5350,7 @@
           <p:cNvPr id="11" name="">
             <a:extLst xmlns:a="http://schemas.openxmlformats.org/drawingml/2006/main">
               <a:ext uri="{FF2B5EF4-FFF2-40B4-BE49-F238E27FC236}">
-                <a16:creationId xmlns:a16="http://schemas.microsoft.com/office/drawing/2014/main" id="{23896F4C-6204-421A-8BB9-878F7D0BE85C}"/>
+                <a16:creationId xmlns:a16="http://schemas.microsoft.com/office/drawing/2014/main" id="{A63FCEF9-A058-4B33-B2A1-52A125CB16CA}"/>
               </a:ext>
             </a:extLst>
           </p:cNvPr>
@@ -5462,7 +5381,7 @@
           <p:cNvPr id="12" name="">
             <a:extLst xmlns:a="http://schemas.openxmlformats.org/drawingml/2006/main">
               <a:ext uri="{FF2B5EF4-FFF2-40B4-BE49-F238E27FC236}">
-                <a16:creationId xmlns:a16="http://schemas.microsoft.com/office/drawing/2014/main" id="{8D939BBE-C272-45CB-844B-87C255064511}"/>
+                <a16:creationId xmlns:a16="http://schemas.microsoft.com/office/drawing/2014/main" id="{A45D2351-BF24-4A62-9B20-F0668D260762}"/>
               </a:ext>
             </a:extLst>
           </p:cNvPr>
@@ -5520,7 +5439,7 @@
           <p:cNvPr id="13" name="">
             <a:extLst xmlns:a="http://schemas.openxmlformats.org/drawingml/2006/main">
               <a:ext uri="{FF2B5EF4-FFF2-40B4-BE49-F238E27FC236}">
-                <a16:creationId xmlns:a16="http://schemas.microsoft.com/office/drawing/2014/main" id="{B825923D-4697-489D-970E-D691B232064C}"/>
+                <a16:creationId xmlns:a16="http://schemas.microsoft.com/office/drawing/2014/main" id="{78BD9176-A700-4096-83D2-BEB7361AEE2B}"/>
               </a:ext>
             </a:extLst>
           </p:cNvPr>
@@ -5578,7 +5497,7 @@
           <p:cNvPr id="14" name="">
             <a:extLst xmlns:a="http://schemas.openxmlformats.org/drawingml/2006/main">
               <a:ext uri="{FF2B5EF4-FFF2-40B4-BE49-F238E27FC236}">
-                <a16:creationId xmlns:a16="http://schemas.microsoft.com/office/drawing/2014/main" id="{E887A0B8-3F81-4D62-873B-32EFF6E5E1EE}"/>
+                <a16:creationId xmlns:a16="http://schemas.microsoft.com/office/drawing/2014/main" id="{C88B3258-3A73-44DD-AE0E-2516442EC89D}"/>
               </a:ext>
             </a:extLst>
           </p:cNvPr>
@@ -5609,7 +5528,7 @@
           <p:cNvPr id="15" name="">
             <a:extLst xmlns:a="http://schemas.openxmlformats.org/drawingml/2006/main">
               <a:ext uri="{FF2B5EF4-FFF2-40B4-BE49-F238E27FC236}">
-                <a16:creationId xmlns:a16="http://schemas.microsoft.com/office/drawing/2014/main" id="{9D575356-9E60-4378-BFE7-42BA71FB5119}"/>
+                <a16:creationId xmlns:a16="http://schemas.microsoft.com/office/drawing/2014/main" id="{EF3FD259-6F36-4D4F-BBE8-0C7BC57A7072}"/>
               </a:ext>
             </a:extLst>
           </p:cNvPr>
@@ -5667,7 +5586,7 @@
           <p:cNvPr id="16" name="">
             <a:extLst xmlns:a="http://schemas.openxmlformats.org/drawingml/2006/main">
               <a:ext uri="{FF2B5EF4-FFF2-40B4-BE49-F238E27FC236}">
-                <a16:creationId xmlns:a16="http://schemas.microsoft.com/office/drawing/2014/main" id="{75FAE8B1-9B11-4BDE-A2C1-D5E972CF66E3}"/>
+                <a16:creationId xmlns:a16="http://schemas.microsoft.com/office/drawing/2014/main" id="{DB0B08CE-0CB2-4EF5-B68F-9D606DF0F1FE}"/>
               </a:ext>
             </a:extLst>
           </p:cNvPr>
@@ -5727,7 +5646,7 @@
           <p:cNvPr id="17" name="">
             <a:extLst xmlns:a="http://schemas.openxmlformats.org/drawingml/2006/main">
               <a:ext uri="{FF2B5EF4-FFF2-40B4-BE49-F238E27FC236}">
-                <a16:creationId xmlns:a16="http://schemas.microsoft.com/office/drawing/2014/main" id="{598E5970-97C4-40D8-BF7E-23A270000789}"/>
+                <a16:creationId xmlns:a16="http://schemas.microsoft.com/office/drawing/2014/main" id="{5FF7520F-1646-4541-9B70-55B4BCECCFCD}"/>
               </a:ext>
             </a:extLst>
           </p:cNvPr>
@@ -5785,7 +5704,7 @@
           <p:cNvPr id="18" name="">
             <a:extLst xmlns:a="http://schemas.openxmlformats.org/drawingml/2006/main">
               <a:ext uri="{FF2B5EF4-FFF2-40B4-BE49-F238E27FC236}">
-                <a16:creationId xmlns:a16="http://schemas.microsoft.com/office/drawing/2014/main" id="{03904541-64EA-4899-8CB4-B4BAA9B7F412}"/>
+                <a16:creationId xmlns:a16="http://schemas.microsoft.com/office/drawing/2014/main" id="{2B39EA13-9BAC-49E2-8EA9-6C17B2DEED06}"/>
               </a:ext>
             </a:extLst>
           </p:cNvPr>
@@ -5843,7 +5762,7 @@
           <p:cNvPr id="19" name="">
             <a:extLst xmlns:a="http://schemas.openxmlformats.org/drawingml/2006/main">
               <a:ext uri="{FF2B5EF4-FFF2-40B4-BE49-F238E27FC236}">
-                <a16:creationId xmlns:a16="http://schemas.microsoft.com/office/drawing/2014/main" id="{56CAB30F-7415-40AF-9E28-6121FCA455F9}"/>
+                <a16:creationId xmlns:a16="http://schemas.microsoft.com/office/drawing/2014/main" id="{C8C47687-BC4B-4474-8346-80E57693B549}"/>
               </a:ext>
             </a:extLst>
           </p:cNvPr>
@@ -5903,7 +5822,7 @@
           <p:cNvPr id="20" name="">
             <a:extLst xmlns:a="http://schemas.openxmlformats.org/drawingml/2006/main">
               <a:ext uri="{FF2B5EF4-FFF2-40B4-BE49-F238E27FC236}">
-                <a16:creationId xmlns:a16="http://schemas.microsoft.com/office/drawing/2014/main" id="{AC043B12-9B97-4389-ABE1-6C61A008950B}"/>
+                <a16:creationId xmlns:a16="http://schemas.microsoft.com/office/drawing/2014/main" id="{F87A04C2-289F-4320-999C-61B299655FB2}"/>
               </a:ext>
             </a:extLst>
           </p:cNvPr>
@@ -5961,7 +5880,7 @@
           <p:cNvPr id="21" name="">
             <a:extLst xmlns:a="http://schemas.openxmlformats.org/drawingml/2006/main">
               <a:ext uri="{FF2B5EF4-FFF2-40B4-BE49-F238E27FC236}">
-                <a16:creationId xmlns:a16="http://schemas.microsoft.com/office/drawing/2014/main" id="{9E5EA173-EC9C-4561-8CE3-CF318A80667B}"/>
+                <a16:creationId xmlns:a16="http://schemas.microsoft.com/office/drawing/2014/main" id="{D193A345-45BA-4765-A369-D1D727CC963D}"/>
               </a:ext>
             </a:extLst>
           </p:cNvPr>
@@ -6019,7 +5938,7 @@
           <p:cNvPr id="22" name="">
             <a:extLst xmlns:a="http://schemas.openxmlformats.org/drawingml/2006/main">
               <a:ext uri="{FF2B5EF4-FFF2-40B4-BE49-F238E27FC236}">
-                <a16:creationId xmlns:a16="http://schemas.microsoft.com/office/drawing/2014/main" id="{AAB576C2-A777-4621-86B7-92EABE590CBE}"/>
+                <a16:creationId xmlns:a16="http://schemas.microsoft.com/office/drawing/2014/main" id="{8C7CCFF7-44C2-4BAA-B883-DCDC26BBE17D}"/>
               </a:ext>
             </a:extLst>
           </p:cNvPr>
@@ -6079,7 +5998,7 @@
           <p:cNvPr id="23" name="">
             <a:extLst xmlns:a="http://schemas.openxmlformats.org/drawingml/2006/main">
               <a:ext uri="{FF2B5EF4-FFF2-40B4-BE49-F238E27FC236}">
-                <a16:creationId xmlns:a16="http://schemas.microsoft.com/office/drawing/2014/main" id="{0196E695-7713-493C-A7B6-99F6E884DF27}"/>
+                <a16:creationId xmlns:a16="http://schemas.microsoft.com/office/drawing/2014/main" id="{40D63B0C-47C4-4AD9-A67B-AE40CF409F3F}"/>
               </a:ext>
             </a:extLst>
           </p:cNvPr>
@@ -6137,7 +6056,7 @@
           <p:cNvPr id="24" name="">
             <a:extLst xmlns:a="http://schemas.openxmlformats.org/drawingml/2006/main">
               <a:ext uri="{FF2B5EF4-FFF2-40B4-BE49-F238E27FC236}">
-                <a16:creationId xmlns:a16="http://schemas.microsoft.com/office/drawing/2014/main" id="{57F60F37-1980-4ED8-AEF1-58748FBD93E1}"/>
+                <a16:creationId xmlns:a16="http://schemas.microsoft.com/office/drawing/2014/main" id="{B9893D6E-86D2-4062-A180-ECF8FE6B4FF5}"/>
               </a:ext>
             </a:extLst>
           </p:cNvPr>
@@ -6195,7 +6114,7 @@
           <p:cNvPr id="25" name="">
             <a:extLst xmlns:a="http://schemas.openxmlformats.org/drawingml/2006/main">
               <a:ext uri="{FF2B5EF4-FFF2-40B4-BE49-F238E27FC236}">
-                <a16:creationId xmlns:a16="http://schemas.microsoft.com/office/drawing/2014/main" id="{42C3FF07-7B36-4E84-A49B-CA1C35030C0A}"/>
+                <a16:creationId xmlns:a16="http://schemas.microsoft.com/office/drawing/2014/main" id="{A4D93CDC-60D5-496E-8E7E-3DDBFF34EC2A}"/>
               </a:ext>
             </a:extLst>
           </p:cNvPr>
@@ -6255,7 +6174,7 @@
           <p:cNvPr id="26" name="">
             <a:extLst xmlns:a="http://schemas.openxmlformats.org/drawingml/2006/main">
               <a:ext uri="{FF2B5EF4-FFF2-40B4-BE49-F238E27FC236}">
-                <a16:creationId xmlns:a16="http://schemas.microsoft.com/office/drawing/2014/main" id="{4FF3ACED-CE7F-49DE-B83E-E8250BFD0622}"/>
+                <a16:creationId xmlns:a16="http://schemas.microsoft.com/office/drawing/2014/main" id="{003C71FF-9A32-4304-BD02-D4BF5A19E361}"/>
               </a:ext>
             </a:extLst>
           </p:cNvPr>
@@ -6313,7 +6232,7 @@
           <p:cNvPr id="27" name="">
             <a:extLst xmlns:a="http://schemas.openxmlformats.org/drawingml/2006/main">
               <a:ext uri="{FF2B5EF4-FFF2-40B4-BE49-F238E27FC236}">
-                <a16:creationId xmlns:a16="http://schemas.microsoft.com/office/drawing/2014/main" id="{2F1678FB-3386-47A0-B464-68F7EF0A51F1}"/>
+                <a16:creationId xmlns:a16="http://schemas.microsoft.com/office/drawing/2014/main" id="{4697C4D2-97D5-4873-9F5F-423FC73657B0}"/>
               </a:ext>
             </a:extLst>
           </p:cNvPr>
@@ -6371,7 +6290,7 @@
           <p:cNvPr id="28" name="">
             <a:extLst xmlns:a="http://schemas.openxmlformats.org/drawingml/2006/main">
               <a:ext uri="{FF2B5EF4-FFF2-40B4-BE49-F238E27FC236}">
-                <a16:creationId xmlns:a16="http://schemas.microsoft.com/office/drawing/2014/main" id="{4F427C5E-AB57-4BE3-9AE7-A9913543B0C6}"/>
+                <a16:creationId xmlns:a16="http://schemas.microsoft.com/office/drawing/2014/main" id="{A3EFB332-3AFD-4D43-9364-FBD0457EFFD4}"/>
               </a:ext>
             </a:extLst>
           </p:cNvPr>
@@ -6429,7 +6348,7 @@
           <p:cNvPr id="29" name="">
             <a:extLst xmlns:a="http://schemas.openxmlformats.org/drawingml/2006/main">
               <a:ext uri="{FF2B5EF4-FFF2-40B4-BE49-F238E27FC236}">
-                <a16:creationId xmlns:a16="http://schemas.microsoft.com/office/drawing/2014/main" id="{2F79D4E5-915F-4A18-A7CA-440B06F6FBAD}"/>
+                <a16:creationId xmlns:a16="http://schemas.microsoft.com/office/drawing/2014/main" id="{F6976999-C2A4-4F44-97A2-B248635BA516}"/>
               </a:ext>
             </a:extLst>
           </p:cNvPr>
@@ -6477,7 +6396,7 @@
                 <a:ea typeface="Aptos"/>
                 <a:cs typeface="Aptos"/>
               </a:rPr>
-              <a:t>SMARTCOURSE  /  FYP VIVA</a:t>
+              <a:t>SMARTCOURSE  /  PROJECT</a:t>
             </a:r>
           </a:p>
         </p:txBody>
@@ -6487,7 +6406,7 @@
           <p:cNvPr id="30" name="">
             <a:extLst xmlns:a="http://schemas.openxmlformats.org/drawingml/2006/main">
               <a:ext uri="{FF2B5EF4-FFF2-40B4-BE49-F238E27FC236}">
-                <a16:creationId xmlns:a16="http://schemas.microsoft.com/office/drawing/2014/main" id="{208E8122-02D6-4B89-9A06-550DD960FA87}"/>
+                <a16:creationId xmlns:a16="http://schemas.microsoft.com/office/drawing/2014/main" id="{0E1BC9D6-B681-4FCE-8F3A-EB2CF85E5072}"/>
               </a:ext>
             </a:extLst>
           </p:cNvPr>
@@ -6543,7 +6462,7 @@
     </p:spTree>
     <p:extLst>
       <p:ext uri="{BB962C8B-B14F-4D97-AF65-F5344CB8AC3E}">
-        <p14:creationId xmlns:p14="http://schemas.microsoft.com/office/powerpoint/2010/main" val="1697237094"/>
+        <p14:creationId xmlns:p14="http://schemas.microsoft.com/office/powerpoint/2010/main" val="320220695"/>
       </p:ext>
     </p:extLst>
   </p:cSld>
@@ -6574,7 +6493,7 @@
           <p:cNvPr id="28" name="kicker">
             <a:extLst xmlns:a="http://schemas.openxmlformats.org/drawingml/2006/main">
               <a:ext uri="{FF2B5EF4-FFF2-40B4-BE49-F238E27FC236}">
-                <a16:creationId xmlns:a16="http://schemas.microsoft.com/office/drawing/2014/main" id="{67A24C17-E720-44A5-87EC-158F66F84312}"/>
+                <a16:creationId xmlns:a16="http://schemas.microsoft.com/office/drawing/2014/main" id="{7E88BB82-099B-4D83-AAB5-B64680EC66D9}"/>
               </a:ext>
             </a:extLst>
           </p:cNvPr>
@@ -6622,7 +6541,7 @@
                 <a:ea typeface="Aptos"/>
                 <a:cs typeface="Aptos"/>
               </a:rPr>
-              <a:t>11 / LIKELY VIVA QUESTIONS</a:t>
+              <a:t>11 / DESIGN CHOICES</a:t>
             </a:r>
           </a:p>
         </p:txBody>
@@ -6632,7 +6551,7 @@
           <p:cNvPr id="2" name="title">
             <a:extLst xmlns:a="http://schemas.openxmlformats.org/drawingml/2006/main">
               <a:ext uri="{FF2B5EF4-FFF2-40B4-BE49-F238E27FC236}">
-                <a16:creationId xmlns:a16="http://schemas.microsoft.com/office/drawing/2014/main" id="{EAF88743-2CED-4D51-A906-18D7EF32D4B7}"/>
+                <a16:creationId xmlns:a16="http://schemas.microsoft.com/office/drawing/2014/main" id="{8B205894-F4BD-43EA-AABA-367CBB65DC44}"/>
               </a:ext>
             </a:extLst>
           </p:cNvPr>
@@ -6680,7 +6599,7 @@
                 <a:ea typeface="Aptos"/>
                 <a:cs typeface="Aptos"/>
               </a:rPr>
-              <a:t>Answer with the current prototype, then name the next improvement.</a:t>
+              <a:t>The technology choices reflect the prototype's goals and constraints.</a:t>
             </a:r>
           </a:p>
         </p:txBody>
@@ -6690,7 +6609,7 @@
           <p:cNvPr id="3" name="subtitle">
             <a:extLst xmlns:a="http://schemas.openxmlformats.org/drawingml/2006/main">
               <a:ext uri="{FF2B5EF4-FFF2-40B4-BE49-F238E27FC236}">
-                <a16:creationId xmlns:a16="http://schemas.microsoft.com/office/drawing/2014/main" id="{588A9937-8328-47FF-A31D-3C57EE3F7BB5}"/>
+                <a16:creationId xmlns:a16="http://schemas.microsoft.com/office/drawing/2014/main" id="{1417A30B-0258-4B6F-BB18-5146C6F85E8B}"/>
               </a:ext>
             </a:extLst>
           </p:cNvPr>
@@ -6738,7 +6657,7 @@
                 <a:ea typeface="Aptos"/>
                 <a:cs typeface="Aptos"/>
               </a:rPr>
-              <a:t>Short, structured answers keep the discussion grounded in what the code actually does.</a:t>
+              <a:t>Each component supports a clear, testable recommendation workflow.</a:t>
             </a:r>
           </a:p>
         </p:txBody>
@@ -6748,7 +6667,7 @@
           <p:cNvPr id="4" name="">
             <a:extLst xmlns:a="http://schemas.openxmlformats.org/drawingml/2006/main">
               <a:ext uri="{FF2B5EF4-FFF2-40B4-BE49-F238E27FC236}">
-                <a16:creationId xmlns:a16="http://schemas.microsoft.com/office/drawing/2014/main" id="{156F48EE-341F-465A-B266-BF7ABF40EB4A}"/>
+                <a16:creationId xmlns:a16="http://schemas.microsoft.com/office/drawing/2014/main" id="{1C6DB1FB-F7EA-431D-AB9F-90EB15E52984}"/>
               </a:ext>
             </a:extLst>
           </p:cNvPr>
@@ -6779,7 +6698,7 @@
           <p:cNvPr id="5" name="">
             <a:extLst xmlns:a="http://schemas.openxmlformats.org/drawingml/2006/main">
               <a:ext uri="{FF2B5EF4-FFF2-40B4-BE49-F238E27FC236}">
-                <a16:creationId xmlns:a16="http://schemas.microsoft.com/office/drawing/2014/main" id="{19EF2E51-6F5D-4FD6-B6A7-85DCB56EDF57}"/>
+                <a16:creationId xmlns:a16="http://schemas.microsoft.com/office/drawing/2014/main" id="{9651290D-D4D3-483E-99C6-B520D1AEA420}"/>
               </a:ext>
             </a:extLst>
           </p:cNvPr>
@@ -6820,7 +6739,7 @@
           <p:cNvPr id="6" name="">
             <a:extLst xmlns:a="http://schemas.openxmlformats.org/drawingml/2006/main">
               <a:ext uri="{FF2B5EF4-FFF2-40B4-BE49-F238E27FC236}">
-                <a16:creationId xmlns:a16="http://schemas.microsoft.com/office/drawing/2014/main" id="{89AEB9E6-C70E-48E5-82A1-0413C058DA65}"/>
+                <a16:creationId xmlns:a16="http://schemas.microsoft.com/office/drawing/2014/main" id="{2714BDD4-29D4-4871-B377-01213E2798DB}"/>
               </a:ext>
             </a:extLst>
           </p:cNvPr>
@@ -6878,7 +6797,7 @@
           <p:cNvPr id="7" name="">
             <a:extLst xmlns:a="http://schemas.openxmlformats.org/drawingml/2006/main">
               <a:ext uri="{FF2B5EF4-FFF2-40B4-BE49-F238E27FC236}">
-                <a16:creationId xmlns:a16="http://schemas.microsoft.com/office/drawing/2014/main" id="{19A98846-7978-4493-BC4B-3881D1BCDC46}"/>
+                <a16:creationId xmlns:a16="http://schemas.microsoft.com/office/drawing/2014/main" id="{189759FE-5E6B-477A-B662-522932958144}"/>
               </a:ext>
             </a:extLst>
           </p:cNvPr>
@@ -6936,7 +6855,7 @@
           <p:cNvPr id="8" name="">
             <a:extLst xmlns:a="http://schemas.openxmlformats.org/drawingml/2006/main">
               <a:ext uri="{FF2B5EF4-FFF2-40B4-BE49-F238E27FC236}">
-                <a16:creationId xmlns:a16="http://schemas.microsoft.com/office/drawing/2014/main" id="{119D5DDE-404F-4F56-AC03-B36A30D7E4CA}"/>
+                <a16:creationId xmlns:a16="http://schemas.microsoft.com/office/drawing/2014/main" id="{CC36EDBA-9ADE-4244-9F88-4D160058C3B5}"/>
               </a:ext>
             </a:extLst>
           </p:cNvPr>
@@ -6977,7 +6896,7 @@
           <p:cNvPr id="9" name="">
             <a:extLst xmlns:a="http://schemas.openxmlformats.org/drawingml/2006/main">
               <a:ext uri="{FF2B5EF4-FFF2-40B4-BE49-F238E27FC236}">
-                <a16:creationId xmlns:a16="http://schemas.microsoft.com/office/drawing/2014/main" id="{979499DD-B6F6-4BE1-8ABA-4A7B29BF9BA7}"/>
+                <a16:creationId xmlns:a16="http://schemas.microsoft.com/office/drawing/2014/main" id="{9C91C8FD-C027-4E9A-B99E-991846F54608}"/>
               </a:ext>
             </a:extLst>
           </p:cNvPr>
@@ -7035,7 +6954,7 @@
           <p:cNvPr id="10" name="">
             <a:extLst xmlns:a="http://schemas.openxmlformats.org/drawingml/2006/main">
               <a:ext uri="{FF2B5EF4-FFF2-40B4-BE49-F238E27FC236}">
-                <a16:creationId xmlns:a16="http://schemas.microsoft.com/office/drawing/2014/main" id="{FC7F7359-B27E-4A7B-895E-059EA6C1A2E0}"/>
+                <a16:creationId xmlns:a16="http://schemas.microsoft.com/office/drawing/2014/main" id="{199A3752-460E-45CC-8D95-133DA1AC7E48}"/>
               </a:ext>
             </a:extLst>
           </p:cNvPr>
@@ -7093,7 +7012,7 @@
           <p:cNvPr id="11" name="">
             <a:extLst xmlns:a="http://schemas.openxmlformats.org/drawingml/2006/main">
               <a:ext uri="{FF2B5EF4-FFF2-40B4-BE49-F238E27FC236}">
-                <a16:creationId xmlns:a16="http://schemas.microsoft.com/office/drawing/2014/main" id="{000684C7-5053-4D55-A823-9BAFC69B1A2C}"/>
+                <a16:creationId xmlns:a16="http://schemas.microsoft.com/office/drawing/2014/main" id="{68376EF0-969F-48AE-851E-8272742F4039}"/>
               </a:ext>
             </a:extLst>
           </p:cNvPr>
@@ -7134,7 +7053,7 @@
           <p:cNvPr id="12" name="">
             <a:extLst xmlns:a="http://schemas.openxmlformats.org/drawingml/2006/main">
               <a:ext uri="{FF2B5EF4-FFF2-40B4-BE49-F238E27FC236}">
-                <a16:creationId xmlns:a16="http://schemas.microsoft.com/office/drawing/2014/main" id="{032C0811-5350-469D-A40E-06B29AA1A367}"/>
+                <a16:creationId xmlns:a16="http://schemas.microsoft.com/office/drawing/2014/main" id="{80E01501-F609-4417-8CCA-E6E05C84128F}"/>
               </a:ext>
             </a:extLst>
           </p:cNvPr>
@@ -7192,7 +7111,7 @@
           <p:cNvPr id="13" name="">
             <a:extLst xmlns:a="http://schemas.openxmlformats.org/drawingml/2006/main">
               <a:ext uri="{FF2B5EF4-FFF2-40B4-BE49-F238E27FC236}">
-                <a16:creationId xmlns:a16="http://schemas.microsoft.com/office/drawing/2014/main" id="{27CA8DF6-DE32-43F7-A173-1DBFEA07192C}"/>
+                <a16:creationId xmlns:a16="http://schemas.microsoft.com/office/drawing/2014/main" id="{A815C700-164F-425D-8BCB-93606DD77245}"/>
               </a:ext>
             </a:extLst>
           </p:cNvPr>
@@ -7250,7 +7169,7 @@
           <p:cNvPr id="14" name="">
             <a:extLst xmlns:a="http://schemas.openxmlformats.org/drawingml/2006/main">
               <a:ext uri="{FF2B5EF4-FFF2-40B4-BE49-F238E27FC236}">
-                <a16:creationId xmlns:a16="http://schemas.microsoft.com/office/drawing/2014/main" id="{85D4945A-0A77-4CA6-86DE-FAE4D9887A43}"/>
+                <a16:creationId xmlns:a16="http://schemas.microsoft.com/office/drawing/2014/main" id="{17503953-C986-4C9D-85A6-EDFF0278CEF1}"/>
               </a:ext>
             </a:extLst>
           </p:cNvPr>
@@ -7291,7 +7210,7 @@
           <p:cNvPr id="15" name="">
             <a:extLst xmlns:a="http://schemas.openxmlformats.org/drawingml/2006/main">
               <a:ext uri="{FF2B5EF4-FFF2-40B4-BE49-F238E27FC236}">
-                <a16:creationId xmlns:a16="http://schemas.microsoft.com/office/drawing/2014/main" id="{F7B3E2EC-6FAC-4D06-951B-F83A4CE73E9C}"/>
+                <a16:creationId xmlns:a16="http://schemas.microsoft.com/office/drawing/2014/main" id="{2BE267A7-49E9-4B60-BCF0-4087F705341D}"/>
               </a:ext>
             </a:extLst>
           </p:cNvPr>
@@ -7349,7 +7268,7 @@
           <p:cNvPr id="16" name="">
             <a:extLst xmlns:a="http://schemas.openxmlformats.org/drawingml/2006/main">
               <a:ext uri="{FF2B5EF4-FFF2-40B4-BE49-F238E27FC236}">
-                <a16:creationId xmlns:a16="http://schemas.microsoft.com/office/drawing/2014/main" id="{BE8D48C6-7798-42CF-8445-2090FC1DCBEF}"/>
+                <a16:creationId xmlns:a16="http://schemas.microsoft.com/office/drawing/2014/main" id="{8FBDF4D7-0424-42D1-8B24-A7E8C96B792F}"/>
               </a:ext>
             </a:extLst>
           </p:cNvPr>
@@ -7407,7 +7326,7 @@
           <p:cNvPr id="17" name="">
             <a:extLst xmlns:a="http://schemas.openxmlformats.org/drawingml/2006/main">
               <a:ext uri="{FF2B5EF4-FFF2-40B4-BE49-F238E27FC236}">
-                <a16:creationId xmlns:a16="http://schemas.microsoft.com/office/drawing/2014/main" id="{49CBF63C-ADC0-4A94-BF6A-652DEF22DFFA}"/>
+                <a16:creationId xmlns:a16="http://schemas.microsoft.com/office/drawing/2014/main" id="{9A546E48-096D-4F42-A9F8-7A5F0B4E628F}"/>
               </a:ext>
             </a:extLst>
           </p:cNvPr>
@@ -7448,7 +7367,7 @@
           <p:cNvPr id="18" name="">
             <a:extLst xmlns:a="http://schemas.openxmlformats.org/drawingml/2006/main">
               <a:ext uri="{FF2B5EF4-FFF2-40B4-BE49-F238E27FC236}">
-                <a16:creationId xmlns:a16="http://schemas.microsoft.com/office/drawing/2014/main" id="{A993B0FF-10C1-42E4-874D-F5FC59ACDF70}"/>
+                <a16:creationId xmlns:a16="http://schemas.microsoft.com/office/drawing/2014/main" id="{A5B38D31-CB30-4891-981A-186F60CF7135}"/>
               </a:ext>
             </a:extLst>
           </p:cNvPr>
@@ -7506,7 +7425,7 @@
           <p:cNvPr id="19" name="">
             <a:extLst xmlns:a="http://schemas.openxmlformats.org/drawingml/2006/main">
               <a:ext uri="{FF2B5EF4-FFF2-40B4-BE49-F238E27FC236}">
-                <a16:creationId xmlns:a16="http://schemas.microsoft.com/office/drawing/2014/main" id="{3AC82292-D3E2-4237-927B-AE21E119F8C7}"/>
+                <a16:creationId xmlns:a16="http://schemas.microsoft.com/office/drawing/2014/main" id="{0203CCAE-D174-44F6-9BBB-EB456942304C}"/>
               </a:ext>
             </a:extLst>
           </p:cNvPr>
@@ -7564,7 +7483,7 @@
           <p:cNvPr id="20" name="">
             <a:extLst xmlns:a="http://schemas.openxmlformats.org/drawingml/2006/main">
               <a:ext uri="{FF2B5EF4-FFF2-40B4-BE49-F238E27FC236}">
-                <a16:creationId xmlns:a16="http://schemas.microsoft.com/office/drawing/2014/main" id="{1DC71863-EF66-4108-B659-FEC947D5345A}"/>
+                <a16:creationId xmlns:a16="http://schemas.microsoft.com/office/drawing/2014/main" id="{0B6B1443-83BB-4BD1-BCFF-B57DDB4D6610}"/>
               </a:ext>
             </a:extLst>
           </p:cNvPr>
@@ -7605,7 +7524,7 @@
           <p:cNvPr id="21" name="">
             <a:extLst xmlns:a="http://schemas.openxmlformats.org/drawingml/2006/main">
               <a:ext uri="{FF2B5EF4-FFF2-40B4-BE49-F238E27FC236}">
-                <a16:creationId xmlns:a16="http://schemas.microsoft.com/office/drawing/2014/main" id="{234C3557-DDE8-4C21-A9C1-B33E329C9D0B}"/>
+                <a16:creationId xmlns:a16="http://schemas.microsoft.com/office/drawing/2014/main" id="{45298B8F-A3E0-47B5-B7A9-842082E77231}"/>
               </a:ext>
             </a:extLst>
           </p:cNvPr>
@@ -7663,7 +7582,7 @@
           <p:cNvPr id="22" name="">
             <a:extLst xmlns:a="http://schemas.openxmlformats.org/drawingml/2006/main">
               <a:ext uri="{FF2B5EF4-FFF2-40B4-BE49-F238E27FC236}">
-                <a16:creationId xmlns:a16="http://schemas.microsoft.com/office/drawing/2014/main" id="{040B061B-7333-455E-A641-21F5482F6652}"/>
+                <a16:creationId xmlns:a16="http://schemas.microsoft.com/office/drawing/2014/main" id="{CFC8BCB9-459C-4116-964E-AE197B0D969C}"/>
               </a:ext>
             </a:extLst>
           </p:cNvPr>
@@ -7721,7 +7640,7 @@
           <p:cNvPr id="23" name="">
             <a:extLst xmlns:a="http://schemas.openxmlformats.org/drawingml/2006/main">
               <a:ext uri="{FF2B5EF4-FFF2-40B4-BE49-F238E27FC236}">
-                <a16:creationId xmlns:a16="http://schemas.microsoft.com/office/drawing/2014/main" id="{0038BB8D-5BA4-4EBB-AABD-C54D973E5043}"/>
+                <a16:creationId xmlns:a16="http://schemas.microsoft.com/office/drawing/2014/main" id="{5DCE2520-DB7E-447F-A467-6DC09B2CCE95}"/>
               </a:ext>
             </a:extLst>
           </p:cNvPr>
@@ -7756,7 +7675,7 @@
           <p:cNvPr id="24" name="">
             <a:extLst xmlns:a="http://schemas.openxmlformats.org/drawingml/2006/main">
               <a:ext uri="{FF2B5EF4-FFF2-40B4-BE49-F238E27FC236}">
-                <a16:creationId xmlns:a16="http://schemas.microsoft.com/office/drawing/2014/main" id="{C088A8FC-884A-4E60-A584-D70421E1FA07}"/>
+                <a16:creationId xmlns:a16="http://schemas.microsoft.com/office/drawing/2014/main" id="{07A7DF4E-783F-4CA3-919F-EDF9CDC06685}"/>
               </a:ext>
             </a:extLst>
           </p:cNvPr>
@@ -7814,7 +7733,7 @@
           <p:cNvPr id="25" name="">
             <a:extLst xmlns:a="http://schemas.openxmlformats.org/drawingml/2006/main">
               <a:ext uri="{FF2B5EF4-FFF2-40B4-BE49-F238E27FC236}">
-                <a16:creationId xmlns:a16="http://schemas.microsoft.com/office/drawing/2014/main" id="{35E801E6-7452-414C-8120-84970857D109}"/>
+                <a16:creationId xmlns:a16="http://schemas.microsoft.com/office/drawing/2014/main" id="{B36370CE-B1FB-4EED-9590-8B38F74035EE}"/>
               </a:ext>
             </a:extLst>
           </p:cNvPr>
@@ -7872,7 +7791,7 @@
           <p:cNvPr id="26" name="">
             <a:extLst xmlns:a="http://schemas.openxmlformats.org/drawingml/2006/main">
               <a:ext uri="{FF2B5EF4-FFF2-40B4-BE49-F238E27FC236}">
-                <a16:creationId xmlns:a16="http://schemas.microsoft.com/office/drawing/2014/main" id="{7D1468E4-0C3E-4758-90D5-C1C633E5B0D8}"/>
+                <a16:creationId xmlns:a16="http://schemas.microsoft.com/office/drawing/2014/main" id="{83685886-6B73-4DA0-A19A-2357677181C3}"/>
               </a:ext>
             </a:extLst>
           </p:cNvPr>
@@ -7920,7 +7839,7 @@
                 <a:ea typeface="Aptos"/>
                 <a:cs typeface="Aptos"/>
               </a:rPr>
-              <a:t>SMARTCOURSE  /  FYP VIVA</a:t>
+              <a:t>SMARTCOURSE  /  PROJECT</a:t>
             </a:r>
           </a:p>
         </p:txBody>
@@ -7930,7 +7849,7 @@
           <p:cNvPr id="27" name="">
             <a:extLst xmlns:a="http://schemas.openxmlformats.org/drawingml/2006/main">
               <a:ext uri="{FF2B5EF4-FFF2-40B4-BE49-F238E27FC236}">
-                <a16:creationId xmlns:a16="http://schemas.microsoft.com/office/drawing/2014/main" id="{D852777B-CF6D-4A44-B77C-CFE49E410121}"/>
+                <a16:creationId xmlns:a16="http://schemas.microsoft.com/office/drawing/2014/main" id="{D590CBE3-CAFD-4D25-90AB-45F1C7C551C7}"/>
               </a:ext>
             </a:extLst>
           </p:cNvPr>
@@ -7986,7 +7905,7 @@
     </p:spTree>
     <p:extLst>
       <p:ext uri="{BB962C8B-B14F-4D97-AF65-F5344CB8AC3E}">
-        <p14:creationId xmlns:p14="http://schemas.microsoft.com/office/powerpoint/2010/main" val="457086371"/>
+        <p14:creationId xmlns:p14="http://schemas.microsoft.com/office/powerpoint/2010/main" val="1909696966"/>
       </p:ext>
     </p:extLst>
   </p:cSld>
@@ -8017,7 +7936,7 @@
           <p:cNvPr id="32" name="kicker">
             <a:extLst xmlns:a="http://schemas.openxmlformats.org/drawingml/2006/main">
               <a:ext uri="{FF2B5EF4-FFF2-40B4-BE49-F238E27FC236}">
-                <a16:creationId xmlns:a16="http://schemas.microsoft.com/office/drawing/2014/main" id="{3386980F-791D-4C94-AE19-55400E1F7C1C}"/>
+                <a16:creationId xmlns:a16="http://schemas.microsoft.com/office/drawing/2014/main" id="{A116E1FC-2C26-4A18-815C-9AD19BE0B711}"/>
               </a:ext>
             </a:extLst>
           </p:cNvPr>
@@ -8075,7 +7994,7 @@
           <p:cNvPr id="2" name="title">
             <a:extLst xmlns:a="http://schemas.openxmlformats.org/drawingml/2006/main">
               <a:ext uri="{FF2B5EF4-FFF2-40B4-BE49-F238E27FC236}">
-                <a16:creationId xmlns:a16="http://schemas.microsoft.com/office/drawing/2014/main" id="{9D51FBE8-36C8-4C88-8855-478370A19B27}"/>
+                <a16:creationId xmlns:a16="http://schemas.microsoft.com/office/drawing/2014/main" id="{2823683A-AD15-46ED-8E65-EA4EB225CB7A}"/>
               </a:ext>
             </a:extLst>
           </p:cNvPr>
@@ -8123,7 +8042,7 @@
                 <a:ea typeface="Aptos"/>
                 <a:cs typeface="Aptos"/>
               </a:rPr>
-              <a:t>The live story is simple: search → compare → save → revisit.</a:t>
+              <a:t>The product flow is search → compare → save → revisit.</a:t>
             </a:r>
           </a:p>
         </p:txBody>
@@ -8133,7 +8052,7 @@
           <p:cNvPr id="3" name="subtitle">
             <a:extLst xmlns:a="http://schemas.openxmlformats.org/drawingml/2006/main">
               <a:ext uri="{FF2B5EF4-FFF2-40B4-BE49-F238E27FC236}">
-                <a16:creationId xmlns:a16="http://schemas.microsoft.com/office/drawing/2014/main" id="{32F027B8-A90B-4EAB-A47B-E19410BE7818}"/>
+                <a16:creationId xmlns:a16="http://schemas.microsoft.com/office/drawing/2014/main" id="{F4322033-0059-437B-B86E-72E10D7C58FF}"/>
               </a:ext>
             </a:extLst>
           </p:cNvPr>
@@ -8181,7 +8100,7 @@
                 <a:ea typeface="Aptos"/>
                 <a:cs typeface="Aptos"/>
               </a:rPr>
-              <a:t>A short, repeatable demo keeps the viva focused on the system's value and the engineering behind it.</a:t>
+              <a:t>The demo connects the user journey to the engineering behind it.</a:t>
             </a:r>
           </a:p>
         </p:txBody>
@@ -8191,7 +8110,7 @@
           <p:cNvPr id="4" name="">
             <a:extLst xmlns:a="http://schemas.openxmlformats.org/drawingml/2006/main">
               <a:ext uri="{FF2B5EF4-FFF2-40B4-BE49-F238E27FC236}">
-                <a16:creationId xmlns:a16="http://schemas.microsoft.com/office/drawing/2014/main" id="{8546401A-17C2-4762-A71D-9286E58E7BFF}"/>
+                <a16:creationId xmlns:a16="http://schemas.microsoft.com/office/drawing/2014/main" id="{FE3FD94F-52E7-4C62-ADBF-39834FFEB496}"/>
               </a:ext>
             </a:extLst>
           </p:cNvPr>
@@ -8222,7 +8141,7 @@
           <p:cNvPr id="5" name="">
             <a:extLst xmlns:a="http://schemas.openxmlformats.org/drawingml/2006/main">
               <a:ext uri="{FF2B5EF4-FFF2-40B4-BE49-F238E27FC236}">
-                <a16:creationId xmlns:a16="http://schemas.microsoft.com/office/drawing/2014/main" id="{81726B5A-1E98-4B06-9D2C-C9405A69688F}"/>
+                <a16:creationId xmlns:a16="http://schemas.microsoft.com/office/drawing/2014/main" id="{C57CC58C-AA8F-4DCE-AF76-20C7D490195D}"/>
               </a:ext>
             </a:extLst>
           </p:cNvPr>
@@ -8263,7 +8182,7 @@
           <p:cNvPr id="6" name="">
             <a:extLst xmlns:a="http://schemas.openxmlformats.org/drawingml/2006/main">
               <a:ext uri="{FF2B5EF4-FFF2-40B4-BE49-F238E27FC236}">
-                <a16:creationId xmlns:a16="http://schemas.microsoft.com/office/drawing/2014/main" id="{DB224D7D-BE7D-4C88-852E-3CA6DB91241F}"/>
+                <a16:creationId xmlns:a16="http://schemas.microsoft.com/office/drawing/2014/main" id="{3935FEFD-3824-4148-8C41-6A348D6313AD}"/>
               </a:ext>
             </a:extLst>
           </p:cNvPr>
@@ -8321,7 +8240,7 @@
           <p:cNvPr id="7" name="">
             <a:extLst xmlns:a="http://schemas.openxmlformats.org/drawingml/2006/main">
               <a:ext uri="{FF2B5EF4-FFF2-40B4-BE49-F238E27FC236}">
-                <a16:creationId xmlns:a16="http://schemas.microsoft.com/office/drawing/2014/main" id="{8B5CC3FB-0833-4516-97E4-CADB419EDB04}"/>
+                <a16:creationId xmlns:a16="http://schemas.microsoft.com/office/drawing/2014/main" id="{BC641809-28CB-49A3-BECA-92FA1E99227D}"/>
               </a:ext>
             </a:extLst>
           </p:cNvPr>
@@ -8379,7 +8298,7 @@
           <p:cNvPr id="8" name="">
             <a:extLst xmlns:a="http://schemas.openxmlformats.org/drawingml/2006/main">
               <a:ext uri="{FF2B5EF4-FFF2-40B4-BE49-F238E27FC236}">
-                <a16:creationId xmlns:a16="http://schemas.microsoft.com/office/drawing/2014/main" id="{C769EB5B-7539-47F0-9EFB-40126B59AE67}"/>
+                <a16:creationId xmlns:a16="http://schemas.microsoft.com/office/drawing/2014/main" id="{4A4F5155-0B27-41C6-8173-8859432C5278}"/>
               </a:ext>
             </a:extLst>
           </p:cNvPr>
@@ -8460,7 +8379,7 @@
           <p:cNvPr id="9" name="">
             <a:extLst xmlns:a="http://schemas.openxmlformats.org/drawingml/2006/main">
               <a:ext uri="{FF2B5EF4-FFF2-40B4-BE49-F238E27FC236}">
-                <a16:creationId xmlns:a16="http://schemas.microsoft.com/office/drawing/2014/main" id="{F386B5BE-6573-41C1-A0EF-DE81B7874FF7}"/>
+                <a16:creationId xmlns:a16="http://schemas.microsoft.com/office/drawing/2014/main" id="{5C33747B-1045-42BA-BD00-1BB8DF8D7BD0}"/>
               </a:ext>
             </a:extLst>
           </p:cNvPr>
@@ -8491,7 +8410,7 @@
           <p:cNvPr id="10" name="">
             <a:extLst xmlns:a="http://schemas.openxmlformats.org/drawingml/2006/main">
               <a:ext uri="{FF2B5EF4-FFF2-40B4-BE49-F238E27FC236}">
-                <a16:creationId xmlns:a16="http://schemas.microsoft.com/office/drawing/2014/main" id="{2BF3F3CE-BFEE-44DA-A755-673F61729158}"/>
+                <a16:creationId xmlns:a16="http://schemas.microsoft.com/office/drawing/2014/main" id="{49DFCB4C-34F0-406B-A5F0-F8E272F11E62}"/>
               </a:ext>
             </a:extLst>
           </p:cNvPr>
@@ -8549,7 +8468,7 @@
           <p:cNvPr id="11" name="">
             <a:extLst xmlns:a="http://schemas.openxmlformats.org/drawingml/2006/main">
               <a:ext uri="{FF2B5EF4-FFF2-40B4-BE49-F238E27FC236}">
-                <a16:creationId xmlns:a16="http://schemas.microsoft.com/office/drawing/2014/main" id="{6D5A07E4-BE63-4459-B4D6-225906489693}"/>
+                <a16:creationId xmlns:a16="http://schemas.microsoft.com/office/drawing/2014/main" id="{91ED92D3-6994-4E5E-8F83-175500801C03}"/>
               </a:ext>
             </a:extLst>
           </p:cNvPr>
@@ -8590,7 +8509,7 @@
           <p:cNvPr id="12" name="">
             <a:extLst xmlns:a="http://schemas.openxmlformats.org/drawingml/2006/main">
               <a:ext uri="{FF2B5EF4-FFF2-40B4-BE49-F238E27FC236}">
-                <a16:creationId xmlns:a16="http://schemas.microsoft.com/office/drawing/2014/main" id="{2BDEBA2F-0E94-4DB2-8891-AC2A0C043C39}"/>
+                <a16:creationId xmlns:a16="http://schemas.microsoft.com/office/drawing/2014/main" id="{7AA55CA3-57CF-4574-AF92-64AB5DB5C5CA}"/>
               </a:ext>
             </a:extLst>
           </p:cNvPr>
@@ -8648,7 +8567,7 @@
           <p:cNvPr id="13" name="">
             <a:extLst xmlns:a="http://schemas.openxmlformats.org/drawingml/2006/main">
               <a:ext uri="{FF2B5EF4-FFF2-40B4-BE49-F238E27FC236}">
-                <a16:creationId xmlns:a16="http://schemas.microsoft.com/office/drawing/2014/main" id="{4C6668FD-42EB-406E-9DFD-90D87AF4F931}"/>
+                <a16:creationId xmlns:a16="http://schemas.microsoft.com/office/drawing/2014/main" id="{C358762E-DC7E-4042-974A-1A3922481CFB}"/>
               </a:ext>
             </a:extLst>
           </p:cNvPr>
@@ -8706,7 +8625,7 @@
           <p:cNvPr id="14" name="">
             <a:extLst xmlns:a="http://schemas.openxmlformats.org/drawingml/2006/main">
               <a:ext uri="{FF2B5EF4-FFF2-40B4-BE49-F238E27FC236}">
-                <a16:creationId xmlns:a16="http://schemas.microsoft.com/office/drawing/2014/main" id="{7E922452-8B61-432F-98D3-D05343EEE566}"/>
+                <a16:creationId xmlns:a16="http://schemas.microsoft.com/office/drawing/2014/main" id="{874841AB-C649-4B54-B209-DB5231EE0DB3}"/>
               </a:ext>
             </a:extLst>
           </p:cNvPr>
@@ -8787,7 +8706,7 @@
           <p:cNvPr id="15" name="">
             <a:extLst xmlns:a="http://schemas.openxmlformats.org/drawingml/2006/main">
               <a:ext uri="{FF2B5EF4-FFF2-40B4-BE49-F238E27FC236}">
-                <a16:creationId xmlns:a16="http://schemas.microsoft.com/office/drawing/2014/main" id="{71B173D4-5C9D-4F02-AFCF-267161009036}"/>
+                <a16:creationId xmlns:a16="http://schemas.microsoft.com/office/drawing/2014/main" id="{C658D504-C34D-48FB-873A-19E33C1C8C72}"/>
               </a:ext>
             </a:extLst>
           </p:cNvPr>
@@ -8818,7 +8737,7 @@
           <p:cNvPr id="16" name="">
             <a:extLst xmlns:a="http://schemas.openxmlformats.org/drawingml/2006/main">
               <a:ext uri="{FF2B5EF4-FFF2-40B4-BE49-F238E27FC236}">
-                <a16:creationId xmlns:a16="http://schemas.microsoft.com/office/drawing/2014/main" id="{869F9477-7891-4E66-BAEB-7A2934AC2FC6}"/>
+                <a16:creationId xmlns:a16="http://schemas.microsoft.com/office/drawing/2014/main" id="{A81258F3-6DB7-4124-93F6-1D23346AF64C}"/>
               </a:ext>
             </a:extLst>
           </p:cNvPr>
@@ -8876,7 +8795,7 @@
           <p:cNvPr id="17" name="">
             <a:extLst xmlns:a="http://schemas.openxmlformats.org/drawingml/2006/main">
               <a:ext uri="{FF2B5EF4-FFF2-40B4-BE49-F238E27FC236}">
-                <a16:creationId xmlns:a16="http://schemas.microsoft.com/office/drawing/2014/main" id="{C2FF15ED-6AB2-413D-BC75-9A94E0A625C2}"/>
+                <a16:creationId xmlns:a16="http://schemas.microsoft.com/office/drawing/2014/main" id="{03C4106A-29EA-4C36-A9E1-733CCB301A96}"/>
               </a:ext>
             </a:extLst>
           </p:cNvPr>
@@ -8917,7 +8836,7 @@
           <p:cNvPr id="18" name="">
             <a:extLst xmlns:a="http://schemas.openxmlformats.org/drawingml/2006/main">
               <a:ext uri="{FF2B5EF4-FFF2-40B4-BE49-F238E27FC236}">
-                <a16:creationId xmlns:a16="http://schemas.microsoft.com/office/drawing/2014/main" id="{380E4B29-3BA2-4FCA-BD5B-015FD4F3F6CC}"/>
+                <a16:creationId xmlns:a16="http://schemas.microsoft.com/office/drawing/2014/main" id="{C40779D8-2496-4AC8-BBC4-A573037326F7}"/>
               </a:ext>
             </a:extLst>
           </p:cNvPr>
@@ -8975,7 +8894,7 @@
           <p:cNvPr id="19" name="">
             <a:extLst xmlns:a="http://schemas.openxmlformats.org/drawingml/2006/main">
               <a:ext uri="{FF2B5EF4-FFF2-40B4-BE49-F238E27FC236}">
-                <a16:creationId xmlns:a16="http://schemas.microsoft.com/office/drawing/2014/main" id="{DDF9B99E-59A1-4444-9FBB-52DDECED253B}"/>
+                <a16:creationId xmlns:a16="http://schemas.microsoft.com/office/drawing/2014/main" id="{19FAAB0B-0090-461A-BA17-5CC5318BE043}"/>
               </a:ext>
             </a:extLst>
           </p:cNvPr>
@@ -9033,7 +8952,7 @@
           <p:cNvPr id="20" name="">
             <a:extLst xmlns:a="http://schemas.openxmlformats.org/drawingml/2006/main">
               <a:ext uri="{FF2B5EF4-FFF2-40B4-BE49-F238E27FC236}">
-                <a16:creationId xmlns:a16="http://schemas.microsoft.com/office/drawing/2014/main" id="{47010983-4E48-4AEF-9AF6-3BE9795BAABF}"/>
+                <a16:creationId xmlns:a16="http://schemas.microsoft.com/office/drawing/2014/main" id="{C1C0BBD5-473B-4FF4-B8B0-DF9E307ED457}"/>
               </a:ext>
             </a:extLst>
           </p:cNvPr>
@@ -9114,7 +9033,7 @@
           <p:cNvPr id="21" name="">
             <a:extLst xmlns:a="http://schemas.openxmlformats.org/drawingml/2006/main">
               <a:ext uri="{FF2B5EF4-FFF2-40B4-BE49-F238E27FC236}">
-                <a16:creationId xmlns:a16="http://schemas.microsoft.com/office/drawing/2014/main" id="{93DCEDB8-9499-4682-AA2D-1C00F2E38FFA}"/>
+                <a16:creationId xmlns:a16="http://schemas.microsoft.com/office/drawing/2014/main" id="{AF65D358-CD8E-41BE-95E4-7B2C6E4390DB}"/>
               </a:ext>
             </a:extLst>
           </p:cNvPr>
@@ -9145,7 +9064,7 @@
           <p:cNvPr id="22" name="">
             <a:extLst xmlns:a="http://schemas.openxmlformats.org/drawingml/2006/main">
               <a:ext uri="{FF2B5EF4-FFF2-40B4-BE49-F238E27FC236}">
-                <a16:creationId xmlns:a16="http://schemas.microsoft.com/office/drawing/2014/main" id="{CC1CF89C-B70D-4E22-9479-602DC1F8261F}"/>
+                <a16:creationId xmlns:a16="http://schemas.microsoft.com/office/drawing/2014/main" id="{2C750455-FE84-4600-A685-D5A4C8B07EA3}"/>
               </a:ext>
             </a:extLst>
           </p:cNvPr>
@@ -9203,7 +9122,7 @@
           <p:cNvPr id="23" name="">
             <a:extLst xmlns:a="http://schemas.openxmlformats.org/drawingml/2006/main">
               <a:ext uri="{FF2B5EF4-FFF2-40B4-BE49-F238E27FC236}">
-                <a16:creationId xmlns:a16="http://schemas.microsoft.com/office/drawing/2014/main" id="{1BAA3E85-CB91-4835-8434-1539C007A5B5}"/>
+                <a16:creationId xmlns:a16="http://schemas.microsoft.com/office/drawing/2014/main" id="{8881A668-0093-4F38-BE3E-574ACA937555}"/>
               </a:ext>
             </a:extLst>
           </p:cNvPr>
@@ -9244,7 +9163,7 @@
           <p:cNvPr id="24" name="">
             <a:extLst xmlns:a="http://schemas.openxmlformats.org/drawingml/2006/main">
               <a:ext uri="{FF2B5EF4-FFF2-40B4-BE49-F238E27FC236}">
-                <a16:creationId xmlns:a16="http://schemas.microsoft.com/office/drawing/2014/main" id="{8FC4F036-4308-4710-9C8D-A87146E8FFF3}"/>
+                <a16:creationId xmlns:a16="http://schemas.microsoft.com/office/drawing/2014/main" id="{52C0564E-6CA3-4F26-A9AE-BC9A9C0D469D}"/>
               </a:ext>
             </a:extLst>
           </p:cNvPr>
@@ -9302,7 +9221,7 @@
           <p:cNvPr id="25" name="">
             <a:extLst xmlns:a="http://schemas.openxmlformats.org/drawingml/2006/main">
               <a:ext uri="{FF2B5EF4-FFF2-40B4-BE49-F238E27FC236}">
-                <a16:creationId xmlns:a16="http://schemas.microsoft.com/office/drawing/2014/main" id="{32CE5F7A-F34E-4CE3-AAAA-203C96812D4D}"/>
+                <a16:creationId xmlns:a16="http://schemas.microsoft.com/office/drawing/2014/main" id="{869AC3D8-4761-4A7A-B1BA-89F15DBF2D8F}"/>
               </a:ext>
             </a:extLst>
           </p:cNvPr>
@@ -9360,7 +9279,7 @@
           <p:cNvPr id="26" name="">
             <a:extLst xmlns:a="http://schemas.openxmlformats.org/drawingml/2006/main">
               <a:ext uri="{FF2B5EF4-FFF2-40B4-BE49-F238E27FC236}">
-                <a16:creationId xmlns:a16="http://schemas.microsoft.com/office/drawing/2014/main" id="{38FA4485-A783-4B5E-A0E8-A135E530F4A2}"/>
+                <a16:creationId xmlns:a16="http://schemas.microsoft.com/office/drawing/2014/main" id="{48DA0271-F682-4008-9C54-D71A2D4883F4}"/>
               </a:ext>
             </a:extLst>
           </p:cNvPr>
@@ -9441,7 +9360,7 @@
           <p:cNvPr id="27" name="">
             <a:extLst xmlns:a="http://schemas.openxmlformats.org/drawingml/2006/main">
               <a:ext uri="{FF2B5EF4-FFF2-40B4-BE49-F238E27FC236}">
-                <a16:creationId xmlns:a16="http://schemas.microsoft.com/office/drawing/2014/main" id="{0F4315E5-C10F-4410-85AC-D372DCC1F716}"/>
+                <a16:creationId xmlns:a16="http://schemas.microsoft.com/office/drawing/2014/main" id="{6BE6C158-E7FD-4B13-8F9F-B12A72BF885A}"/>
               </a:ext>
             </a:extLst>
           </p:cNvPr>
@@ -9472,7 +9391,7 @@
           <p:cNvPr id="28" name="">
             <a:extLst xmlns:a="http://schemas.openxmlformats.org/drawingml/2006/main">
               <a:ext uri="{FF2B5EF4-FFF2-40B4-BE49-F238E27FC236}">
-                <a16:creationId xmlns:a16="http://schemas.microsoft.com/office/drawing/2014/main" id="{C544C0F5-0EC6-4036-B11E-B1E633411F79}"/>
+                <a16:creationId xmlns:a16="http://schemas.microsoft.com/office/drawing/2014/main" id="{251251C9-481E-44D4-81D5-7DF4083ACD8F}"/>
               </a:ext>
             </a:extLst>
           </p:cNvPr>
@@ -9530,7 +9449,7 @@
           <p:cNvPr id="29" name="">
             <a:extLst xmlns:a="http://schemas.openxmlformats.org/drawingml/2006/main">
               <a:ext uri="{FF2B5EF4-FFF2-40B4-BE49-F238E27FC236}">
-                <a16:creationId xmlns:a16="http://schemas.microsoft.com/office/drawing/2014/main" id="{070F07AD-04B2-428D-A36F-782E50FB79B9}"/>
+                <a16:creationId xmlns:a16="http://schemas.microsoft.com/office/drawing/2014/main" id="{09366544-BB4E-41F8-9582-67AE0BDA16E7}"/>
               </a:ext>
             </a:extLst>
           </p:cNvPr>
@@ -9578,7 +9497,7 @@
                 <a:ea typeface="Aptos"/>
                 <a:cs typeface="Aptos"/>
               </a:rPr>
-              <a:t>If the examiner asks “what happens underneath?”, return to the request flow: validate → rank → normalize → persist → render.</a:t>
+              <a:t>Request flow: validate → rank → normalize → persist → render.</a:t>
             </a:r>
           </a:p>
         </p:txBody>
@@ -9588,7 +9507,7 @@
           <p:cNvPr id="30" name="">
             <a:extLst xmlns:a="http://schemas.openxmlformats.org/drawingml/2006/main">
               <a:ext uri="{FF2B5EF4-FFF2-40B4-BE49-F238E27FC236}">
-                <a16:creationId xmlns:a16="http://schemas.microsoft.com/office/drawing/2014/main" id="{92CAAC2A-FFCD-4679-AEF7-C00D7CABF13A}"/>
+                <a16:creationId xmlns:a16="http://schemas.microsoft.com/office/drawing/2014/main" id="{9F51B8FC-BEDB-44B2-9893-1C3A0FBEB199}"/>
               </a:ext>
             </a:extLst>
           </p:cNvPr>
@@ -9636,7 +9555,7 @@
                 <a:ea typeface="Aptos"/>
                 <a:cs typeface="Aptos"/>
               </a:rPr>
-              <a:t>SMARTCOURSE  /  FYP VIVA</a:t>
+              <a:t>SMARTCOURSE  /  PROJECT</a:t>
             </a:r>
           </a:p>
         </p:txBody>
@@ -9646,7 +9565,7 @@
           <p:cNvPr id="31" name="">
             <a:extLst xmlns:a="http://schemas.openxmlformats.org/drawingml/2006/main">
               <a:ext uri="{FF2B5EF4-FFF2-40B4-BE49-F238E27FC236}">
-                <a16:creationId xmlns:a16="http://schemas.microsoft.com/office/drawing/2014/main" id="{A3DF5B34-FBB0-4216-8087-BA8C26641777}"/>
+                <a16:creationId xmlns:a16="http://schemas.microsoft.com/office/drawing/2014/main" id="{58CD178F-3C3C-4DCF-A789-7A156F74F5FC}"/>
               </a:ext>
             </a:extLst>
           </p:cNvPr>
@@ -9702,7 +9621,7 @@
     </p:spTree>
     <p:extLst>
       <p:ext uri="{BB962C8B-B14F-4D97-AF65-F5344CB8AC3E}">
-        <p14:creationId xmlns:p14="http://schemas.microsoft.com/office/powerpoint/2010/main" val="678212524"/>
+        <p14:creationId xmlns:p14="http://schemas.microsoft.com/office/powerpoint/2010/main" val="666282378"/>
       </p:ext>
     </p:extLst>
   </p:cSld>
@@ -9744,7 +9663,7 @@
           <p:cNvPr id="16" name="">
             <a:extLst xmlns:a="http://schemas.openxmlformats.org/drawingml/2006/main">
               <a:ext uri="{FF2B5EF4-FFF2-40B4-BE49-F238E27FC236}">
-                <a16:creationId xmlns:a16="http://schemas.microsoft.com/office/drawing/2014/main" id="{51C8F63C-C5C8-4F05-B4AF-F00FA42A8901}"/>
+                <a16:creationId xmlns:a16="http://schemas.microsoft.com/office/drawing/2014/main" id="{E6F2797C-F109-446E-B6D2-D3297209C911}"/>
               </a:ext>
             </a:extLst>
           </p:cNvPr>
@@ -9802,7 +9721,7 @@
           <p:cNvPr id="2" name="">
             <a:extLst xmlns:a="http://schemas.openxmlformats.org/drawingml/2006/main">
               <a:ext uri="{FF2B5EF4-FFF2-40B4-BE49-F238E27FC236}">
-                <a16:creationId xmlns:a16="http://schemas.microsoft.com/office/drawing/2014/main" id="{734C12A7-9DB0-419B-8090-11175EF2AE90}"/>
+                <a16:creationId xmlns:a16="http://schemas.microsoft.com/office/drawing/2014/main" id="{D75AA80F-149D-496E-8BE6-9946B5BB1A6D}"/>
               </a:ext>
             </a:extLst>
           </p:cNvPr>
@@ -9883,7 +9802,7 @@
           <p:cNvPr id="3" name="">
             <a:extLst xmlns:a="http://schemas.openxmlformats.org/drawingml/2006/main">
               <a:ext uri="{FF2B5EF4-FFF2-40B4-BE49-F238E27FC236}">
-                <a16:creationId xmlns:a16="http://schemas.microsoft.com/office/drawing/2014/main" id="{DE3207CF-5271-4690-9BBD-6E2E243BCBCB}"/>
+                <a16:creationId xmlns:a16="http://schemas.microsoft.com/office/drawing/2014/main" id="{E6EF1FCB-1761-465A-AAD1-653066169395}"/>
               </a:ext>
             </a:extLst>
           </p:cNvPr>
@@ -9941,7 +9860,7 @@
           <p:cNvPr id="4" name="">
             <a:extLst xmlns:a="http://schemas.openxmlformats.org/drawingml/2006/main">
               <a:ext uri="{FF2B5EF4-FFF2-40B4-BE49-F238E27FC236}">
-                <a16:creationId xmlns:a16="http://schemas.microsoft.com/office/drawing/2014/main" id="{93A8650D-D2D3-4853-A736-CC1DD914E907}"/>
+                <a16:creationId xmlns:a16="http://schemas.microsoft.com/office/drawing/2014/main" id="{5E48E830-A0B3-4FB9-B604-4E06A29D0FBB}"/>
               </a:ext>
             </a:extLst>
           </p:cNvPr>
@@ -9972,7 +9891,7 @@
           <p:cNvPr id="5" name="">
             <a:extLst xmlns:a="http://schemas.openxmlformats.org/drawingml/2006/main">
               <a:ext uri="{FF2B5EF4-FFF2-40B4-BE49-F238E27FC236}">
-                <a16:creationId xmlns:a16="http://schemas.microsoft.com/office/drawing/2014/main" id="{59C70E21-57E1-46B1-911F-E75A21D76475}"/>
+                <a16:creationId xmlns:a16="http://schemas.microsoft.com/office/drawing/2014/main" id="{6CD1072B-F148-4428-9192-EA9EA96E7EA1}"/>
               </a:ext>
             </a:extLst>
           </p:cNvPr>
@@ -10030,7 +9949,7 @@
           <p:cNvPr id="6" name="">
             <a:extLst xmlns:a="http://schemas.openxmlformats.org/drawingml/2006/main">
               <a:ext uri="{FF2B5EF4-FFF2-40B4-BE49-F238E27FC236}">
-                <a16:creationId xmlns:a16="http://schemas.microsoft.com/office/drawing/2014/main" id="{4BBF38D7-2A1A-4366-913D-A635B492B145}"/>
+                <a16:creationId xmlns:a16="http://schemas.microsoft.com/office/drawing/2014/main" id="{9B30A229-27BB-4D1B-A544-B2847DE3FFC5}"/>
               </a:ext>
             </a:extLst>
           </p:cNvPr>
@@ -10088,7 +10007,7 @@
           <p:cNvPr id="7" name="">
             <a:extLst xmlns:a="http://schemas.openxmlformats.org/drawingml/2006/main">
               <a:ext uri="{FF2B5EF4-FFF2-40B4-BE49-F238E27FC236}">
-                <a16:creationId xmlns:a16="http://schemas.microsoft.com/office/drawing/2014/main" id="{C07BA1EF-9AEB-45A9-BD51-96F1FD523E11}"/>
+                <a16:creationId xmlns:a16="http://schemas.microsoft.com/office/drawing/2014/main" id="{78DBC9DD-CFFE-47F2-9281-8221660E10D3}"/>
               </a:ext>
             </a:extLst>
           </p:cNvPr>
@@ -10146,7 +10065,7 @@
           <p:cNvPr id="8" name="">
             <a:extLst xmlns:a="http://schemas.openxmlformats.org/drawingml/2006/main">
               <a:ext uri="{FF2B5EF4-FFF2-40B4-BE49-F238E27FC236}">
-                <a16:creationId xmlns:a16="http://schemas.microsoft.com/office/drawing/2014/main" id="{6E964991-2063-4DE9-A9DB-698E6855142F}"/>
+                <a16:creationId xmlns:a16="http://schemas.microsoft.com/office/drawing/2014/main" id="{10E20B24-BC70-47B5-932E-377307A3CA8D}"/>
               </a:ext>
             </a:extLst>
           </p:cNvPr>
@@ -10204,7 +10123,7 @@
           <p:cNvPr id="9" name="">
             <a:extLst xmlns:a="http://schemas.openxmlformats.org/drawingml/2006/main">
               <a:ext uri="{FF2B5EF4-FFF2-40B4-BE49-F238E27FC236}">
-                <a16:creationId xmlns:a16="http://schemas.microsoft.com/office/drawing/2014/main" id="{46273532-AEAB-4A28-8F7E-C6CEA6FFA924}"/>
+                <a16:creationId xmlns:a16="http://schemas.microsoft.com/office/drawing/2014/main" id="{5348D8FC-7266-4ECE-AB09-AFC4B1D5863E}"/>
               </a:ext>
             </a:extLst>
           </p:cNvPr>
@@ -10262,7 +10181,7 @@
           <p:cNvPr id="10" name="">
             <a:extLst xmlns:a="http://schemas.openxmlformats.org/drawingml/2006/main">
               <a:ext uri="{FF2B5EF4-FFF2-40B4-BE49-F238E27FC236}">
-                <a16:creationId xmlns:a16="http://schemas.microsoft.com/office/drawing/2014/main" id="{22B39361-0FA7-4765-B250-FFF5EC9DEB1A}"/>
+                <a16:creationId xmlns:a16="http://schemas.microsoft.com/office/drawing/2014/main" id="{4EF13248-8380-4F9B-AF11-7F8E2F864DAD}"/>
               </a:ext>
             </a:extLst>
           </p:cNvPr>
@@ -10320,7 +10239,7 @@
           <p:cNvPr id="11" name="">
             <a:extLst xmlns:a="http://schemas.openxmlformats.org/drawingml/2006/main">
               <a:ext uri="{FF2B5EF4-FFF2-40B4-BE49-F238E27FC236}">
-                <a16:creationId xmlns:a16="http://schemas.microsoft.com/office/drawing/2014/main" id="{D8805D19-5D60-46BB-BC07-4AB8F56B1EA6}"/>
+                <a16:creationId xmlns:a16="http://schemas.microsoft.com/office/drawing/2014/main" id="{F7B8699D-C9EE-4D24-AD1F-508481041F91}"/>
               </a:ext>
             </a:extLst>
           </p:cNvPr>
@@ -10361,7 +10280,7 @@
           <p:cNvPr id="12" name="">
             <a:extLst xmlns:a="http://schemas.openxmlformats.org/drawingml/2006/main">
               <a:ext uri="{FF2B5EF4-FFF2-40B4-BE49-F238E27FC236}">
-                <a16:creationId xmlns:a16="http://schemas.microsoft.com/office/drawing/2014/main" id="{B6105B8C-19F3-4B01-8C42-B22A7C8D3B92}"/>
+                <a16:creationId xmlns:a16="http://schemas.microsoft.com/office/drawing/2014/main" id="{EBDAF3A7-857E-4E20-A142-144A884D780D}"/>
               </a:ext>
             </a:extLst>
           </p:cNvPr>
@@ -10409,7 +10328,7 @@
                 <a:ea typeface="Aptos"/>
                 <a:cs typeface="Aptos"/>
               </a:rPr>
-              <a:t>QUESTIONS</a:t>
+              <a:t>DISCUSSION</a:t>
             </a:r>
           </a:p>
         </p:txBody>
@@ -10419,7 +10338,7 @@
           <p:cNvPr id="13" name="">
             <a:extLst xmlns:a="http://schemas.openxmlformats.org/drawingml/2006/main">
               <a:ext uri="{FF2B5EF4-FFF2-40B4-BE49-F238E27FC236}">
-                <a16:creationId xmlns:a16="http://schemas.microsoft.com/office/drawing/2014/main" id="{E0037538-2C7E-4B07-9FEE-B8C86473F16E}"/>
+                <a16:creationId xmlns:a16="http://schemas.microsoft.com/office/drawing/2014/main" id="{B6AAC136-482B-4586-A577-5657A1855212}"/>
               </a:ext>
             </a:extLst>
           </p:cNvPr>
@@ -10449,7 +10368,7 @@
           <a:lstStyle xmlns:a="http://schemas.openxmlformats.org/drawingml/2006/main"/>
           <a:p xmlns:a="http://schemas.openxmlformats.org/drawingml/2006/main">
             <a:pPr algn="ctr">
-              <a:defRPr sz="1650" b="1">
+              <a:defRPr sz="1500" b="1">
                 <a:solidFill>
                   <a:srgbClr val="F5F8FC"/>
                 </a:solidFill>
@@ -10459,7 +10378,7 @@
               </a:defRPr>
             </a:pPr>
             <a:r>
-              <a:rPr sz="1650" b="1">
+              <a:rPr sz="1500" b="1">
                 <a:solidFill>
                   <a:srgbClr val="F5F8FC"/>
                 </a:solidFill>
@@ -10467,7 +10386,7 @@
                 <a:ea typeface="Aptos"/>
                 <a:cs typeface="Aptos"/>
               </a:rPr>
-              <a:t>Thank you</a:t>
+              <a:t>Questions and feedback</a:t>
             </a:r>
           </a:p>
         </p:txBody>
@@ -10477,7 +10396,7 @@
           <p:cNvPr id="14" name="">
             <a:extLst xmlns:a="http://schemas.openxmlformats.org/drawingml/2006/main">
               <a:ext uri="{FF2B5EF4-FFF2-40B4-BE49-F238E27FC236}">
-                <a16:creationId xmlns:a16="http://schemas.microsoft.com/office/drawing/2014/main" id="{B1F0ED79-3AF3-4AEF-A71E-EFEB483B9DE3}"/>
+                <a16:creationId xmlns:a16="http://schemas.microsoft.com/office/drawing/2014/main" id="{53D7EC17-ADB3-431F-97B4-60B73609D4A0}"/>
               </a:ext>
             </a:extLst>
           </p:cNvPr>
@@ -10535,7 +10454,7 @@
           <p:cNvPr id="15" name="">
             <a:extLst xmlns:a="http://schemas.openxmlformats.org/drawingml/2006/main">
               <a:ext uri="{FF2B5EF4-FFF2-40B4-BE49-F238E27FC236}">
-                <a16:creationId xmlns:a16="http://schemas.microsoft.com/office/drawing/2014/main" id="{8B3E7A98-17F0-47AB-B1E6-9AF921CE3C44}"/>
+                <a16:creationId xmlns:a16="http://schemas.microsoft.com/office/drawing/2014/main" id="{5639D335-2575-4730-8BCE-E7CE0DDEA446}"/>
               </a:ext>
             </a:extLst>
           </p:cNvPr>
@@ -10591,7 +10510,7 @@
     </p:spTree>
     <p:extLst>
       <p:ext uri="{BB962C8B-B14F-4D97-AF65-F5344CB8AC3E}">
-        <p14:creationId xmlns:p14="http://schemas.microsoft.com/office/powerpoint/2010/main" val="690990132"/>
+        <p14:creationId xmlns:p14="http://schemas.microsoft.com/office/powerpoint/2010/main" val="1785432439"/>
       </p:ext>
     </p:extLst>
   </p:cSld>
@@ -10622,7 +10541,7 @@
           <p:cNvPr id="24" name="kicker">
             <a:extLst xmlns:a="http://schemas.openxmlformats.org/drawingml/2006/main">
               <a:ext uri="{FF2B5EF4-FFF2-40B4-BE49-F238E27FC236}">
-                <a16:creationId xmlns:a16="http://schemas.microsoft.com/office/drawing/2014/main" id="{D36DDE56-AB2B-4D6C-917D-E0546F75314A}"/>
+                <a16:creationId xmlns:a16="http://schemas.microsoft.com/office/drawing/2014/main" id="{9642699B-7BC6-4367-B3DC-CE366A6D188C}"/>
               </a:ext>
             </a:extLst>
           </p:cNvPr>
@@ -10680,7 +10599,7 @@
           <p:cNvPr id="2" name="title">
             <a:extLst xmlns:a="http://schemas.openxmlformats.org/drawingml/2006/main">
               <a:ext uri="{FF2B5EF4-FFF2-40B4-BE49-F238E27FC236}">
-                <a16:creationId xmlns:a16="http://schemas.microsoft.com/office/drawing/2014/main" id="{D2699E44-45B9-484A-95CF-34F7803AA962}"/>
+                <a16:creationId xmlns:a16="http://schemas.microsoft.com/office/drawing/2014/main" id="{A312C32C-AF73-479E-A159-F677FE18A9A2}"/>
               </a:ext>
             </a:extLst>
           </p:cNvPr>
@@ -10738,7 +10657,7 @@
           <p:cNvPr id="3" name="subtitle">
             <a:extLst xmlns:a="http://schemas.openxmlformats.org/drawingml/2006/main">
               <a:ext uri="{FF2B5EF4-FFF2-40B4-BE49-F238E27FC236}">
-                <a16:creationId xmlns:a16="http://schemas.microsoft.com/office/drawing/2014/main" id="{D49DFD5D-81B4-472A-BC25-828FD6CA54FC}"/>
+                <a16:creationId xmlns:a16="http://schemas.microsoft.com/office/drawing/2014/main" id="{BE82033C-CAF4-4F7B-8459-DFC6B2AEE50E}"/>
               </a:ext>
             </a:extLst>
           </p:cNvPr>
@@ -10796,7 +10715,7 @@
           <p:cNvPr id="4" name="">
             <a:extLst xmlns:a="http://schemas.openxmlformats.org/drawingml/2006/main">
               <a:ext uri="{FF2B5EF4-FFF2-40B4-BE49-F238E27FC236}">
-                <a16:creationId xmlns:a16="http://schemas.microsoft.com/office/drawing/2014/main" id="{42767614-080E-46E1-8E34-DF28B09D8952}"/>
+                <a16:creationId xmlns:a16="http://schemas.microsoft.com/office/drawing/2014/main" id="{3780600D-36C6-4339-A33D-EB5D14F00316}"/>
               </a:ext>
             </a:extLst>
           </p:cNvPr>
@@ -10827,7 +10746,7 @@
           <p:cNvPr id="5" name="">
             <a:extLst xmlns:a="http://schemas.openxmlformats.org/drawingml/2006/main">
               <a:ext uri="{FF2B5EF4-FFF2-40B4-BE49-F238E27FC236}">
-                <a16:creationId xmlns:a16="http://schemas.microsoft.com/office/drawing/2014/main" id="{F642C925-8E5C-43F3-8BF0-42A0BA871845}"/>
+                <a16:creationId xmlns:a16="http://schemas.microsoft.com/office/drawing/2014/main" id="{70A1D7D6-A1DE-4076-ABC9-1D34ECA3860D}"/>
               </a:ext>
             </a:extLst>
           </p:cNvPr>
@@ -10885,7 +10804,7 @@
           <p:cNvPr id="6" name="">
             <a:extLst xmlns:a="http://schemas.openxmlformats.org/drawingml/2006/main">
               <a:ext uri="{FF2B5EF4-FFF2-40B4-BE49-F238E27FC236}">
-                <a16:creationId xmlns:a16="http://schemas.microsoft.com/office/drawing/2014/main" id="{A136B932-B336-42DF-BF5E-09275F267602}"/>
+                <a16:creationId xmlns:a16="http://schemas.microsoft.com/office/drawing/2014/main" id="{E07F7FA3-3834-485E-B0D4-E007622DBE6F}"/>
               </a:ext>
             </a:extLst>
           </p:cNvPr>
@@ -10943,7 +10862,7 @@
           <p:cNvPr id="7" name="">
             <a:extLst xmlns:a="http://schemas.openxmlformats.org/drawingml/2006/main">
               <a:ext uri="{FF2B5EF4-FFF2-40B4-BE49-F238E27FC236}">
-                <a16:creationId xmlns:a16="http://schemas.microsoft.com/office/drawing/2014/main" id="{C915BDA0-DE02-45AD-AF40-088357C9677C}"/>
+                <a16:creationId xmlns:a16="http://schemas.microsoft.com/office/drawing/2014/main" id="{53E65934-AA9B-4C71-8A20-4099FA628D1E}"/>
               </a:ext>
             </a:extLst>
           </p:cNvPr>
@@ -11005,7 +10924,7 @@
           <p:cNvPr id="8" name="">
             <a:extLst xmlns:a="http://schemas.openxmlformats.org/drawingml/2006/main">
               <a:ext uri="{FF2B5EF4-FFF2-40B4-BE49-F238E27FC236}">
-                <a16:creationId xmlns:a16="http://schemas.microsoft.com/office/drawing/2014/main" id="{888C0D2A-ADE8-4514-B729-81E01391CF9B}"/>
+                <a16:creationId xmlns:a16="http://schemas.microsoft.com/office/drawing/2014/main" id="{CCD620DF-F442-494C-90CD-DE16F28B6D53}"/>
               </a:ext>
             </a:extLst>
           </p:cNvPr>
@@ -11046,7 +10965,7 @@
           <p:cNvPr id="9" name="">
             <a:extLst xmlns:a="http://schemas.openxmlformats.org/drawingml/2006/main">
               <a:ext uri="{FF2B5EF4-FFF2-40B4-BE49-F238E27FC236}">
-                <a16:creationId xmlns:a16="http://schemas.microsoft.com/office/drawing/2014/main" id="{DEC0A577-AA59-4D47-B312-4F26D083D057}"/>
+                <a16:creationId xmlns:a16="http://schemas.microsoft.com/office/drawing/2014/main" id="{4EDDBD11-005E-4F50-A443-743978506DF3}"/>
               </a:ext>
             </a:extLst>
           </p:cNvPr>
@@ -11127,7 +11046,7 @@
           <p:cNvPr id="10" name="">
             <a:extLst xmlns:a="http://schemas.openxmlformats.org/drawingml/2006/main">
               <a:ext uri="{FF2B5EF4-FFF2-40B4-BE49-F238E27FC236}">
-                <a16:creationId xmlns:a16="http://schemas.microsoft.com/office/drawing/2014/main" id="{A8938B38-0983-404C-AE4F-6C5C3DAAD141}"/>
+                <a16:creationId xmlns:a16="http://schemas.microsoft.com/office/drawing/2014/main" id="{BEC39C29-5BCB-4E46-A059-F1CD74EBF64C}"/>
               </a:ext>
             </a:extLst>
           </p:cNvPr>
@@ -11189,7 +11108,7 @@
           <p:cNvPr id="11" name="">
             <a:extLst xmlns:a="http://schemas.openxmlformats.org/drawingml/2006/main">
               <a:ext uri="{FF2B5EF4-FFF2-40B4-BE49-F238E27FC236}">
-                <a16:creationId xmlns:a16="http://schemas.microsoft.com/office/drawing/2014/main" id="{BAEDF535-F68C-497E-8677-9D3E6F5814EE}"/>
+                <a16:creationId xmlns:a16="http://schemas.microsoft.com/office/drawing/2014/main" id="{62963248-A508-4B4D-B8F7-9B57EAE3EFDB}"/>
               </a:ext>
             </a:extLst>
           </p:cNvPr>
@@ -11247,7 +11166,7 @@
           <p:cNvPr id="12" name="">
             <a:extLst xmlns:a="http://schemas.openxmlformats.org/drawingml/2006/main">
               <a:ext uri="{FF2B5EF4-FFF2-40B4-BE49-F238E27FC236}">
-                <a16:creationId xmlns:a16="http://schemas.microsoft.com/office/drawing/2014/main" id="{CA450D6D-18EA-4946-AAC8-1D3DA42098DA}"/>
+                <a16:creationId xmlns:a16="http://schemas.microsoft.com/office/drawing/2014/main" id="{554495D7-C0F9-43D6-830C-F1173AB6CAB9}"/>
               </a:ext>
             </a:extLst>
           </p:cNvPr>
@@ -11305,7 +11224,7 @@
           <p:cNvPr id="13" name="">
             <a:extLst xmlns:a="http://schemas.openxmlformats.org/drawingml/2006/main">
               <a:ext uri="{FF2B5EF4-FFF2-40B4-BE49-F238E27FC236}">
-                <a16:creationId xmlns:a16="http://schemas.microsoft.com/office/drawing/2014/main" id="{35B11C8A-2A46-4DAA-82D6-E210148DB257}"/>
+                <a16:creationId xmlns:a16="http://schemas.microsoft.com/office/drawing/2014/main" id="{953FA78E-5FCE-4774-BE7B-52101B610595}"/>
               </a:ext>
             </a:extLst>
           </p:cNvPr>
@@ -11363,7 +11282,7 @@
           <p:cNvPr id="14" name="">
             <a:extLst xmlns:a="http://schemas.openxmlformats.org/drawingml/2006/main">
               <a:ext uri="{FF2B5EF4-FFF2-40B4-BE49-F238E27FC236}">
-                <a16:creationId xmlns:a16="http://schemas.microsoft.com/office/drawing/2014/main" id="{87B6A614-C056-42D6-9193-5CA0B2E595DE}"/>
+                <a16:creationId xmlns:a16="http://schemas.microsoft.com/office/drawing/2014/main" id="{0A63172C-95C4-41AA-AD3D-A267198D5936}"/>
               </a:ext>
             </a:extLst>
           </p:cNvPr>
@@ -11394,7 +11313,7 @@
           <p:cNvPr id="15" name="">
             <a:extLst xmlns:a="http://schemas.openxmlformats.org/drawingml/2006/main">
               <a:ext uri="{FF2B5EF4-FFF2-40B4-BE49-F238E27FC236}">
-                <a16:creationId xmlns:a16="http://schemas.microsoft.com/office/drawing/2014/main" id="{F2E59845-C231-4C69-B80A-C0E4578D32AD}"/>
+                <a16:creationId xmlns:a16="http://schemas.microsoft.com/office/drawing/2014/main" id="{0452FDEB-B51F-4C6A-8272-3BE2276452DE}"/>
               </a:ext>
             </a:extLst>
           </p:cNvPr>
@@ -11452,7 +11371,7 @@
           <p:cNvPr id="16" name="">
             <a:extLst xmlns:a="http://schemas.openxmlformats.org/drawingml/2006/main">
               <a:ext uri="{FF2B5EF4-FFF2-40B4-BE49-F238E27FC236}">
-                <a16:creationId xmlns:a16="http://schemas.microsoft.com/office/drawing/2014/main" id="{3D54E6A5-2F96-4D82-9FF5-F59AEFC76064}"/>
+                <a16:creationId xmlns:a16="http://schemas.microsoft.com/office/drawing/2014/main" id="{6A168FD4-9FB6-4924-8C15-F97628AC09C8}"/>
               </a:ext>
             </a:extLst>
           </p:cNvPr>
@@ -11510,7 +11429,7 @@
           <p:cNvPr id="17" name="">
             <a:extLst xmlns:a="http://schemas.openxmlformats.org/drawingml/2006/main">
               <a:ext uri="{FF2B5EF4-FFF2-40B4-BE49-F238E27FC236}">
-                <a16:creationId xmlns:a16="http://schemas.microsoft.com/office/drawing/2014/main" id="{993D3F6E-3D2D-400D-B7B2-A86C8371B514}"/>
+                <a16:creationId xmlns:a16="http://schemas.microsoft.com/office/drawing/2014/main" id="{41FEFCD2-0289-4A1A-ACC7-637358F986DB}"/>
               </a:ext>
             </a:extLst>
           </p:cNvPr>
@@ -11568,7 +11487,7 @@
           <p:cNvPr id="18" name="">
             <a:extLst xmlns:a="http://schemas.openxmlformats.org/drawingml/2006/main">
               <a:ext uri="{FF2B5EF4-FFF2-40B4-BE49-F238E27FC236}">
-                <a16:creationId xmlns:a16="http://schemas.microsoft.com/office/drawing/2014/main" id="{F7A464C6-67B9-46C3-9471-396BD13946E0}"/>
+                <a16:creationId xmlns:a16="http://schemas.microsoft.com/office/drawing/2014/main" id="{31E3AEE3-4FA5-4B3C-AC1C-8A844954BD4D}"/>
               </a:ext>
             </a:extLst>
           </p:cNvPr>
@@ -11599,7 +11518,7 @@
           <p:cNvPr id="19" name="">
             <a:extLst xmlns:a="http://schemas.openxmlformats.org/drawingml/2006/main">
               <a:ext uri="{FF2B5EF4-FFF2-40B4-BE49-F238E27FC236}">
-                <a16:creationId xmlns:a16="http://schemas.microsoft.com/office/drawing/2014/main" id="{B08A7C09-9528-44C8-88FA-82623E02D74E}"/>
+                <a16:creationId xmlns:a16="http://schemas.microsoft.com/office/drawing/2014/main" id="{451CD5AA-DB25-4C6D-9E5C-22F07D8F425E}"/>
               </a:ext>
             </a:extLst>
           </p:cNvPr>
@@ -11657,7 +11576,7 @@
           <p:cNvPr id="20" name="">
             <a:extLst xmlns:a="http://schemas.openxmlformats.org/drawingml/2006/main">
               <a:ext uri="{FF2B5EF4-FFF2-40B4-BE49-F238E27FC236}">
-                <a16:creationId xmlns:a16="http://schemas.microsoft.com/office/drawing/2014/main" id="{6D9E5070-CCD7-4945-A5E6-1D95F74731CB}"/>
+                <a16:creationId xmlns:a16="http://schemas.microsoft.com/office/drawing/2014/main" id="{42499B5E-5517-4293-BDAA-724D49618BE4}"/>
               </a:ext>
             </a:extLst>
           </p:cNvPr>
@@ -11715,7 +11634,7 @@
           <p:cNvPr id="21" name="">
             <a:extLst xmlns:a="http://schemas.openxmlformats.org/drawingml/2006/main">
               <a:ext uri="{FF2B5EF4-FFF2-40B4-BE49-F238E27FC236}">
-                <a16:creationId xmlns:a16="http://schemas.microsoft.com/office/drawing/2014/main" id="{097AC1E0-09CD-4E9A-9391-A9549381BF5B}"/>
+                <a16:creationId xmlns:a16="http://schemas.microsoft.com/office/drawing/2014/main" id="{900F5268-DED6-40DA-A28A-EC6840DCE373}"/>
               </a:ext>
             </a:extLst>
           </p:cNvPr>
@@ -11773,7 +11692,7 @@
           <p:cNvPr id="22" name="">
             <a:extLst xmlns:a="http://schemas.openxmlformats.org/drawingml/2006/main">
               <a:ext uri="{FF2B5EF4-FFF2-40B4-BE49-F238E27FC236}">
-                <a16:creationId xmlns:a16="http://schemas.microsoft.com/office/drawing/2014/main" id="{ED9DEA55-82B5-488C-A1FC-E446A3241A04}"/>
+                <a16:creationId xmlns:a16="http://schemas.microsoft.com/office/drawing/2014/main" id="{17B1A0CE-5441-45A2-A3E8-5D322C20CC0D}"/>
               </a:ext>
             </a:extLst>
           </p:cNvPr>
@@ -11821,7 +11740,7 @@
                 <a:ea typeface="Aptos"/>
                 <a:cs typeface="Aptos"/>
               </a:rPr>
-              <a:t>SMARTCOURSE  /  FYP VIVA</a:t>
+              <a:t>SMARTCOURSE  /  PROJECT</a:t>
             </a:r>
           </a:p>
         </p:txBody>
@@ -11831,7 +11750,7 @@
           <p:cNvPr id="23" name="">
             <a:extLst xmlns:a="http://schemas.openxmlformats.org/drawingml/2006/main">
               <a:ext uri="{FF2B5EF4-FFF2-40B4-BE49-F238E27FC236}">
-                <a16:creationId xmlns:a16="http://schemas.microsoft.com/office/drawing/2014/main" id="{A9525D95-F28E-47A0-A0C5-24C8E7363A3A}"/>
+                <a16:creationId xmlns:a16="http://schemas.microsoft.com/office/drawing/2014/main" id="{39B050D8-56BB-4A81-90E0-E5CEBEF0F42D}"/>
               </a:ext>
             </a:extLst>
           </p:cNvPr>
@@ -11887,7 +11806,7 @@
     </p:spTree>
     <p:extLst>
       <p:ext uri="{BB962C8B-B14F-4D97-AF65-F5344CB8AC3E}">
-        <p14:creationId xmlns:p14="http://schemas.microsoft.com/office/powerpoint/2010/main" val="1961839307"/>
+        <p14:creationId xmlns:p14="http://schemas.microsoft.com/office/powerpoint/2010/main" val="611993391"/>
       </p:ext>
     </p:extLst>
   </p:cSld>
@@ -11918,7 +11837,7 @@
           <p:cNvPr id="28" name="kicker">
             <a:extLst xmlns:a="http://schemas.openxmlformats.org/drawingml/2006/main">
               <a:ext uri="{FF2B5EF4-FFF2-40B4-BE49-F238E27FC236}">
-                <a16:creationId xmlns:a16="http://schemas.microsoft.com/office/drawing/2014/main" id="{9275B23A-8E53-48A2-8D7F-D4B246D73DC1}"/>
+                <a16:creationId xmlns:a16="http://schemas.microsoft.com/office/drawing/2014/main" id="{0D4D0099-D18C-4C16-9D9C-75648903EF37}"/>
               </a:ext>
             </a:extLst>
           </p:cNvPr>
@@ -11976,7 +11895,7 @@
           <p:cNvPr id="2" name="title">
             <a:extLst xmlns:a="http://schemas.openxmlformats.org/drawingml/2006/main">
               <a:ext uri="{FF2B5EF4-FFF2-40B4-BE49-F238E27FC236}">
-                <a16:creationId xmlns:a16="http://schemas.microsoft.com/office/drawing/2014/main" id="{ECC05B72-2E6F-4B02-BE22-C25CAAC90E16}"/>
+                <a16:creationId xmlns:a16="http://schemas.microsoft.com/office/drawing/2014/main" id="{B3ACEE3D-9115-46C1-8DF8-C9A4D1065EEA}"/>
               </a:ext>
             </a:extLst>
           </p:cNvPr>
@@ -12034,7 +11953,7 @@
           <p:cNvPr id="3" name="subtitle">
             <a:extLst xmlns:a="http://schemas.openxmlformats.org/drawingml/2006/main">
               <a:ext uri="{FF2B5EF4-FFF2-40B4-BE49-F238E27FC236}">
-                <a16:creationId xmlns:a16="http://schemas.microsoft.com/office/drawing/2014/main" id="{9A9BC14C-BE1E-4C21-9681-49E530B62DCA}"/>
+                <a16:creationId xmlns:a16="http://schemas.microsoft.com/office/drawing/2014/main" id="{2B9E109F-3DFC-427F-9B7C-42F77A1E7680}"/>
               </a:ext>
             </a:extLst>
           </p:cNvPr>
@@ -12092,7 +12011,7 @@
           <p:cNvPr id="4" name="">
             <a:extLst xmlns:a="http://schemas.openxmlformats.org/drawingml/2006/main">
               <a:ext uri="{FF2B5EF4-FFF2-40B4-BE49-F238E27FC236}">
-                <a16:creationId xmlns:a16="http://schemas.microsoft.com/office/drawing/2014/main" id="{9C1B7971-7E5D-48B6-AFC2-C4B2B78EDB30}"/>
+                <a16:creationId xmlns:a16="http://schemas.microsoft.com/office/drawing/2014/main" id="{3D6B8728-8DBD-458D-8EAB-F5985C54AA51}"/>
               </a:ext>
             </a:extLst>
           </p:cNvPr>
@@ -12123,7 +12042,7 @@
           <p:cNvPr id="5" name="">
             <a:extLst xmlns:a="http://schemas.openxmlformats.org/drawingml/2006/main">
               <a:ext uri="{FF2B5EF4-FFF2-40B4-BE49-F238E27FC236}">
-                <a16:creationId xmlns:a16="http://schemas.microsoft.com/office/drawing/2014/main" id="{A4E3D7BA-46D7-4F71-9A7D-14F59EAAB510}"/>
+                <a16:creationId xmlns:a16="http://schemas.microsoft.com/office/drawing/2014/main" id="{F0A36383-FE80-49DE-BE70-85B933384FD7}"/>
               </a:ext>
             </a:extLst>
           </p:cNvPr>
@@ -12181,7 +12100,7 @@
           <p:cNvPr id="6" name="">
             <a:extLst xmlns:a="http://schemas.openxmlformats.org/drawingml/2006/main">
               <a:ext uri="{FF2B5EF4-FFF2-40B4-BE49-F238E27FC236}">
-                <a16:creationId xmlns:a16="http://schemas.microsoft.com/office/drawing/2014/main" id="{3992A01A-0C4E-4B0A-B193-D0B4C420EC69}"/>
+                <a16:creationId xmlns:a16="http://schemas.microsoft.com/office/drawing/2014/main" id="{CB6A2BFD-78F1-43F2-B38A-EF015DAB8AA3}"/>
               </a:ext>
             </a:extLst>
           </p:cNvPr>
@@ -12222,7 +12141,7 @@
           <p:cNvPr id="7" name="">
             <a:extLst xmlns:a="http://schemas.openxmlformats.org/drawingml/2006/main">
               <a:ext uri="{FF2B5EF4-FFF2-40B4-BE49-F238E27FC236}">
-                <a16:creationId xmlns:a16="http://schemas.microsoft.com/office/drawing/2014/main" id="{1BCB0A47-9ED2-4F29-AABF-4488997A76B5}"/>
+                <a16:creationId xmlns:a16="http://schemas.microsoft.com/office/drawing/2014/main" id="{B0159E5B-A603-4966-8829-A6372B65BD20}"/>
               </a:ext>
             </a:extLst>
           </p:cNvPr>
@@ -12303,7 +12222,7 @@
           <p:cNvPr id="8" name="">
             <a:extLst xmlns:a="http://schemas.openxmlformats.org/drawingml/2006/main">
               <a:ext uri="{FF2B5EF4-FFF2-40B4-BE49-F238E27FC236}">
-                <a16:creationId xmlns:a16="http://schemas.microsoft.com/office/drawing/2014/main" id="{41593B5B-16AC-48DE-B584-604294995084}"/>
+                <a16:creationId xmlns:a16="http://schemas.microsoft.com/office/drawing/2014/main" id="{AC904CAB-AF28-4C55-AE67-FB416B28F3B4}"/>
               </a:ext>
             </a:extLst>
           </p:cNvPr>
@@ -12334,7 +12253,7 @@
           <p:cNvPr id="9" name="">
             <a:extLst xmlns:a="http://schemas.openxmlformats.org/drawingml/2006/main">
               <a:ext uri="{FF2B5EF4-FFF2-40B4-BE49-F238E27FC236}">
-                <a16:creationId xmlns:a16="http://schemas.microsoft.com/office/drawing/2014/main" id="{666CFA14-D2DC-4529-A860-47AD86CBB64D}"/>
+                <a16:creationId xmlns:a16="http://schemas.microsoft.com/office/drawing/2014/main" id="{699999AC-3AD9-4698-9086-9DBEBC57A349}"/>
               </a:ext>
             </a:extLst>
           </p:cNvPr>
@@ -12392,7 +12311,7 @@
           <p:cNvPr id="10" name="">
             <a:extLst xmlns:a="http://schemas.openxmlformats.org/drawingml/2006/main">
               <a:ext uri="{FF2B5EF4-FFF2-40B4-BE49-F238E27FC236}">
-                <a16:creationId xmlns:a16="http://schemas.microsoft.com/office/drawing/2014/main" id="{AFE706BC-C752-4786-BB3B-3C496ECABBC2}"/>
+                <a16:creationId xmlns:a16="http://schemas.microsoft.com/office/drawing/2014/main" id="{281A5A12-40AB-4A0B-B639-C4D68638E3D9}"/>
               </a:ext>
             </a:extLst>
           </p:cNvPr>
@@ -12433,7 +12352,7 @@
           <p:cNvPr id="11" name="">
             <a:extLst xmlns:a="http://schemas.openxmlformats.org/drawingml/2006/main">
               <a:ext uri="{FF2B5EF4-FFF2-40B4-BE49-F238E27FC236}">
-                <a16:creationId xmlns:a16="http://schemas.microsoft.com/office/drawing/2014/main" id="{B0DE8466-BB15-41CB-9FE7-811CF889A572}"/>
+                <a16:creationId xmlns:a16="http://schemas.microsoft.com/office/drawing/2014/main" id="{16B5AFC9-D7CA-455C-8F01-2732ADD63D5A}"/>
               </a:ext>
             </a:extLst>
           </p:cNvPr>
@@ -12491,7 +12410,7 @@
           <p:cNvPr id="12" name="">
             <a:extLst xmlns:a="http://schemas.openxmlformats.org/drawingml/2006/main">
               <a:ext uri="{FF2B5EF4-FFF2-40B4-BE49-F238E27FC236}">
-                <a16:creationId xmlns:a16="http://schemas.microsoft.com/office/drawing/2014/main" id="{9A1C0B7B-09EB-4AE6-B646-4FC2C92E7051}"/>
+                <a16:creationId xmlns:a16="http://schemas.microsoft.com/office/drawing/2014/main" id="{C2DDE416-16DF-4FBC-9BE3-40A08AFF0F9E}"/>
               </a:ext>
             </a:extLst>
           </p:cNvPr>
@@ -12549,7 +12468,7 @@
           <p:cNvPr id="13" name="">
             <a:extLst xmlns:a="http://schemas.openxmlformats.org/drawingml/2006/main">
               <a:ext uri="{FF2B5EF4-FFF2-40B4-BE49-F238E27FC236}">
-                <a16:creationId xmlns:a16="http://schemas.microsoft.com/office/drawing/2014/main" id="{9102AD36-3CE9-4AC5-AEB5-92C9F88D1526}"/>
+                <a16:creationId xmlns:a16="http://schemas.microsoft.com/office/drawing/2014/main" id="{0768236E-2D07-4230-8D26-06E72F9B3B69}"/>
               </a:ext>
             </a:extLst>
           </p:cNvPr>
@@ -12590,7 +12509,7 @@
           <p:cNvPr id="14" name="">
             <a:extLst xmlns:a="http://schemas.openxmlformats.org/drawingml/2006/main">
               <a:ext uri="{FF2B5EF4-FFF2-40B4-BE49-F238E27FC236}">
-                <a16:creationId xmlns:a16="http://schemas.microsoft.com/office/drawing/2014/main" id="{A9CF9EA1-1972-4623-8C93-D27CA5ACB733}"/>
+                <a16:creationId xmlns:a16="http://schemas.microsoft.com/office/drawing/2014/main" id="{E6E0FEEC-EBBB-4905-80FB-E2F9AD9552CA}"/>
               </a:ext>
             </a:extLst>
           </p:cNvPr>
@@ -12648,7 +12567,7 @@
           <p:cNvPr id="15" name="">
             <a:extLst xmlns:a="http://schemas.openxmlformats.org/drawingml/2006/main">
               <a:ext uri="{FF2B5EF4-FFF2-40B4-BE49-F238E27FC236}">
-                <a16:creationId xmlns:a16="http://schemas.microsoft.com/office/drawing/2014/main" id="{758C9FD3-AEFB-40EE-89E0-4373F79A1286}"/>
+                <a16:creationId xmlns:a16="http://schemas.microsoft.com/office/drawing/2014/main" id="{77DA1E49-1532-406C-BDC8-6BEF20E29150}"/>
               </a:ext>
             </a:extLst>
           </p:cNvPr>
@@ -12706,7 +12625,7 @@
           <p:cNvPr id="16" name="">
             <a:extLst xmlns:a="http://schemas.openxmlformats.org/drawingml/2006/main">
               <a:ext uri="{FF2B5EF4-FFF2-40B4-BE49-F238E27FC236}">
-                <a16:creationId xmlns:a16="http://schemas.microsoft.com/office/drawing/2014/main" id="{7F505AD3-8143-4DF0-82D9-2A381B44D487}"/>
+                <a16:creationId xmlns:a16="http://schemas.microsoft.com/office/drawing/2014/main" id="{A007822E-7C67-4432-907B-6A53AF39DE58}"/>
               </a:ext>
             </a:extLst>
           </p:cNvPr>
@@ -12737,7 +12656,7 @@
           <p:cNvPr id="17" name="">
             <a:extLst xmlns:a="http://schemas.openxmlformats.org/drawingml/2006/main">
               <a:ext uri="{FF2B5EF4-FFF2-40B4-BE49-F238E27FC236}">
-                <a16:creationId xmlns:a16="http://schemas.microsoft.com/office/drawing/2014/main" id="{BD3DABD2-140D-45BC-A83F-1FC6D4926E1A}"/>
+                <a16:creationId xmlns:a16="http://schemas.microsoft.com/office/drawing/2014/main" id="{58682BAC-8D99-4CC1-B0BC-2BF4A75B3CBF}"/>
               </a:ext>
             </a:extLst>
           </p:cNvPr>
@@ -12795,7 +12714,7 @@
           <p:cNvPr id="18" name="">
             <a:extLst xmlns:a="http://schemas.openxmlformats.org/drawingml/2006/main">
               <a:ext uri="{FF2B5EF4-FFF2-40B4-BE49-F238E27FC236}">
-                <a16:creationId xmlns:a16="http://schemas.microsoft.com/office/drawing/2014/main" id="{B40268DC-83B6-477B-AD3F-596219FE13D6}"/>
+                <a16:creationId xmlns:a16="http://schemas.microsoft.com/office/drawing/2014/main" id="{55CD8563-28DC-4FBB-82F0-7E04EEB8FF12}"/>
               </a:ext>
             </a:extLst>
           </p:cNvPr>
@@ -12836,7 +12755,7 @@
           <p:cNvPr id="19" name="">
             <a:extLst xmlns:a="http://schemas.openxmlformats.org/drawingml/2006/main">
               <a:ext uri="{FF2B5EF4-FFF2-40B4-BE49-F238E27FC236}">
-                <a16:creationId xmlns:a16="http://schemas.microsoft.com/office/drawing/2014/main" id="{EE9CD936-B856-4F95-AD23-F64B229D67A2}"/>
+                <a16:creationId xmlns:a16="http://schemas.microsoft.com/office/drawing/2014/main" id="{B6E07852-1ED5-49E6-A58C-5BEA9D19DCC3}"/>
               </a:ext>
             </a:extLst>
           </p:cNvPr>
@@ -12894,7 +12813,7 @@
           <p:cNvPr id="20" name="">
             <a:extLst xmlns:a="http://schemas.openxmlformats.org/drawingml/2006/main">
               <a:ext uri="{FF2B5EF4-FFF2-40B4-BE49-F238E27FC236}">
-                <a16:creationId xmlns:a16="http://schemas.microsoft.com/office/drawing/2014/main" id="{9AD47A3C-7A9E-4385-B0E0-A48F3E8A5AFC}"/>
+                <a16:creationId xmlns:a16="http://schemas.microsoft.com/office/drawing/2014/main" id="{BB7027DB-19B0-460F-A4BE-8D80B7953ACD}"/>
               </a:ext>
             </a:extLst>
           </p:cNvPr>
@@ -12952,7 +12871,7 @@
           <p:cNvPr id="21" name="">
             <a:extLst xmlns:a="http://schemas.openxmlformats.org/drawingml/2006/main">
               <a:ext uri="{FF2B5EF4-FFF2-40B4-BE49-F238E27FC236}">
-                <a16:creationId xmlns:a16="http://schemas.microsoft.com/office/drawing/2014/main" id="{18A5DDA4-C7BD-43F2-B0CD-DA744FD2C2B9}"/>
+                <a16:creationId xmlns:a16="http://schemas.microsoft.com/office/drawing/2014/main" id="{A37858E1-FDEF-4DEE-A7AF-3A8F4733D87D}"/>
               </a:ext>
             </a:extLst>
           </p:cNvPr>
@@ -13010,7 +12929,7 @@
           <p:cNvPr id="22" name="">
             <a:extLst xmlns:a="http://schemas.openxmlformats.org/drawingml/2006/main">
               <a:ext uri="{FF2B5EF4-FFF2-40B4-BE49-F238E27FC236}">
-                <a16:creationId xmlns:a16="http://schemas.microsoft.com/office/drawing/2014/main" id="{5DC31DE0-C784-4DA5-8878-D8624051F0E5}"/>
+                <a16:creationId xmlns:a16="http://schemas.microsoft.com/office/drawing/2014/main" id="{DC8A0604-F335-4C04-938E-D8A8E69D66C4}"/>
               </a:ext>
             </a:extLst>
           </p:cNvPr>
@@ -13041,7 +12960,7 @@
           <p:cNvPr id="23" name="">
             <a:extLst xmlns:a="http://schemas.openxmlformats.org/drawingml/2006/main">
               <a:ext uri="{FF2B5EF4-FFF2-40B4-BE49-F238E27FC236}">
-                <a16:creationId xmlns:a16="http://schemas.microsoft.com/office/drawing/2014/main" id="{CCDFB0AA-E1B4-4268-9044-523ADEFFAA66}"/>
+                <a16:creationId xmlns:a16="http://schemas.microsoft.com/office/drawing/2014/main" id="{FF20529E-235A-4449-A1E5-512788EFB4D3}"/>
               </a:ext>
             </a:extLst>
           </p:cNvPr>
@@ -13072,7 +12991,7 @@
           <p:cNvPr id="24" name="">
             <a:extLst xmlns:a="http://schemas.openxmlformats.org/drawingml/2006/main">
               <a:ext uri="{FF2B5EF4-FFF2-40B4-BE49-F238E27FC236}">
-                <a16:creationId xmlns:a16="http://schemas.microsoft.com/office/drawing/2014/main" id="{FC7801F5-27A2-48FE-9F00-4B4D0E3E9047}"/>
+                <a16:creationId xmlns:a16="http://schemas.microsoft.com/office/drawing/2014/main" id="{4CB6E584-2454-436F-84B9-69A5760CEA39}"/>
               </a:ext>
             </a:extLst>
           </p:cNvPr>
@@ -13130,7 +13049,7 @@
           <p:cNvPr id="25" name="">
             <a:extLst xmlns:a="http://schemas.openxmlformats.org/drawingml/2006/main">
               <a:ext uri="{FF2B5EF4-FFF2-40B4-BE49-F238E27FC236}">
-                <a16:creationId xmlns:a16="http://schemas.microsoft.com/office/drawing/2014/main" id="{234BCC54-1590-4041-B57F-086B17F34CD5}"/>
+                <a16:creationId xmlns:a16="http://schemas.microsoft.com/office/drawing/2014/main" id="{50E3860D-3F08-4A9B-82C9-E7D858A7D3FF}"/>
               </a:ext>
             </a:extLst>
           </p:cNvPr>
@@ -13188,7 +13107,7 @@
           <p:cNvPr id="26" name="">
             <a:extLst xmlns:a="http://schemas.openxmlformats.org/drawingml/2006/main">
               <a:ext uri="{FF2B5EF4-FFF2-40B4-BE49-F238E27FC236}">
-                <a16:creationId xmlns:a16="http://schemas.microsoft.com/office/drawing/2014/main" id="{C5D46BAD-12FF-47CC-8263-0D2F750B84EB}"/>
+                <a16:creationId xmlns:a16="http://schemas.microsoft.com/office/drawing/2014/main" id="{1CF75FFB-468C-492A-9599-081DBBD450BA}"/>
               </a:ext>
             </a:extLst>
           </p:cNvPr>
@@ -13236,7 +13155,7 @@
                 <a:ea typeface="Aptos"/>
                 <a:cs typeface="Aptos"/>
               </a:rPr>
-              <a:t>SMARTCOURSE  /  FYP VIVA</a:t>
+              <a:t>SMARTCOURSE  /  PROJECT</a:t>
             </a:r>
           </a:p>
         </p:txBody>
@@ -13246,7 +13165,7 @@
           <p:cNvPr id="27" name="">
             <a:extLst xmlns:a="http://schemas.openxmlformats.org/drawingml/2006/main">
               <a:ext uri="{FF2B5EF4-FFF2-40B4-BE49-F238E27FC236}">
-                <a16:creationId xmlns:a16="http://schemas.microsoft.com/office/drawing/2014/main" id="{D6DDF326-B017-4A2C-899F-0BBDDC0D8D36}"/>
+                <a16:creationId xmlns:a16="http://schemas.microsoft.com/office/drawing/2014/main" id="{8392E915-454B-4662-B17D-B116099C9445}"/>
               </a:ext>
             </a:extLst>
           </p:cNvPr>
@@ -13302,7 +13221,7 @@
     </p:spTree>
     <p:extLst>
       <p:ext uri="{BB962C8B-B14F-4D97-AF65-F5344CB8AC3E}">
-        <p14:creationId xmlns:p14="http://schemas.microsoft.com/office/powerpoint/2010/main" val="296515965"/>
+        <p14:creationId xmlns:p14="http://schemas.microsoft.com/office/powerpoint/2010/main" val="207493705"/>
       </p:ext>
     </p:extLst>
   </p:cSld>
@@ -13333,7 +13252,7 @@
           <p:cNvPr id="21" name="kicker">
             <a:extLst xmlns:a="http://schemas.openxmlformats.org/drawingml/2006/main">
               <a:ext uri="{FF2B5EF4-FFF2-40B4-BE49-F238E27FC236}">
-                <a16:creationId xmlns:a16="http://schemas.microsoft.com/office/drawing/2014/main" id="{28B5EAB3-954F-41F0-915F-C96B955DADD6}"/>
+                <a16:creationId xmlns:a16="http://schemas.microsoft.com/office/drawing/2014/main" id="{64E5DD47-A2E7-4C9D-A98D-92284DB89FA0}"/>
               </a:ext>
             </a:extLst>
           </p:cNvPr>
@@ -13391,7 +13310,7 @@
           <p:cNvPr id="2" name="title">
             <a:extLst xmlns:a="http://schemas.openxmlformats.org/drawingml/2006/main">
               <a:ext uri="{FF2B5EF4-FFF2-40B4-BE49-F238E27FC236}">
-                <a16:creationId xmlns:a16="http://schemas.microsoft.com/office/drawing/2014/main" id="{1DCF26BF-9E09-4EC5-94C2-C106805F81C1}"/>
+                <a16:creationId xmlns:a16="http://schemas.microsoft.com/office/drawing/2014/main" id="{016DDD9D-04EF-4C90-8F54-C1A559960DBF}"/>
               </a:ext>
             </a:extLst>
           </p:cNvPr>
@@ -13449,7 +13368,7 @@
           <p:cNvPr id="3" name="subtitle">
             <a:extLst xmlns:a="http://schemas.openxmlformats.org/drawingml/2006/main">
               <a:ext uri="{FF2B5EF4-FFF2-40B4-BE49-F238E27FC236}">
-                <a16:creationId xmlns:a16="http://schemas.microsoft.com/office/drawing/2014/main" id="{AAFD43DC-ADF8-4E8F-9216-555EB4CD1F81}"/>
+                <a16:creationId xmlns:a16="http://schemas.microsoft.com/office/drawing/2014/main" id="{F3204BE5-5650-4E61-8EAC-D4AC55D6EA75}"/>
               </a:ext>
             </a:extLst>
           </p:cNvPr>
@@ -13507,7 +13426,7 @@
           <p:cNvPr id="4" name="">
             <a:extLst xmlns:a="http://schemas.openxmlformats.org/drawingml/2006/main">
               <a:ext uri="{FF2B5EF4-FFF2-40B4-BE49-F238E27FC236}">
-                <a16:creationId xmlns:a16="http://schemas.microsoft.com/office/drawing/2014/main" id="{38C84790-B296-441D-94AC-1BB3F52CCDE0}"/>
+                <a16:creationId xmlns:a16="http://schemas.microsoft.com/office/drawing/2014/main" id="{5D98174E-F4D1-4101-A139-3E01C1DC7856}"/>
               </a:ext>
             </a:extLst>
           </p:cNvPr>
@@ -13538,7 +13457,7 @@
           <p:cNvPr id="5" name="">
             <a:extLst xmlns:a="http://schemas.openxmlformats.org/drawingml/2006/main">
               <a:ext uri="{FF2B5EF4-FFF2-40B4-BE49-F238E27FC236}">
-                <a16:creationId xmlns:a16="http://schemas.microsoft.com/office/drawing/2014/main" id="{EF4C69C4-7186-4FA2-AE79-F52ED4ACECDB}"/>
+                <a16:creationId xmlns:a16="http://schemas.microsoft.com/office/drawing/2014/main" id="{8292AF43-EC23-4451-B444-79467CDC3383}"/>
               </a:ext>
             </a:extLst>
           </p:cNvPr>
@@ -13579,7 +13498,7 @@
           <p:cNvPr id="6" name="">
             <a:extLst xmlns:a="http://schemas.openxmlformats.org/drawingml/2006/main">
               <a:ext uri="{FF2B5EF4-FFF2-40B4-BE49-F238E27FC236}">
-                <a16:creationId xmlns:a16="http://schemas.microsoft.com/office/drawing/2014/main" id="{359DE1ED-B407-4106-A278-7CC23DA60013}"/>
+                <a16:creationId xmlns:a16="http://schemas.microsoft.com/office/drawing/2014/main" id="{39BD77E3-A4A3-4620-9EA1-DE491012C958}"/>
               </a:ext>
             </a:extLst>
           </p:cNvPr>
@@ -13641,7 +13560,7 @@
           <p:cNvPr id="7" name="">
             <a:extLst xmlns:a="http://schemas.openxmlformats.org/drawingml/2006/main">
               <a:ext uri="{FF2B5EF4-FFF2-40B4-BE49-F238E27FC236}">
-                <a16:creationId xmlns:a16="http://schemas.microsoft.com/office/drawing/2014/main" id="{6814EEE9-D804-4815-A6BD-62511B83E66F}"/>
+                <a16:creationId xmlns:a16="http://schemas.microsoft.com/office/drawing/2014/main" id="{3CA2443C-9F80-4729-A93C-08D3BD81B48B}"/>
               </a:ext>
             </a:extLst>
           </p:cNvPr>
@@ -13699,7 +13618,7 @@
           <p:cNvPr id="8" name="">
             <a:extLst xmlns:a="http://schemas.openxmlformats.org/drawingml/2006/main">
               <a:ext uri="{FF2B5EF4-FFF2-40B4-BE49-F238E27FC236}">
-                <a16:creationId xmlns:a16="http://schemas.microsoft.com/office/drawing/2014/main" id="{25844D66-909E-4A9E-8115-6F21BC283CFC}"/>
+                <a16:creationId xmlns:a16="http://schemas.microsoft.com/office/drawing/2014/main" id="{2EBD9CBF-9564-46A5-A2B6-E3424246D56E}"/>
               </a:ext>
             </a:extLst>
           </p:cNvPr>
@@ -13757,7 +13676,7 @@
           <p:cNvPr id="9" name="">
             <a:extLst xmlns:a="http://schemas.openxmlformats.org/drawingml/2006/main">
               <a:ext uri="{FF2B5EF4-FFF2-40B4-BE49-F238E27FC236}">
-                <a16:creationId xmlns:a16="http://schemas.microsoft.com/office/drawing/2014/main" id="{21DA09AD-9C59-4C77-82A2-A2171E026CCC}"/>
+                <a16:creationId xmlns:a16="http://schemas.microsoft.com/office/drawing/2014/main" id="{8181FDAF-F961-41DD-AB29-36E6325FF922}"/>
               </a:ext>
             </a:extLst>
           </p:cNvPr>
@@ -13884,7 +13803,7 @@
           <p:cNvPr id="10" name="">
             <a:extLst xmlns:a="http://schemas.openxmlformats.org/drawingml/2006/main">
               <a:ext uri="{FF2B5EF4-FFF2-40B4-BE49-F238E27FC236}">
-                <a16:creationId xmlns:a16="http://schemas.microsoft.com/office/drawing/2014/main" id="{23FA14CA-180B-428D-9521-027854677396}"/>
+                <a16:creationId xmlns:a16="http://schemas.microsoft.com/office/drawing/2014/main" id="{C1B85CC6-599E-4909-862C-6A4B8EDC45FE}"/>
               </a:ext>
             </a:extLst>
           </p:cNvPr>
@@ -13942,7 +13861,7 @@
           <p:cNvPr id="11" name="">
             <a:extLst xmlns:a="http://schemas.openxmlformats.org/drawingml/2006/main">
               <a:ext uri="{FF2B5EF4-FFF2-40B4-BE49-F238E27FC236}">
-                <a16:creationId xmlns:a16="http://schemas.microsoft.com/office/drawing/2014/main" id="{F5D5F52A-756D-4F04-A021-0B9BFE6D18E4}"/>
+                <a16:creationId xmlns:a16="http://schemas.microsoft.com/office/drawing/2014/main" id="{EE2BB47D-0F48-4A71-A7D1-B8DE911AF664}"/>
               </a:ext>
             </a:extLst>
           </p:cNvPr>
@@ -13983,7 +13902,7 @@
           <p:cNvPr id="12" name="">
             <a:extLst xmlns:a="http://schemas.openxmlformats.org/drawingml/2006/main">
               <a:ext uri="{FF2B5EF4-FFF2-40B4-BE49-F238E27FC236}">
-                <a16:creationId xmlns:a16="http://schemas.microsoft.com/office/drawing/2014/main" id="{621D08E0-6B02-4844-9FC4-EAE40EE34C43}"/>
+                <a16:creationId xmlns:a16="http://schemas.microsoft.com/office/drawing/2014/main" id="{793D30A7-558C-45A3-A278-A4A2E6EF75D8}"/>
               </a:ext>
             </a:extLst>
           </p:cNvPr>
@@ -14045,7 +13964,7 @@
           <p:cNvPr id="13" name="">
             <a:extLst xmlns:a="http://schemas.openxmlformats.org/drawingml/2006/main">
               <a:ext uri="{FF2B5EF4-FFF2-40B4-BE49-F238E27FC236}">
-                <a16:creationId xmlns:a16="http://schemas.microsoft.com/office/drawing/2014/main" id="{0FAB29FC-E2E3-4FA1-9F40-9E719082A231}"/>
+                <a16:creationId xmlns:a16="http://schemas.microsoft.com/office/drawing/2014/main" id="{A0B119A1-D5F6-4ECD-A630-24F01AB6A4E6}"/>
               </a:ext>
             </a:extLst>
           </p:cNvPr>
@@ -14103,7 +14022,7 @@
           <p:cNvPr id="14" name="">
             <a:extLst xmlns:a="http://schemas.openxmlformats.org/drawingml/2006/main">
               <a:ext uri="{FF2B5EF4-FFF2-40B4-BE49-F238E27FC236}">
-                <a16:creationId xmlns:a16="http://schemas.microsoft.com/office/drawing/2014/main" id="{A05A114B-CDC8-4A86-A447-F7A48E003E74}"/>
+                <a16:creationId xmlns:a16="http://schemas.microsoft.com/office/drawing/2014/main" id="{2AE4710D-63D2-4064-8005-E3D4B78A42A5}"/>
               </a:ext>
             </a:extLst>
           </p:cNvPr>
@@ -14161,7 +14080,7 @@
           <p:cNvPr id="15" name="">
             <a:extLst xmlns:a="http://schemas.openxmlformats.org/drawingml/2006/main">
               <a:ext uri="{FF2B5EF4-FFF2-40B4-BE49-F238E27FC236}">
-                <a16:creationId xmlns:a16="http://schemas.microsoft.com/office/drawing/2014/main" id="{1F385255-9606-4E82-AACD-1B3A6C15BF4C}"/>
+                <a16:creationId xmlns:a16="http://schemas.microsoft.com/office/drawing/2014/main" id="{E5B2732C-C430-4B6A-B970-735572A8F107}"/>
               </a:ext>
             </a:extLst>
           </p:cNvPr>
@@ -14288,7 +14207,7 @@
           <p:cNvPr id="16" name="">
             <a:extLst xmlns:a="http://schemas.openxmlformats.org/drawingml/2006/main">
               <a:ext uri="{FF2B5EF4-FFF2-40B4-BE49-F238E27FC236}">
-                <a16:creationId xmlns:a16="http://schemas.microsoft.com/office/drawing/2014/main" id="{1070220A-79E2-4177-AF99-56A15324F731}"/>
+                <a16:creationId xmlns:a16="http://schemas.microsoft.com/office/drawing/2014/main" id="{75148F79-B7FB-4E85-A40D-1C1F17DFE6D3}"/>
               </a:ext>
             </a:extLst>
           </p:cNvPr>
@@ -14346,7 +14265,7 @@
           <p:cNvPr id="17" name="">
             <a:extLst xmlns:a="http://schemas.openxmlformats.org/drawingml/2006/main">
               <a:ext uri="{FF2B5EF4-FFF2-40B4-BE49-F238E27FC236}">
-                <a16:creationId xmlns:a16="http://schemas.microsoft.com/office/drawing/2014/main" id="{73E00B5C-9442-4F3D-93B7-227B9C79BFF8}"/>
+                <a16:creationId xmlns:a16="http://schemas.microsoft.com/office/drawing/2014/main" id="{347E8BB7-1D02-4AAE-AF9C-20D64047F5FD}"/>
               </a:ext>
             </a:extLst>
           </p:cNvPr>
@@ -14377,7 +14296,7 @@
           <p:cNvPr id="18" name="">
             <a:extLst xmlns:a="http://schemas.openxmlformats.org/drawingml/2006/main">
               <a:ext uri="{FF2B5EF4-FFF2-40B4-BE49-F238E27FC236}">
-                <a16:creationId xmlns:a16="http://schemas.microsoft.com/office/drawing/2014/main" id="{C77B5202-79F3-466D-B6D1-4F23ADB015D5}"/>
+                <a16:creationId xmlns:a16="http://schemas.microsoft.com/office/drawing/2014/main" id="{1BF444A8-E7C2-41C7-92C0-5A0653D973C7}"/>
               </a:ext>
             </a:extLst>
           </p:cNvPr>
@@ -14435,7 +14354,7 @@
           <p:cNvPr id="19" name="">
             <a:extLst xmlns:a="http://schemas.openxmlformats.org/drawingml/2006/main">
               <a:ext uri="{FF2B5EF4-FFF2-40B4-BE49-F238E27FC236}">
-                <a16:creationId xmlns:a16="http://schemas.microsoft.com/office/drawing/2014/main" id="{EDDBD5FF-5804-4533-A59E-6F39BB11F55A}"/>
+                <a16:creationId xmlns:a16="http://schemas.microsoft.com/office/drawing/2014/main" id="{3FDD3AF4-300E-450D-A827-86A46DDBC304}"/>
               </a:ext>
             </a:extLst>
           </p:cNvPr>
@@ -14483,7 +14402,7 @@
                 <a:ea typeface="Aptos"/>
                 <a:cs typeface="Aptos"/>
               </a:rPr>
-              <a:t>SMARTCOURSE  /  FYP VIVA</a:t>
+              <a:t>SMARTCOURSE  /  PROJECT</a:t>
             </a:r>
           </a:p>
         </p:txBody>
@@ -14493,7 +14412,7 @@
           <p:cNvPr id="20" name="">
             <a:extLst xmlns:a="http://schemas.openxmlformats.org/drawingml/2006/main">
               <a:ext uri="{FF2B5EF4-FFF2-40B4-BE49-F238E27FC236}">
-                <a16:creationId xmlns:a16="http://schemas.microsoft.com/office/drawing/2014/main" id="{62D40193-B0F3-4F23-974D-3C606A9D50FF}"/>
+                <a16:creationId xmlns:a16="http://schemas.microsoft.com/office/drawing/2014/main" id="{BF7C521C-124C-4833-A04B-545DEA0F7AAE}"/>
               </a:ext>
             </a:extLst>
           </p:cNvPr>
@@ -14549,7 +14468,7 @@
     </p:spTree>
     <p:extLst>
       <p:ext uri="{BB962C8B-B14F-4D97-AF65-F5344CB8AC3E}">
-        <p14:creationId xmlns:p14="http://schemas.microsoft.com/office/powerpoint/2010/main" val="2055109693"/>
+        <p14:creationId xmlns:p14="http://schemas.microsoft.com/office/powerpoint/2010/main" val="432563299"/>
       </p:ext>
     </p:extLst>
   </p:cSld>
@@ -14580,7 +14499,7 @@
           <p:cNvPr id="31" name="kicker">
             <a:extLst xmlns:a="http://schemas.openxmlformats.org/drawingml/2006/main">
               <a:ext uri="{FF2B5EF4-FFF2-40B4-BE49-F238E27FC236}">
-                <a16:creationId xmlns:a16="http://schemas.microsoft.com/office/drawing/2014/main" id="{843A1A00-8408-4832-8B99-BCCAAA39DBB9}"/>
+                <a16:creationId xmlns:a16="http://schemas.microsoft.com/office/drawing/2014/main" id="{245669C0-7E3D-433C-8801-9653962C326B}"/>
               </a:ext>
             </a:extLst>
           </p:cNvPr>
@@ -14638,7 +14557,7 @@
           <p:cNvPr id="2" name="title">
             <a:extLst xmlns:a="http://schemas.openxmlformats.org/drawingml/2006/main">
               <a:ext uri="{FF2B5EF4-FFF2-40B4-BE49-F238E27FC236}">
-                <a16:creationId xmlns:a16="http://schemas.microsoft.com/office/drawing/2014/main" id="{3535D0CA-968B-4DC6-9671-1A82805004A9}"/>
+                <a16:creationId xmlns:a16="http://schemas.microsoft.com/office/drawing/2014/main" id="{B098AC31-9037-447D-807B-92EC91570AA3}"/>
               </a:ext>
             </a:extLst>
           </p:cNvPr>
@@ -14696,7 +14615,7 @@
           <p:cNvPr id="3" name="subtitle">
             <a:extLst xmlns:a="http://schemas.openxmlformats.org/drawingml/2006/main">
               <a:ext uri="{FF2B5EF4-FFF2-40B4-BE49-F238E27FC236}">
-                <a16:creationId xmlns:a16="http://schemas.microsoft.com/office/drawing/2014/main" id="{65B7467E-3C6E-41CE-B3DC-E87F763BC58C}"/>
+                <a16:creationId xmlns:a16="http://schemas.microsoft.com/office/drawing/2014/main" id="{16C11698-AF8A-4F5D-BDC3-B3B46219339B}"/>
               </a:ext>
             </a:extLst>
           </p:cNvPr>
@@ -14754,7 +14673,7 @@
           <p:cNvPr id="4" name="">
             <a:extLst xmlns:a="http://schemas.openxmlformats.org/drawingml/2006/main">
               <a:ext uri="{FF2B5EF4-FFF2-40B4-BE49-F238E27FC236}">
-                <a16:creationId xmlns:a16="http://schemas.microsoft.com/office/drawing/2014/main" id="{835FDBF7-6D76-4C59-AE0A-C69D4F507528}"/>
+                <a16:creationId xmlns:a16="http://schemas.microsoft.com/office/drawing/2014/main" id="{B970023A-E3AA-4FA4-A16E-562C5E9D4CB4}"/>
               </a:ext>
             </a:extLst>
           </p:cNvPr>
@@ -14785,7 +14704,7 @@
           <p:cNvPr id="5" name="">
             <a:extLst xmlns:a="http://schemas.openxmlformats.org/drawingml/2006/main">
               <a:ext uri="{FF2B5EF4-FFF2-40B4-BE49-F238E27FC236}">
-                <a16:creationId xmlns:a16="http://schemas.microsoft.com/office/drawing/2014/main" id="{3E6FC96C-65F9-4837-A259-D1E88715EF22}"/>
+                <a16:creationId xmlns:a16="http://schemas.microsoft.com/office/drawing/2014/main" id="{416CD0EE-782C-4C57-B133-DB5B9D77D9AF}"/>
               </a:ext>
             </a:extLst>
           </p:cNvPr>
@@ -14847,7 +14766,7 @@
           <p:cNvPr id="6" name="">
             <a:extLst xmlns:a="http://schemas.openxmlformats.org/drawingml/2006/main">
               <a:ext uri="{FF2B5EF4-FFF2-40B4-BE49-F238E27FC236}">
-                <a16:creationId xmlns:a16="http://schemas.microsoft.com/office/drawing/2014/main" id="{BB27BB33-EC78-45E9-AB93-746B541E994F}"/>
+                <a16:creationId xmlns:a16="http://schemas.microsoft.com/office/drawing/2014/main" id="{D6937DEC-F624-482C-BCC2-1AA29FEA822A}"/>
               </a:ext>
             </a:extLst>
           </p:cNvPr>
@@ -14878,7 +14797,7 @@
           <p:cNvPr id="7" name="">
             <a:extLst xmlns:a="http://schemas.openxmlformats.org/drawingml/2006/main">
               <a:ext uri="{FF2B5EF4-FFF2-40B4-BE49-F238E27FC236}">
-                <a16:creationId xmlns:a16="http://schemas.microsoft.com/office/drawing/2014/main" id="{C0E8602B-663F-42B0-BBDB-83FD61B71201}"/>
+                <a16:creationId xmlns:a16="http://schemas.microsoft.com/office/drawing/2014/main" id="{74C61DA8-61CA-430A-AB7A-43BC676F9C61}"/>
               </a:ext>
             </a:extLst>
           </p:cNvPr>
@@ -14919,7 +14838,7 @@
           <p:cNvPr id="8" name="">
             <a:extLst xmlns:a="http://schemas.openxmlformats.org/drawingml/2006/main">
               <a:ext uri="{FF2B5EF4-FFF2-40B4-BE49-F238E27FC236}">
-                <a16:creationId xmlns:a16="http://schemas.microsoft.com/office/drawing/2014/main" id="{894CDEE1-A4E4-4439-9F94-FEFAB94BA30D}"/>
+                <a16:creationId xmlns:a16="http://schemas.microsoft.com/office/drawing/2014/main" id="{1EA38B0E-5CC4-4E0D-B12B-E66EC563DD31}"/>
               </a:ext>
             </a:extLst>
           </p:cNvPr>
@@ -14977,7 +14896,7 @@
           <p:cNvPr id="9" name="">
             <a:extLst xmlns:a="http://schemas.openxmlformats.org/drawingml/2006/main">
               <a:ext uri="{FF2B5EF4-FFF2-40B4-BE49-F238E27FC236}">
-                <a16:creationId xmlns:a16="http://schemas.microsoft.com/office/drawing/2014/main" id="{4AC16FF1-46EB-4264-AF0E-AC78C2B4C444}"/>
+                <a16:creationId xmlns:a16="http://schemas.microsoft.com/office/drawing/2014/main" id="{1CC4B3E8-C403-4056-8AE7-3F5C369726F0}"/>
               </a:ext>
             </a:extLst>
           </p:cNvPr>
@@ -15035,7 +14954,7 @@
           <p:cNvPr id="10" name="">
             <a:extLst xmlns:a="http://schemas.openxmlformats.org/drawingml/2006/main">
               <a:ext uri="{FF2B5EF4-FFF2-40B4-BE49-F238E27FC236}">
-                <a16:creationId xmlns:a16="http://schemas.microsoft.com/office/drawing/2014/main" id="{F9299D2E-AE42-4CD9-82EF-2E136462BFD4}"/>
+                <a16:creationId xmlns:a16="http://schemas.microsoft.com/office/drawing/2014/main" id="{47EA0FC7-19B1-4F50-B972-BC4FE7C28DC6}"/>
               </a:ext>
             </a:extLst>
           </p:cNvPr>
@@ -15116,7 +15035,7 @@
           <p:cNvPr id="11" name="">
             <a:extLst xmlns:a="http://schemas.openxmlformats.org/drawingml/2006/main">
               <a:ext uri="{FF2B5EF4-FFF2-40B4-BE49-F238E27FC236}">
-                <a16:creationId xmlns:a16="http://schemas.microsoft.com/office/drawing/2014/main" id="{13D6C56F-E063-4CF7-9590-2230806821CB}"/>
+                <a16:creationId xmlns:a16="http://schemas.microsoft.com/office/drawing/2014/main" id="{5B369FD4-D5D1-458D-9772-8B67DDF829F8}"/>
               </a:ext>
             </a:extLst>
           </p:cNvPr>
@@ -15147,7 +15066,7 @@
           <p:cNvPr id="12" name="">
             <a:extLst xmlns:a="http://schemas.openxmlformats.org/drawingml/2006/main">
               <a:ext uri="{FF2B5EF4-FFF2-40B4-BE49-F238E27FC236}">
-                <a16:creationId xmlns:a16="http://schemas.microsoft.com/office/drawing/2014/main" id="{788F2458-EE04-4804-AB00-40E8CF496CEE}"/>
+                <a16:creationId xmlns:a16="http://schemas.microsoft.com/office/drawing/2014/main" id="{2195D4CD-343A-46E2-BB12-83366BB58771}"/>
               </a:ext>
             </a:extLst>
           </p:cNvPr>
@@ -15188,7 +15107,7 @@
           <p:cNvPr id="13" name="">
             <a:extLst xmlns:a="http://schemas.openxmlformats.org/drawingml/2006/main">
               <a:ext uri="{FF2B5EF4-FFF2-40B4-BE49-F238E27FC236}">
-                <a16:creationId xmlns:a16="http://schemas.microsoft.com/office/drawing/2014/main" id="{63513E5A-3FBE-4F92-9DBE-1138B297C2CA}"/>
+                <a16:creationId xmlns:a16="http://schemas.microsoft.com/office/drawing/2014/main" id="{24B3A477-B7F8-423F-A823-7BA84867AE50}"/>
               </a:ext>
             </a:extLst>
           </p:cNvPr>
@@ -15246,7 +15165,7 @@
           <p:cNvPr id="14" name="">
             <a:extLst xmlns:a="http://schemas.openxmlformats.org/drawingml/2006/main">
               <a:ext uri="{FF2B5EF4-FFF2-40B4-BE49-F238E27FC236}">
-                <a16:creationId xmlns:a16="http://schemas.microsoft.com/office/drawing/2014/main" id="{9E0C49A9-56A7-4FD8-93BC-0FAC7DC37ACD}"/>
+                <a16:creationId xmlns:a16="http://schemas.microsoft.com/office/drawing/2014/main" id="{8F78ED58-ED4B-460E-BC84-44101E479A10}"/>
               </a:ext>
             </a:extLst>
           </p:cNvPr>
@@ -15304,7 +15223,7 @@
           <p:cNvPr id="15" name="">
             <a:extLst xmlns:a="http://schemas.openxmlformats.org/drawingml/2006/main">
               <a:ext uri="{FF2B5EF4-FFF2-40B4-BE49-F238E27FC236}">
-                <a16:creationId xmlns:a16="http://schemas.microsoft.com/office/drawing/2014/main" id="{5133E871-DB43-4209-AB6F-03300820B7A4}"/>
+                <a16:creationId xmlns:a16="http://schemas.microsoft.com/office/drawing/2014/main" id="{D3527481-D276-4937-9211-1C2F793D12DB}"/>
               </a:ext>
             </a:extLst>
           </p:cNvPr>
@@ -15385,7 +15304,7 @@
           <p:cNvPr id="16" name="">
             <a:extLst xmlns:a="http://schemas.openxmlformats.org/drawingml/2006/main">
               <a:ext uri="{FF2B5EF4-FFF2-40B4-BE49-F238E27FC236}">
-                <a16:creationId xmlns:a16="http://schemas.microsoft.com/office/drawing/2014/main" id="{DF09B298-B0FA-41E2-AB23-6FCF547465B9}"/>
+                <a16:creationId xmlns:a16="http://schemas.microsoft.com/office/drawing/2014/main" id="{762B3CE4-B0A1-4877-8899-A1B4A7950D5C}"/>
               </a:ext>
             </a:extLst>
           </p:cNvPr>
@@ -15416,7 +15335,7 @@
           <p:cNvPr id="17" name="">
             <a:extLst xmlns:a="http://schemas.openxmlformats.org/drawingml/2006/main">
               <a:ext uri="{FF2B5EF4-FFF2-40B4-BE49-F238E27FC236}">
-                <a16:creationId xmlns:a16="http://schemas.microsoft.com/office/drawing/2014/main" id="{0AEAC272-56F5-4F1E-9C4C-0B59DCF2F9A5}"/>
+                <a16:creationId xmlns:a16="http://schemas.microsoft.com/office/drawing/2014/main" id="{0745E9B1-51E9-4E28-A22F-E123C272DE0C}"/>
               </a:ext>
             </a:extLst>
           </p:cNvPr>
@@ -15457,7 +15376,7 @@
           <p:cNvPr id="18" name="">
             <a:extLst xmlns:a="http://schemas.openxmlformats.org/drawingml/2006/main">
               <a:ext uri="{FF2B5EF4-FFF2-40B4-BE49-F238E27FC236}">
-                <a16:creationId xmlns:a16="http://schemas.microsoft.com/office/drawing/2014/main" id="{8E3E1FEE-7FA9-4C16-B90B-F2ACC69F4D03}"/>
+                <a16:creationId xmlns:a16="http://schemas.microsoft.com/office/drawing/2014/main" id="{DA98EBB9-7833-4FC4-BF88-DE3171123EC3}"/>
               </a:ext>
             </a:extLst>
           </p:cNvPr>
@@ -15515,7 +15434,7 @@
           <p:cNvPr id="19" name="">
             <a:extLst xmlns:a="http://schemas.openxmlformats.org/drawingml/2006/main">
               <a:ext uri="{FF2B5EF4-FFF2-40B4-BE49-F238E27FC236}">
-                <a16:creationId xmlns:a16="http://schemas.microsoft.com/office/drawing/2014/main" id="{DEE13B8B-B47E-457D-95D9-8DB3E1FAFC90}"/>
+                <a16:creationId xmlns:a16="http://schemas.microsoft.com/office/drawing/2014/main" id="{6DF37366-C152-4DA0-A3FF-7C5781B2F656}"/>
               </a:ext>
             </a:extLst>
           </p:cNvPr>
@@ -15573,7 +15492,7 @@
           <p:cNvPr id="20" name="">
             <a:extLst xmlns:a="http://schemas.openxmlformats.org/drawingml/2006/main">
               <a:ext uri="{FF2B5EF4-FFF2-40B4-BE49-F238E27FC236}">
-                <a16:creationId xmlns:a16="http://schemas.microsoft.com/office/drawing/2014/main" id="{79EF9F7B-4D6F-4BB9-800E-D44705A0C504}"/>
+                <a16:creationId xmlns:a16="http://schemas.microsoft.com/office/drawing/2014/main" id="{D1E7CE58-D898-4C90-AFB3-A175DAB43900}"/>
               </a:ext>
             </a:extLst>
           </p:cNvPr>
@@ -15654,7 +15573,7 @@
           <p:cNvPr id="21" name="">
             <a:extLst xmlns:a="http://schemas.openxmlformats.org/drawingml/2006/main">
               <a:ext uri="{FF2B5EF4-FFF2-40B4-BE49-F238E27FC236}">
-                <a16:creationId xmlns:a16="http://schemas.microsoft.com/office/drawing/2014/main" id="{07A62037-EF79-49BB-B4EE-AC608C198431}"/>
+                <a16:creationId xmlns:a16="http://schemas.microsoft.com/office/drawing/2014/main" id="{51E0BE44-7D06-4F7E-B208-569CD08055AF}"/>
               </a:ext>
             </a:extLst>
           </p:cNvPr>
@@ -15695,7 +15614,7 @@
           <p:cNvPr id="22" name="">
             <a:extLst xmlns:a="http://schemas.openxmlformats.org/drawingml/2006/main">
               <a:ext uri="{FF2B5EF4-FFF2-40B4-BE49-F238E27FC236}">
-                <a16:creationId xmlns:a16="http://schemas.microsoft.com/office/drawing/2014/main" id="{72CEDF0F-4A4C-4DDF-A2FD-F492526F4336}"/>
+                <a16:creationId xmlns:a16="http://schemas.microsoft.com/office/drawing/2014/main" id="{347B58BC-D42E-4721-8F61-EE3E9BBEF05B}"/>
               </a:ext>
             </a:extLst>
           </p:cNvPr>
@@ -15753,7 +15672,7 @@
           <p:cNvPr id="23" name="">
             <a:extLst xmlns:a="http://schemas.openxmlformats.org/drawingml/2006/main">
               <a:ext uri="{FF2B5EF4-FFF2-40B4-BE49-F238E27FC236}">
-                <a16:creationId xmlns:a16="http://schemas.microsoft.com/office/drawing/2014/main" id="{0E32E419-75FD-41AE-AB57-B92F627399D2}"/>
+                <a16:creationId xmlns:a16="http://schemas.microsoft.com/office/drawing/2014/main" id="{D319F5C6-8172-4DF7-99A9-CBDE86996B3E}"/>
               </a:ext>
             </a:extLst>
           </p:cNvPr>
@@ -15811,7 +15730,7 @@
           <p:cNvPr id="24" name="">
             <a:extLst xmlns:a="http://schemas.openxmlformats.org/drawingml/2006/main">
               <a:ext uri="{FF2B5EF4-FFF2-40B4-BE49-F238E27FC236}">
-                <a16:creationId xmlns:a16="http://schemas.microsoft.com/office/drawing/2014/main" id="{399B96B9-09DE-491F-B8EE-6A8E0A8CBEB4}"/>
+                <a16:creationId xmlns:a16="http://schemas.microsoft.com/office/drawing/2014/main" id="{2CB12D8C-4188-4FBC-9CF7-E131996C161D}"/>
               </a:ext>
             </a:extLst>
           </p:cNvPr>
@@ -15892,7 +15811,7 @@
           <p:cNvPr id="25" name="">
             <a:extLst xmlns:a="http://schemas.openxmlformats.org/drawingml/2006/main">
               <a:ext uri="{FF2B5EF4-FFF2-40B4-BE49-F238E27FC236}">
-                <a16:creationId xmlns:a16="http://schemas.microsoft.com/office/drawing/2014/main" id="{C1E33659-105F-4548-BAB1-659427DF7E97}"/>
+                <a16:creationId xmlns:a16="http://schemas.microsoft.com/office/drawing/2014/main" id="{75556FCC-067B-4467-A5CF-C85271801643}"/>
               </a:ext>
             </a:extLst>
           </p:cNvPr>
@@ -15923,7 +15842,7 @@
           <p:cNvPr id="26" name="">
             <a:extLst xmlns:a="http://schemas.openxmlformats.org/drawingml/2006/main">
               <a:ext uri="{FF2B5EF4-FFF2-40B4-BE49-F238E27FC236}">
-                <a16:creationId xmlns:a16="http://schemas.microsoft.com/office/drawing/2014/main" id="{1DA1E9B0-41B5-466C-B76C-7DEA466DD8E6}"/>
+                <a16:creationId xmlns:a16="http://schemas.microsoft.com/office/drawing/2014/main" id="{4BAE348E-EFDC-4AE7-B741-E7D898D20C5F}"/>
               </a:ext>
             </a:extLst>
           </p:cNvPr>
@@ -15985,7 +15904,7 @@
           <p:cNvPr id="27" name="">
             <a:extLst xmlns:a="http://schemas.openxmlformats.org/drawingml/2006/main">
               <a:ext uri="{FF2B5EF4-FFF2-40B4-BE49-F238E27FC236}">
-                <a16:creationId xmlns:a16="http://schemas.microsoft.com/office/drawing/2014/main" id="{02A2C89E-BD2E-4EC6-9385-C7C174E28C16}"/>
+                <a16:creationId xmlns:a16="http://schemas.microsoft.com/office/drawing/2014/main" id="{6B124EDA-2434-4BFB-808B-4DF5E7DF897E}"/>
               </a:ext>
             </a:extLst>
           </p:cNvPr>
@@ -16043,7 +15962,7 @@
           <p:cNvPr id="28" name="">
             <a:extLst xmlns:a="http://schemas.openxmlformats.org/drawingml/2006/main">
               <a:ext uri="{FF2B5EF4-FFF2-40B4-BE49-F238E27FC236}">
-                <a16:creationId xmlns:a16="http://schemas.microsoft.com/office/drawing/2014/main" id="{0EA141F2-0095-47EB-B36A-3074041C8853}"/>
+                <a16:creationId xmlns:a16="http://schemas.microsoft.com/office/drawing/2014/main" id="{08A6533D-2A3C-44E5-B4BA-C87543BD64AC}"/>
               </a:ext>
             </a:extLst>
           </p:cNvPr>
@@ -16101,7 +16020,7 @@
           <p:cNvPr id="29" name="">
             <a:extLst xmlns:a="http://schemas.openxmlformats.org/drawingml/2006/main">
               <a:ext uri="{FF2B5EF4-FFF2-40B4-BE49-F238E27FC236}">
-                <a16:creationId xmlns:a16="http://schemas.microsoft.com/office/drawing/2014/main" id="{3F2D4CDC-C639-418B-9241-3F4426717661}"/>
+                <a16:creationId xmlns:a16="http://schemas.microsoft.com/office/drawing/2014/main" id="{50B3F0AB-E85C-4135-BB30-CECC9792687C}"/>
               </a:ext>
             </a:extLst>
           </p:cNvPr>
@@ -16149,7 +16068,7 @@
                 <a:ea typeface="Aptos"/>
                 <a:cs typeface="Aptos"/>
               </a:rPr>
-              <a:t>SMARTCOURSE  /  FYP VIVA</a:t>
+              <a:t>SMARTCOURSE  /  PROJECT</a:t>
             </a:r>
           </a:p>
         </p:txBody>
@@ -16159,7 +16078,7 @@
           <p:cNvPr id="30" name="">
             <a:extLst xmlns:a="http://schemas.openxmlformats.org/drawingml/2006/main">
               <a:ext uri="{FF2B5EF4-FFF2-40B4-BE49-F238E27FC236}">
-                <a16:creationId xmlns:a16="http://schemas.microsoft.com/office/drawing/2014/main" id="{5ADC4750-7280-4F03-BC1C-7F7D1F50173C}"/>
+                <a16:creationId xmlns:a16="http://schemas.microsoft.com/office/drawing/2014/main" id="{934B1CB7-64AF-4AEA-B16C-292B65D228C5}"/>
               </a:ext>
             </a:extLst>
           </p:cNvPr>
@@ -16215,7 +16134,7 @@
     </p:spTree>
     <p:extLst>
       <p:ext uri="{BB962C8B-B14F-4D97-AF65-F5344CB8AC3E}">
-        <p14:creationId xmlns:p14="http://schemas.microsoft.com/office/powerpoint/2010/main" val="1419329405"/>
+        <p14:creationId xmlns:p14="http://schemas.microsoft.com/office/powerpoint/2010/main" val="192164413"/>
       </p:ext>
     </p:extLst>
   </p:cSld>
@@ -16246,7 +16165,7 @@
           <p:cNvPr id="41" name="kicker">
             <a:extLst xmlns:a="http://schemas.openxmlformats.org/drawingml/2006/main">
               <a:ext uri="{FF2B5EF4-FFF2-40B4-BE49-F238E27FC236}">
-                <a16:creationId xmlns:a16="http://schemas.microsoft.com/office/drawing/2014/main" id="{0D03C212-9145-4CB2-BFA9-FC8D124C18C2}"/>
+                <a16:creationId xmlns:a16="http://schemas.microsoft.com/office/drawing/2014/main" id="{534CEC62-7A9A-4F46-A541-C857B19CD99F}"/>
               </a:ext>
             </a:extLst>
           </p:cNvPr>
@@ -16304,7 +16223,7 @@
           <p:cNvPr id="2" name="title">
             <a:extLst xmlns:a="http://schemas.openxmlformats.org/drawingml/2006/main">
               <a:ext uri="{FF2B5EF4-FFF2-40B4-BE49-F238E27FC236}">
-                <a16:creationId xmlns:a16="http://schemas.microsoft.com/office/drawing/2014/main" id="{5129FAEE-974E-4FE0-AD42-3B85E9F8B3FE}"/>
+                <a16:creationId xmlns:a16="http://schemas.microsoft.com/office/drawing/2014/main" id="{A36B5DCF-1CEC-4AFE-94B6-A7A4F2D9259A}"/>
               </a:ext>
             </a:extLst>
           </p:cNvPr>
@@ -16362,7 +16281,7 @@
           <p:cNvPr id="3" name="subtitle">
             <a:extLst xmlns:a="http://schemas.openxmlformats.org/drawingml/2006/main">
               <a:ext uri="{FF2B5EF4-FFF2-40B4-BE49-F238E27FC236}">
-                <a16:creationId xmlns:a16="http://schemas.microsoft.com/office/drawing/2014/main" id="{2CCCCFAC-48D8-40AC-8ADE-EBF33EACBC6A}"/>
+                <a16:creationId xmlns:a16="http://schemas.microsoft.com/office/drawing/2014/main" id="{586C930C-268D-45A7-BDF2-058E72B77C67}"/>
               </a:ext>
             </a:extLst>
           </p:cNvPr>
@@ -16420,7 +16339,7 @@
           <p:cNvPr id="4" name="">
             <a:extLst xmlns:a="http://schemas.openxmlformats.org/drawingml/2006/main">
               <a:ext uri="{FF2B5EF4-FFF2-40B4-BE49-F238E27FC236}">
-                <a16:creationId xmlns:a16="http://schemas.microsoft.com/office/drawing/2014/main" id="{0F8EC34D-C5CC-47B1-8020-539A40E10822}"/>
+                <a16:creationId xmlns:a16="http://schemas.microsoft.com/office/drawing/2014/main" id="{FD39656B-0B24-40CB-8E5C-21F858CD1C67}"/>
               </a:ext>
             </a:extLst>
           </p:cNvPr>
@@ -16451,7 +16370,7 @@
           <p:cNvPr id="5" name="">
             <a:extLst xmlns:a="http://schemas.openxmlformats.org/drawingml/2006/main">
               <a:ext uri="{FF2B5EF4-FFF2-40B4-BE49-F238E27FC236}">
-                <a16:creationId xmlns:a16="http://schemas.microsoft.com/office/drawing/2014/main" id="{0EDD01B6-3666-49A0-9F0D-CE16E6BD25E9}"/>
+                <a16:creationId xmlns:a16="http://schemas.microsoft.com/office/drawing/2014/main" id="{D5A6395A-1CDF-4786-A6AF-15B3F64644BD}"/>
               </a:ext>
             </a:extLst>
           </p:cNvPr>
@@ -16486,7 +16405,7 @@
           <p:cNvPr id="6" name="">
             <a:extLst xmlns:a="http://schemas.openxmlformats.org/drawingml/2006/main">
               <a:ext uri="{FF2B5EF4-FFF2-40B4-BE49-F238E27FC236}">
-                <a16:creationId xmlns:a16="http://schemas.microsoft.com/office/drawing/2014/main" id="{3EC8171C-A3BF-443F-B17A-92EA47B0147E}"/>
+                <a16:creationId xmlns:a16="http://schemas.microsoft.com/office/drawing/2014/main" id="{598C3217-21E8-4966-B933-D22C327687CB}"/>
               </a:ext>
             </a:extLst>
           </p:cNvPr>
@@ -16544,7 +16463,7 @@
           <p:cNvPr id="7" name="">
             <a:extLst xmlns:a="http://schemas.openxmlformats.org/drawingml/2006/main">
               <a:ext uri="{FF2B5EF4-FFF2-40B4-BE49-F238E27FC236}">
-                <a16:creationId xmlns:a16="http://schemas.microsoft.com/office/drawing/2014/main" id="{E8E03D1B-0CB3-494B-891F-7DD062DCED9C}"/>
+                <a16:creationId xmlns:a16="http://schemas.microsoft.com/office/drawing/2014/main" id="{7EF0C0F6-6457-4347-885A-D3866E230A65}"/>
               </a:ext>
             </a:extLst>
           </p:cNvPr>
@@ -16602,7 +16521,7 @@
           <p:cNvPr id="8" name="">
             <a:extLst xmlns:a="http://schemas.openxmlformats.org/drawingml/2006/main">
               <a:ext uri="{FF2B5EF4-FFF2-40B4-BE49-F238E27FC236}">
-                <a16:creationId xmlns:a16="http://schemas.microsoft.com/office/drawing/2014/main" id="{813EA537-3CE3-472B-AD38-52F8B060A31B}"/>
+                <a16:creationId xmlns:a16="http://schemas.microsoft.com/office/drawing/2014/main" id="{8A7B0DB0-4083-44E9-B781-84BE9C5F8B8F}"/>
               </a:ext>
             </a:extLst>
           </p:cNvPr>
@@ -16637,7 +16556,7 @@
           <p:cNvPr id="9" name="">
             <a:extLst xmlns:a="http://schemas.openxmlformats.org/drawingml/2006/main">
               <a:ext uri="{FF2B5EF4-FFF2-40B4-BE49-F238E27FC236}">
-                <a16:creationId xmlns:a16="http://schemas.microsoft.com/office/drawing/2014/main" id="{59D5601D-453A-4F27-9F1A-DC095091DA27}"/>
+                <a16:creationId xmlns:a16="http://schemas.microsoft.com/office/drawing/2014/main" id="{961BA2F2-B335-4F98-8BBC-7E3545494C3C}"/>
               </a:ext>
             </a:extLst>
           </p:cNvPr>
@@ -16695,7 +16614,7 @@
           <p:cNvPr id="10" name="">
             <a:extLst xmlns:a="http://schemas.openxmlformats.org/drawingml/2006/main">
               <a:ext uri="{FF2B5EF4-FFF2-40B4-BE49-F238E27FC236}">
-                <a16:creationId xmlns:a16="http://schemas.microsoft.com/office/drawing/2014/main" id="{A3A90B98-3692-4DA3-AF1A-810C04AE36EA}"/>
+                <a16:creationId xmlns:a16="http://schemas.microsoft.com/office/drawing/2014/main" id="{BEA9C5D2-8BDA-4A98-BEDE-F75AF4300000}"/>
               </a:ext>
             </a:extLst>
           </p:cNvPr>
@@ -16730,7 +16649,7 @@
           <p:cNvPr id="11" name="">
             <a:extLst xmlns:a="http://schemas.openxmlformats.org/drawingml/2006/main">
               <a:ext uri="{FF2B5EF4-FFF2-40B4-BE49-F238E27FC236}">
-                <a16:creationId xmlns:a16="http://schemas.microsoft.com/office/drawing/2014/main" id="{E5A26011-8285-467F-BB5B-C61BDCD8AD14}"/>
+                <a16:creationId xmlns:a16="http://schemas.microsoft.com/office/drawing/2014/main" id="{18E0F918-9D26-484C-B08F-F42E783C6363}"/>
               </a:ext>
             </a:extLst>
           </p:cNvPr>
@@ -16788,7 +16707,7 @@
           <p:cNvPr id="12" name="">
             <a:extLst xmlns:a="http://schemas.openxmlformats.org/drawingml/2006/main">
               <a:ext uri="{FF2B5EF4-FFF2-40B4-BE49-F238E27FC236}">
-                <a16:creationId xmlns:a16="http://schemas.microsoft.com/office/drawing/2014/main" id="{E2DED3D7-0BCE-44EC-B53E-C39C9B2A1E0D}"/>
+                <a16:creationId xmlns:a16="http://schemas.microsoft.com/office/drawing/2014/main" id="{BDB345C1-99BA-4776-B64D-25966687E39E}"/>
               </a:ext>
             </a:extLst>
           </p:cNvPr>
@@ -16823,7 +16742,7 @@
           <p:cNvPr id="13" name="">
             <a:extLst xmlns:a="http://schemas.openxmlformats.org/drawingml/2006/main">
               <a:ext uri="{FF2B5EF4-FFF2-40B4-BE49-F238E27FC236}">
-                <a16:creationId xmlns:a16="http://schemas.microsoft.com/office/drawing/2014/main" id="{EC6BAA3A-0E71-4535-97A6-5311BE1CF475}"/>
+                <a16:creationId xmlns:a16="http://schemas.microsoft.com/office/drawing/2014/main" id="{4B36B96E-2D0C-40C7-9530-DBF2734A3438}"/>
               </a:ext>
             </a:extLst>
           </p:cNvPr>
@@ -16881,7 +16800,7 @@
           <p:cNvPr id="14" name="">
             <a:extLst xmlns:a="http://schemas.openxmlformats.org/drawingml/2006/main">
               <a:ext uri="{FF2B5EF4-FFF2-40B4-BE49-F238E27FC236}">
-                <a16:creationId xmlns:a16="http://schemas.microsoft.com/office/drawing/2014/main" id="{C00377E5-380D-497A-A74B-CECBC32D37E8}"/>
+                <a16:creationId xmlns:a16="http://schemas.microsoft.com/office/drawing/2014/main" id="{183FB1D9-FFF5-499E-BED4-A92AFBA672FD}"/>
               </a:ext>
             </a:extLst>
           </p:cNvPr>
@@ -16916,7 +16835,7 @@
           <p:cNvPr id="15" name="">
             <a:extLst xmlns:a="http://schemas.openxmlformats.org/drawingml/2006/main">
               <a:ext uri="{FF2B5EF4-FFF2-40B4-BE49-F238E27FC236}">
-                <a16:creationId xmlns:a16="http://schemas.microsoft.com/office/drawing/2014/main" id="{E911D9C0-C62B-4C3E-8BF3-1A1AB69EA8F8}"/>
+                <a16:creationId xmlns:a16="http://schemas.microsoft.com/office/drawing/2014/main" id="{79A16BE2-AFAE-41BD-BAA4-2F6D2F46EF5F}"/>
               </a:ext>
             </a:extLst>
           </p:cNvPr>
@@ -16974,7 +16893,7 @@
           <p:cNvPr id="16" name="">
             <a:extLst xmlns:a="http://schemas.openxmlformats.org/drawingml/2006/main">
               <a:ext uri="{FF2B5EF4-FFF2-40B4-BE49-F238E27FC236}">
-                <a16:creationId xmlns:a16="http://schemas.microsoft.com/office/drawing/2014/main" id="{F3041A6B-5B78-4330-97FD-F8118D15D47D}"/>
+                <a16:creationId xmlns:a16="http://schemas.microsoft.com/office/drawing/2014/main" id="{5F5D0BDC-5343-4B33-9E7C-E71200B4C7AE}"/>
               </a:ext>
             </a:extLst>
           </p:cNvPr>
@@ -17009,7 +16928,7 @@
           <p:cNvPr id="17" name="">
             <a:extLst xmlns:a="http://schemas.openxmlformats.org/drawingml/2006/main">
               <a:ext uri="{FF2B5EF4-FFF2-40B4-BE49-F238E27FC236}">
-                <a16:creationId xmlns:a16="http://schemas.microsoft.com/office/drawing/2014/main" id="{684EFBBC-F47F-4E74-879F-0B7312417227}"/>
+                <a16:creationId xmlns:a16="http://schemas.microsoft.com/office/drawing/2014/main" id="{E146A809-12CF-499F-A54F-8D79D4ED1150}"/>
               </a:ext>
             </a:extLst>
           </p:cNvPr>
@@ -17067,7 +16986,7 @@
           <p:cNvPr id="18" name="">
             <a:extLst xmlns:a="http://schemas.openxmlformats.org/drawingml/2006/main">
               <a:ext uri="{FF2B5EF4-FFF2-40B4-BE49-F238E27FC236}">
-                <a16:creationId xmlns:a16="http://schemas.microsoft.com/office/drawing/2014/main" id="{6CA6DA47-FDF1-4CF7-BF87-A785F3086724}"/>
+                <a16:creationId xmlns:a16="http://schemas.microsoft.com/office/drawing/2014/main" id="{00990B84-B79E-4FB0-9C16-BC9D73F798A1}"/>
               </a:ext>
             </a:extLst>
           </p:cNvPr>
@@ -17125,7 +17044,7 @@
           <p:cNvPr id="19" name="">
             <a:extLst xmlns:a="http://schemas.openxmlformats.org/drawingml/2006/main">
               <a:ext uri="{FF2B5EF4-FFF2-40B4-BE49-F238E27FC236}">
-                <a16:creationId xmlns:a16="http://schemas.microsoft.com/office/drawing/2014/main" id="{E71DE8F1-F565-420B-867B-72E4514FDB0A}"/>
+                <a16:creationId xmlns:a16="http://schemas.microsoft.com/office/drawing/2014/main" id="{1D0BB9ED-5D07-4073-A6BC-949D98070D55}"/>
               </a:ext>
             </a:extLst>
           </p:cNvPr>
@@ -17160,7 +17079,7 @@
           <p:cNvPr id="20" name="">
             <a:extLst xmlns:a="http://schemas.openxmlformats.org/drawingml/2006/main">
               <a:ext uri="{FF2B5EF4-FFF2-40B4-BE49-F238E27FC236}">
-                <a16:creationId xmlns:a16="http://schemas.microsoft.com/office/drawing/2014/main" id="{A3BE8AF1-B1FC-476D-9DEE-D6A5DA1C8840}"/>
+                <a16:creationId xmlns:a16="http://schemas.microsoft.com/office/drawing/2014/main" id="{FFC4341D-772B-4A32-8B85-48E90D8B344C}"/>
               </a:ext>
             </a:extLst>
           </p:cNvPr>
@@ -17218,7 +17137,7 @@
           <p:cNvPr id="21" name="">
             <a:extLst xmlns:a="http://schemas.openxmlformats.org/drawingml/2006/main">
               <a:ext uri="{FF2B5EF4-FFF2-40B4-BE49-F238E27FC236}">
-                <a16:creationId xmlns:a16="http://schemas.microsoft.com/office/drawing/2014/main" id="{56A33BA3-987D-45C0-BFE5-A3A69F8E48FD}"/>
+                <a16:creationId xmlns:a16="http://schemas.microsoft.com/office/drawing/2014/main" id="{C7C5152E-545C-4A48-8D5B-7BDDDD072414}"/>
               </a:ext>
             </a:extLst>
           </p:cNvPr>
@@ -17253,7 +17172,7 @@
           <p:cNvPr id="22" name="">
             <a:extLst xmlns:a="http://schemas.openxmlformats.org/drawingml/2006/main">
               <a:ext uri="{FF2B5EF4-FFF2-40B4-BE49-F238E27FC236}">
-                <a16:creationId xmlns:a16="http://schemas.microsoft.com/office/drawing/2014/main" id="{A759A347-3903-40D8-8857-702C8B35954E}"/>
+                <a16:creationId xmlns:a16="http://schemas.microsoft.com/office/drawing/2014/main" id="{2AA81145-C9F2-4791-94C0-C9DBA765FEFF}"/>
               </a:ext>
             </a:extLst>
           </p:cNvPr>
@@ -17311,7 +17230,7 @@
           <p:cNvPr id="23" name="">
             <a:extLst xmlns:a="http://schemas.openxmlformats.org/drawingml/2006/main">
               <a:ext uri="{FF2B5EF4-FFF2-40B4-BE49-F238E27FC236}">
-                <a16:creationId xmlns:a16="http://schemas.microsoft.com/office/drawing/2014/main" id="{97E6ECF6-D010-49FC-BB6C-9683722374C6}"/>
+                <a16:creationId xmlns:a16="http://schemas.microsoft.com/office/drawing/2014/main" id="{CF5801BF-8E80-4EC5-A3CB-427093FB45A6}"/>
               </a:ext>
             </a:extLst>
           </p:cNvPr>
@@ -17346,7 +17265,7 @@
           <p:cNvPr id="24" name="">
             <a:extLst xmlns:a="http://schemas.openxmlformats.org/drawingml/2006/main">
               <a:ext uri="{FF2B5EF4-FFF2-40B4-BE49-F238E27FC236}">
-                <a16:creationId xmlns:a16="http://schemas.microsoft.com/office/drawing/2014/main" id="{1C659A9C-6EC8-42C2-8798-17C1BA3CC775}"/>
+                <a16:creationId xmlns:a16="http://schemas.microsoft.com/office/drawing/2014/main" id="{E702D667-3B1D-4D59-B5E4-96C93A006A1A}"/>
               </a:ext>
             </a:extLst>
           </p:cNvPr>
@@ -17404,7 +17323,7 @@
           <p:cNvPr id="25" name="">
             <a:extLst xmlns:a="http://schemas.openxmlformats.org/drawingml/2006/main">
               <a:ext uri="{FF2B5EF4-FFF2-40B4-BE49-F238E27FC236}">
-                <a16:creationId xmlns:a16="http://schemas.microsoft.com/office/drawing/2014/main" id="{340A3B58-7439-4404-922B-78ADC7E343BE}"/>
+                <a16:creationId xmlns:a16="http://schemas.microsoft.com/office/drawing/2014/main" id="{592149AD-0715-451D-A201-F7DB69CC2E4F}"/>
               </a:ext>
             </a:extLst>
           </p:cNvPr>
@@ -17439,7 +17358,7 @@
           <p:cNvPr id="26" name="">
             <a:extLst xmlns:a="http://schemas.openxmlformats.org/drawingml/2006/main">
               <a:ext uri="{FF2B5EF4-FFF2-40B4-BE49-F238E27FC236}">
-                <a16:creationId xmlns:a16="http://schemas.microsoft.com/office/drawing/2014/main" id="{FC255208-1F7E-4ED1-846D-3DC8EE387421}"/>
+                <a16:creationId xmlns:a16="http://schemas.microsoft.com/office/drawing/2014/main" id="{434CC504-D628-42DF-ADD3-A0BB30D0D0C9}"/>
               </a:ext>
             </a:extLst>
           </p:cNvPr>
@@ -17497,7 +17416,7 @@
           <p:cNvPr id="27" name="">
             <a:extLst xmlns:a="http://schemas.openxmlformats.org/drawingml/2006/main">
               <a:ext uri="{FF2B5EF4-FFF2-40B4-BE49-F238E27FC236}">
-                <a16:creationId xmlns:a16="http://schemas.microsoft.com/office/drawing/2014/main" id="{74EF76C9-37F0-4386-9B2E-2F871CBED63A}"/>
+                <a16:creationId xmlns:a16="http://schemas.microsoft.com/office/drawing/2014/main" id="{9EB7A241-993C-4F60-8842-DAB477AC79B7}"/>
               </a:ext>
             </a:extLst>
           </p:cNvPr>
@@ -17532,7 +17451,7 @@
           <p:cNvPr id="28" name="">
             <a:extLst xmlns:a="http://schemas.openxmlformats.org/drawingml/2006/main">
               <a:ext uri="{FF2B5EF4-FFF2-40B4-BE49-F238E27FC236}">
-                <a16:creationId xmlns:a16="http://schemas.microsoft.com/office/drawing/2014/main" id="{83B62B97-C4D8-46A6-8491-12F3458FE6BF}"/>
+                <a16:creationId xmlns:a16="http://schemas.microsoft.com/office/drawing/2014/main" id="{3A2E94F2-5A0F-49E6-837C-0A6E3C1EED8F}"/>
               </a:ext>
             </a:extLst>
           </p:cNvPr>
@@ -17590,7 +17509,7 @@
           <p:cNvPr id="29" name="">
             <a:extLst xmlns:a="http://schemas.openxmlformats.org/drawingml/2006/main">
               <a:ext uri="{FF2B5EF4-FFF2-40B4-BE49-F238E27FC236}">
-                <a16:creationId xmlns:a16="http://schemas.microsoft.com/office/drawing/2014/main" id="{88947812-E124-46F0-93C4-F103AF9CF170}"/>
+                <a16:creationId xmlns:a16="http://schemas.microsoft.com/office/drawing/2014/main" id="{E84B71BD-9781-466D-8CE6-721E00E20AF9}"/>
               </a:ext>
             </a:extLst>
           </p:cNvPr>
@@ -17648,7 +17567,7 @@
           <p:cNvPr id="30" name="">
             <a:extLst xmlns:a="http://schemas.openxmlformats.org/drawingml/2006/main">
               <a:ext uri="{FF2B5EF4-FFF2-40B4-BE49-F238E27FC236}">
-                <a16:creationId xmlns:a16="http://schemas.microsoft.com/office/drawing/2014/main" id="{B750C2A8-2943-4C5A-B737-FA89D5210ABF}"/>
+                <a16:creationId xmlns:a16="http://schemas.microsoft.com/office/drawing/2014/main" id="{A7D3F558-CFFB-40CB-94BB-AE8011F9DE93}"/>
               </a:ext>
             </a:extLst>
           </p:cNvPr>
@@ -17683,7 +17602,7 @@
           <p:cNvPr id="31" name="">
             <a:extLst xmlns:a="http://schemas.openxmlformats.org/drawingml/2006/main">
               <a:ext uri="{FF2B5EF4-FFF2-40B4-BE49-F238E27FC236}">
-                <a16:creationId xmlns:a16="http://schemas.microsoft.com/office/drawing/2014/main" id="{37C15679-6AA0-4A39-A0C2-3A26E8EFF9B4}"/>
+                <a16:creationId xmlns:a16="http://schemas.microsoft.com/office/drawing/2014/main" id="{F8931C98-43C6-4F9E-B6C9-F11A605E9470}"/>
               </a:ext>
             </a:extLst>
           </p:cNvPr>
@@ -17741,7 +17660,7 @@
           <p:cNvPr id="32" name="">
             <a:extLst xmlns:a="http://schemas.openxmlformats.org/drawingml/2006/main">
               <a:ext uri="{FF2B5EF4-FFF2-40B4-BE49-F238E27FC236}">
-                <a16:creationId xmlns:a16="http://schemas.microsoft.com/office/drawing/2014/main" id="{717458E1-A943-476C-B731-3D5FB755BAD1}"/>
+                <a16:creationId xmlns:a16="http://schemas.microsoft.com/office/drawing/2014/main" id="{8DD65E26-9699-4103-AD50-181C5316F1C8}"/>
               </a:ext>
             </a:extLst>
           </p:cNvPr>
@@ -17776,7 +17695,7 @@
           <p:cNvPr id="33" name="">
             <a:extLst xmlns:a="http://schemas.openxmlformats.org/drawingml/2006/main">
               <a:ext uri="{FF2B5EF4-FFF2-40B4-BE49-F238E27FC236}">
-                <a16:creationId xmlns:a16="http://schemas.microsoft.com/office/drawing/2014/main" id="{2A1CDE17-767F-4C7A-B8A1-637DA0123D87}"/>
+                <a16:creationId xmlns:a16="http://schemas.microsoft.com/office/drawing/2014/main" id="{E27D877F-F497-4826-B6DD-4078F28E2472}"/>
               </a:ext>
             </a:extLst>
           </p:cNvPr>
@@ -17834,7 +17753,7 @@
           <p:cNvPr id="34" name="">
             <a:extLst xmlns:a="http://schemas.openxmlformats.org/drawingml/2006/main">
               <a:ext uri="{FF2B5EF4-FFF2-40B4-BE49-F238E27FC236}">
-                <a16:creationId xmlns:a16="http://schemas.microsoft.com/office/drawing/2014/main" id="{178CEEE7-A1A6-43C0-A17E-A5B69F425544}"/>
+                <a16:creationId xmlns:a16="http://schemas.microsoft.com/office/drawing/2014/main" id="{77CD8C56-EDD4-4988-9926-A8F53DFB268C}"/>
               </a:ext>
             </a:extLst>
           </p:cNvPr>
@@ -17869,7 +17788,7 @@
           <p:cNvPr id="35" name="">
             <a:extLst xmlns:a="http://schemas.openxmlformats.org/drawingml/2006/main">
               <a:ext uri="{FF2B5EF4-FFF2-40B4-BE49-F238E27FC236}">
-                <a16:creationId xmlns:a16="http://schemas.microsoft.com/office/drawing/2014/main" id="{D1F420C9-EA4E-4260-B36F-A40A12E3B771}"/>
+                <a16:creationId xmlns:a16="http://schemas.microsoft.com/office/drawing/2014/main" id="{9B7AEF6F-9AFE-4FB4-87CC-E09C8ABE43A2}"/>
               </a:ext>
             </a:extLst>
           </p:cNvPr>
@@ -17927,7 +17846,7 @@
           <p:cNvPr id="36" name="">
             <a:extLst xmlns:a="http://schemas.openxmlformats.org/drawingml/2006/main">
               <a:ext uri="{FF2B5EF4-FFF2-40B4-BE49-F238E27FC236}">
-                <a16:creationId xmlns:a16="http://schemas.microsoft.com/office/drawing/2014/main" id="{AEB4D6D4-CD99-4014-830A-CA10AD70B61B}"/>
+                <a16:creationId xmlns:a16="http://schemas.microsoft.com/office/drawing/2014/main" id="{262B1646-AFA2-420E-B49E-BC147CBEF108}"/>
               </a:ext>
             </a:extLst>
           </p:cNvPr>
@@ -17962,7 +17881,7 @@
           <p:cNvPr id="37" name="">
             <a:extLst xmlns:a="http://schemas.openxmlformats.org/drawingml/2006/main">
               <a:ext uri="{FF2B5EF4-FFF2-40B4-BE49-F238E27FC236}">
-                <a16:creationId xmlns:a16="http://schemas.microsoft.com/office/drawing/2014/main" id="{9EE2C83E-4831-4C3F-B457-A1631F0222BC}"/>
+                <a16:creationId xmlns:a16="http://schemas.microsoft.com/office/drawing/2014/main" id="{A06BCBFC-D5C7-4C3B-A040-9BAC5F3515A0}"/>
               </a:ext>
             </a:extLst>
           </p:cNvPr>
@@ -18020,7 +17939,7 @@
           <p:cNvPr id="38" name="">
             <a:extLst xmlns:a="http://schemas.openxmlformats.org/drawingml/2006/main">
               <a:ext uri="{FF2B5EF4-FFF2-40B4-BE49-F238E27FC236}">
-                <a16:creationId xmlns:a16="http://schemas.microsoft.com/office/drawing/2014/main" id="{203172E0-900C-49FF-B256-7A2E47A446BB}"/>
+                <a16:creationId xmlns:a16="http://schemas.microsoft.com/office/drawing/2014/main" id="{61AB7EEE-6A12-44BC-B107-A8910A312A86}"/>
               </a:ext>
             </a:extLst>
           </p:cNvPr>
@@ -18078,7 +17997,7 @@
           <p:cNvPr id="39" name="">
             <a:extLst xmlns:a="http://schemas.openxmlformats.org/drawingml/2006/main">
               <a:ext uri="{FF2B5EF4-FFF2-40B4-BE49-F238E27FC236}">
-                <a16:creationId xmlns:a16="http://schemas.microsoft.com/office/drawing/2014/main" id="{2617F41E-0E5C-43AA-82D0-6093DCB0B8FE}"/>
+                <a16:creationId xmlns:a16="http://schemas.microsoft.com/office/drawing/2014/main" id="{6F8D6E5F-3F51-4BB5-B2AA-156E80372F8B}"/>
               </a:ext>
             </a:extLst>
           </p:cNvPr>
@@ -18126,7 +18045,7 @@
                 <a:ea typeface="Aptos"/>
                 <a:cs typeface="Aptos"/>
               </a:rPr>
-              <a:t>SMARTCOURSE  /  FYP VIVA</a:t>
+              <a:t>SMARTCOURSE  /  PROJECT</a:t>
             </a:r>
           </a:p>
         </p:txBody>
@@ -18136,7 +18055,7 @@
           <p:cNvPr id="40" name="">
             <a:extLst xmlns:a="http://schemas.openxmlformats.org/drawingml/2006/main">
               <a:ext uri="{FF2B5EF4-FFF2-40B4-BE49-F238E27FC236}">
-                <a16:creationId xmlns:a16="http://schemas.microsoft.com/office/drawing/2014/main" id="{BA1627A0-C6CC-439E-8902-A5BE54A7618B}"/>
+                <a16:creationId xmlns:a16="http://schemas.microsoft.com/office/drawing/2014/main" id="{5B323933-2153-4C54-92DA-19D49787B6A1}"/>
               </a:ext>
             </a:extLst>
           </p:cNvPr>
@@ -18192,7 +18111,7 @@
     </p:spTree>
     <p:extLst>
       <p:ext uri="{BB962C8B-B14F-4D97-AF65-F5344CB8AC3E}">
-        <p14:creationId xmlns:p14="http://schemas.microsoft.com/office/powerpoint/2010/main" val="1987758256"/>
+        <p14:creationId xmlns:p14="http://schemas.microsoft.com/office/powerpoint/2010/main" val="182604336"/>
       </p:ext>
     </p:extLst>
   </p:cSld>
@@ -18223,7 +18142,7 @@
           <p:cNvPr id="32" name="kicker">
             <a:extLst xmlns:a="http://schemas.openxmlformats.org/drawingml/2006/main">
               <a:ext uri="{FF2B5EF4-FFF2-40B4-BE49-F238E27FC236}">
-                <a16:creationId xmlns:a16="http://schemas.microsoft.com/office/drawing/2014/main" id="{E7432DC9-67F8-4916-9ADA-B9555C1B055B}"/>
+                <a16:creationId xmlns:a16="http://schemas.microsoft.com/office/drawing/2014/main" id="{9C220030-2B59-41FF-9239-49CA102768D4}"/>
               </a:ext>
             </a:extLst>
           </p:cNvPr>
@@ -18281,7 +18200,7 @@
           <p:cNvPr id="2" name="title">
             <a:extLst xmlns:a="http://schemas.openxmlformats.org/drawingml/2006/main">
               <a:ext uri="{FF2B5EF4-FFF2-40B4-BE49-F238E27FC236}">
-                <a16:creationId xmlns:a16="http://schemas.microsoft.com/office/drawing/2014/main" id="{EA31835C-C613-417D-AE13-A081421BBDFB}"/>
+                <a16:creationId xmlns:a16="http://schemas.microsoft.com/office/drawing/2014/main" id="{C50D02CA-A9F2-4083-83F8-864A1D0370F3}"/>
               </a:ext>
             </a:extLst>
           </p:cNvPr>
@@ -18339,7 +18258,7 @@
           <p:cNvPr id="3" name="subtitle">
             <a:extLst xmlns:a="http://schemas.openxmlformats.org/drawingml/2006/main">
               <a:ext uri="{FF2B5EF4-FFF2-40B4-BE49-F238E27FC236}">
-                <a16:creationId xmlns:a16="http://schemas.microsoft.com/office/drawing/2014/main" id="{A97142B0-8CB8-49D1-802B-1AF4C77C8FF4}"/>
+                <a16:creationId xmlns:a16="http://schemas.microsoft.com/office/drawing/2014/main" id="{39016C70-D2B5-4F3C-A358-606F4E64A4AB}"/>
               </a:ext>
             </a:extLst>
           </p:cNvPr>
@@ -18397,7 +18316,7 @@
           <p:cNvPr id="4" name="">
             <a:extLst xmlns:a="http://schemas.openxmlformats.org/drawingml/2006/main">
               <a:ext uri="{FF2B5EF4-FFF2-40B4-BE49-F238E27FC236}">
-                <a16:creationId xmlns:a16="http://schemas.microsoft.com/office/drawing/2014/main" id="{1CD1F0CB-9265-441F-A067-52DAD9ED14D6}"/>
+                <a16:creationId xmlns:a16="http://schemas.microsoft.com/office/drawing/2014/main" id="{CFDE6876-67B4-4708-84F1-AAB1F9AAE956}"/>
               </a:ext>
             </a:extLst>
           </p:cNvPr>
@@ -18428,7 +18347,7 @@
           <p:cNvPr id="5" name="">
             <a:extLst xmlns:a="http://schemas.openxmlformats.org/drawingml/2006/main">
               <a:ext uri="{FF2B5EF4-FFF2-40B4-BE49-F238E27FC236}">
-                <a16:creationId xmlns:a16="http://schemas.microsoft.com/office/drawing/2014/main" id="{B3D4B822-B271-4D9B-AA10-252730306D89}"/>
+                <a16:creationId xmlns:a16="http://schemas.microsoft.com/office/drawing/2014/main" id="{A8430C28-F900-485C-83A5-C3F4D50E2BC1}"/>
               </a:ext>
             </a:extLst>
           </p:cNvPr>
@@ -18469,7 +18388,7 @@
           <p:cNvPr id="6" name="">
             <a:extLst xmlns:a="http://schemas.openxmlformats.org/drawingml/2006/main">
               <a:ext uri="{FF2B5EF4-FFF2-40B4-BE49-F238E27FC236}">
-                <a16:creationId xmlns:a16="http://schemas.microsoft.com/office/drawing/2014/main" id="{9BEB53A6-4640-4930-AADA-7BDDA0021532}"/>
+                <a16:creationId xmlns:a16="http://schemas.microsoft.com/office/drawing/2014/main" id="{2393CAF6-524F-4ACA-A05A-D5F821C60322}"/>
               </a:ext>
             </a:extLst>
           </p:cNvPr>
@@ -18527,7 +18446,7 @@
           <p:cNvPr id="7" name="">
             <a:extLst xmlns:a="http://schemas.openxmlformats.org/drawingml/2006/main">
               <a:ext uri="{FF2B5EF4-FFF2-40B4-BE49-F238E27FC236}">
-                <a16:creationId xmlns:a16="http://schemas.microsoft.com/office/drawing/2014/main" id="{81C970EA-4834-43E0-80D4-4FE551A15604}"/>
+                <a16:creationId xmlns:a16="http://schemas.microsoft.com/office/drawing/2014/main" id="{BE516CC7-0EE1-40A9-9D1D-11574953D394}"/>
               </a:ext>
             </a:extLst>
           </p:cNvPr>
@@ -18677,7 +18596,7 @@
           <p:cNvPr id="8" name="">
             <a:extLst xmlns:a="http://schemas.openxmlformats.org/drawingml/2006/main">
               <a:ext uri="{FF2B5EF4-FFF2-40B4-BE49-F238E27FC236}">
-                <a16:creationId xmlns:a16="http://schemas.microsoft.com/office/drawing/2014/main" id="{C6AF5372-C64E-4CF9-A49D-AA31B48A10C7}"/>
+                <a16:creationId xmlns:a16="http://schemas.microsoft.com/office/drawing/2014/main" id="{38112A6A-4CC3-4693-BA4C-DF88B59413EF}"/>
               </a:ext>
             </a:extLst>
           </p:cNvPr>
@@ -18735,7 +18654,7 @@
           <p:cNvPr id="9" name="">
             <a:extLst xmlns:a="http://schemas.openxmlformats.org/drawingml/2006/main">
               <a:ext uri="{FF2B5EF4-FFF2-40B4-BE49-F238E27FC236}">
-                <a16:creationId xmlns:a16="http://schemas.microsoft.com/office/drawing/2014/main" id="{4D1B7472-5CEA-423B-B541-D11C406EDBCD}"/>
+                <a16:creationId xmlns:a16="http://schemas.microsoft.com/office/drawing/2014/main" id="{514F12DD-1A75-44C7-ADA6-DCC6CDDD3B5F}"/>
               </a:ext>
             </a:extLst>
           </p:cNvPr>
@@ -18766,7 +18685,7 @@
           <p:cNvPr id="10" name="">
             <a:extLst xmlns:a="http://schemas.openxmlformats.org/drawingml/2006/main">
               <a:ext uri="{FF2B5EF4-FFF2-40B4-BE49-F238E27FC236}">
-                <a16:creationId xmlns:a16="http://schemas.microsoft.com/office/drawing/2014/main" id="{155E89BC-FC5C-4D0A-81B7-874CBF936209}"/>
+                <a16:creationId xmlns:a16="http://schemas.microsoft.com/office/drawing/2014/main" id="{9A8AB3FB-7ABA-4732-A2D0-08D1B9235648}"/>
               </a:ext>
             </a:extLst>
           </p:cNvPr>
@@ -18824,7 +18743,7 @@
           <p:cNvPr id="11" name="">
             <a:extLst xmlns:a="http://schemas.openxmlformats.org/drawingml/2006/main">
               <a:ext uri="{FF2B5EF4-FFF2-40B4-BE49-F238E27FC236}">
-                <a16:creationId xmlns:a16="http://schemas.microsoft.com/office/drawing/2014/main" id="{6CBD12D9-5D7D-4ABB-A571-D27CDF7C5BA6}"/>
+                <a16:creationId xmlns:a16="http://schemas.microsoft.com/office/drawing/2014/main" id="{B4BA7431-95C2-4A67-B70E-365548588104}"/>
               </a:ext>
             </a:extLst>
           </p:cNvPr>
@@ -18882,7 +18801,7 @@
           <p:cNvPr id="12" name="">
             <a:extLst xmlns:a="http://schemas.openxmlformats.org/drawingml/2006/main">
               <a:ext uri="{FF2B5EF4-FFF2-40B4-BE49-F238E27FC236}">
-                <a16:creationId xmlns:a16="http://schemas.microsoft.com/office/drawing/2014/main" id="{00E5AE09-637F-4D4F-847B-C18CA5A72A8E}"/>
+                <a16:creationId xmlns:a16="http://schemas.microsoft.com/office/drawing/2014/main" id="{F86DD689-D474-4E66-A0D9-DDBE6BAF8E80}"/>
               </a:ext>
             </a:extLst>
           </p:cNvPr>
@@ -18940,7 +18859,7 @@
           <p:cNvPr id="13" name="">
             <a:extLst xmlns:a="http://schemas.openxmlformats.org/drawingml/2006/main">
               <a:ext uri="{FF2B5EF4-FFF2-40B4-BE49-F238E27FC236}">
-                <a16:creationId xmlns:a16="http://schemas.microsoft.com/office/drawing/2014/main" id="{CA31B3B5-0F84-4508-BC36-B2534AA1B6EB}"/>
+                <a16:creationId xmlns:a16="http://schemas.microsoft.com/office/drawing/2014/main" id="{917C71BC-5A1C-4B76-897D-6E765C90A076}"/>
               </a:ext>
             </a:extLst>
           </p:cNvPr>
@@ -18971,7 +18890,7 @@
           <p:cNvPr id="14" name="">
             <a:extLst xmlns:a="http://schemas.openxmlformats.org/drawingml/2006/main">
               <a:ext uri="{FF2B5EF4-FFF2-40B4-BE49-F238E27FC236}">
-                <a16:creationId xmlns:a16="http://schemas.microsoft.com/office/drawing/2014/main" id="{9CE1A50F-11FD-4352-9055-E6F5522C5399}"/>
+                <a16:creationId xmlns:a16="http://schemas.microsoft.com/office/drawing/2014/main" id="{068CB6AC-ADCF-4036-A7C8-9C3AAEFC7A97}"/>
               </a:ext>
             </a:extLst>
           </p:cNvPr>
@@ -19029,7 +18948,7 @@
           <p:cNvPr id="15" name="">
             <a:extLst xmlns:a="http://schemas.openxmlformats.org/drawingml/2006/main">
               <a:ext uri="{FF2B5EF4-FFF2-40B4-BE49-F238E27FC236}">
-                <a16:creationId xmlns:a16="http://schemas.microsoft.com/office/drawing/2014/main" id="{5F094844-C454-49BB-9867-807463FD4ECB}"/>
+                <a16:creationId xmlns:a16="http://schemas.microsoft.com/office/drawing/2014/main" id="{1BC3DFF9-0129-4647-AA17-87E806E98F24}"/>
               </a:ext>
             </a:extLst>
           </p:cNvPr>
@@ -19087,7 +19006,7 @@
           <p:cNvPr id="16" name="">
             <a:extLst xmlns:a="http://schemas.openxmlformats.org/drawingml/2006/main">
               <a:ext uri="{FF2B5EF4-FFF2-40B4-BE49-F238E27FC236}">
-                <a16:creationId xmlns:a16="http://schemas.microsoft.com/office/drawing/2014/main" id="{28376853-6F8C-4177-ADFF-C9A54677C297}"/>
+                <a16:creationId xmlns:a16="http://schemas.microsoft.com/office/drawing/2014/main" id="{131BA02A-0D2D-407C-A43C-4134EC5026D3}"/>
               </a:ext>
             </a:extLst>
           </p:cNvPr>
@@ -19145,7 +19064,7 @@
           <p:cNvPr id="17" name="">
             <a:extLst xmlns:a="http://schemas.openxmlformats.org/drawingml/2006/main">
               <a:ext uri="{FF2B5EF4-FFF2-40B4-BE49-F238E27FC236}">
-                <a16:creationId xmlns:a16="http://schemas.microsoft.com/office/drawing/2014/main" id="{88C319AA-21E4-4EEC-978F-E3310758E7E7}"/>
+                <a16:creationId xmlns:a16="http://schemas.microsoft.com/office/drawing/2014/main" id="{00BAEA20-D450-4A8B-B859-712846B16DCD}"/>
               </a:ext>
             </a:extLst>
           </p:cNvPr>
@@ -19176,7 +19095,7 @@
           <p:cNvPr id="18" name="">
             <a:extLst xmlns:a="http://schemas.openxmlformats.org/drawingml/2006/main">
               <a:ext uri="{FF2B5EF4-FFF2-40B4-BE49-F238E27FC236}">
-                <a16:creationId xmlns:a16="http://schemas.microsoft.com/office/drawing/2014/main" id="{08179AB4-E694-4070-A657-B309C820A02D}"/>
+                <a16:creationId xmlns:a16="http://schemas.microsoft.com/office/drawing/2014/main" id="{4B0CBCE4-D8BB-4AC4-A913-74F747A9284B}"/>
               </a:ext>
             </a:extLst>
           </p:cNvPr>
@@ -19234,7 +19153,7 @@
           <p:cNvPr id="19" name="">
             <a:extLst xmlns:a="http://schemas.openxmlformats.org/drawingml/2006/main">
               <a:ext uri="{FF2B5EF4-FFF2-40B4-BE49-F238E27FC236}">
-                <a16:creationId xmlns:a16="http://schemas.microsoft.com/office/drawing/2014/main" id="{DD7D7CE4-A0EE-4729-B4C6-6AD9AD21F2D1}"/>
+                <a16:creationId xmlns:a16="http://schemas.microsoft.com/office/drawing/2014/main" id="{F0FA6095-2B4C-436A-8FC9-A6D0BE738541}"/>
               </a:ext>
             </a:extLst>
           </p:cNvPr>
@@ -19292,7 +19211,7 @@
           <p:cNvPr id="20" name="">
             <a:extLst xmlns:a="http://schemas.openxmlformats.org/drawingml/2006/main">
               <a:ext uri="{FF2B5EF4-FFF2-40B4-BE49-F238E27FC236}">
-                <a16:creationId xmlns:a16="http://schemas.microsoft.com/office/drawing/2014/main" id="{44C0A042-CB2D-4F17-B5E4-15C6FE423C1D}"/>
+                <a16:creationId xmlns:a16="http://schemas.microsoft.com/office/drawing/2014/main" id="{017FE58A-3C76-4083-AC3D-09D91963959C}"/>
               </a:ext>
             </a:extLst>
           </p:cNvPr>
@@ -19350,7 +19269,7 @@
           <p:cNvPr id="21" name="">
             <a:extLst xmlns:a="http://schemas.openxmlformats.org/drawingml/2006/main">
               <a:ext uri="{FF2B5EF4-FFF2-40B4-BE49-F238E27FC236}">
-                <a16:creationId xmlns:a16="http://schemas.microsoft.com/office/drawing/2014/main" id="{61CBE8F5-E97F-4447-A692-DFA820DE2147}"/>
+                <a16:creationId xmlns:a16="http://schemas.microsoft.com/office/drawing/2014/main" id="{C00DEA3A-A260-4243-B73B-C94F7783D292}"/>
               </a:ext>
             </a:extLst>
           </p:cNvPr>
@@ -19381,7 +19300,7 @@
           <p:cNvPr id="22" name="">
             <a:extLst xmlns:a="http://schemas.openxmlformats.org/drawingml/2006/main">
               <a:ext uri="{FF2B5EF4-FFF2-40B4-BE49-F238E27FC236}">
-                <a16:creationId xmlns:a16="http://schemas.microsoft.com/office/drawing/2014/main" id="{88DF7B2C-9C84-4293-A418-48E34A2F470B}"/>
+                <a16:creationId xmlns:a16="http://schemas.microsoft.com/office/drawing/2014/main" id="{D5EB677A-E6E0-4C8B-9FEB-B1267790DDAA}"/>
               </a:ext>
             </a:extLst>
           </p:cNvPr>
@@ -19439,7 +19358,7 @@
           <p:cNvPr id="23" name="">
             <a:extLst xmlns:a="http://schemas.openxmlformats.org/drawingml/2006/main">
               <a:ext uri="{FF2B5EF4-FFF2-40B4-BE49-F238E27FC236}">
-                <a16:creationId xmlns:a16="http://schemas.microsoft.com/office/drawing/2014/main" id="{96D6C1A0-1369-43B5-8EC3-D52AE3F60444}"/>
+                <a16:creationId xmlns:a16="http://schemas.microsoft.com/office/drawing/2014/main" id="{3B33E5AD-F402-47A9-B227-4C44F7902FD5}"/>
               </a:ext>
             </a:extLst>
           </p:cNvPr>
@@ -19497,7 +19416,7 @@
           <p:cNvPr id="24" name="">
             <a:extLst xmlns:a="http://schemas.openxmlformats.org/drawingml/2006/main">
               <a:ext uri="{FF2B5EF4-FFF2-40B4-BE49-F238E27FC236}">
-                <a16:creationId xmlns:a16="http://schemas.microsoft.com/office/drawing/2014/main" id="{862BBC70-8AA4-4796-B32E-58D166D2F2BD}"/>
+                <a16:creationId xmlns:a16="http://schemas.microsoft.com/office/drawing/2014/main" id="{C3719A8B-EFCD-4933-B589-90C4851C674B}"/>
               </a:ext>
             </a:extLst>
           </p:cNvPr>
@@ -19555,7 +19474,7 @@
           <p:cNvPr id="25" name="">
             <a:extLst xmlns:a="http://schemas.openxmlformats.org/drawingml/2006/main">
               <a:ext uri="{FF2B5EF4-FFF2-40B4-BE49-F238E27FC236}">
-                <a16:creationId xmlns:a16="http://schemas.microsoft.com/office/drawing/2014/main" id="{28DF7298-7CBE-4F28-BC51-68AB5CE3F671}"/>
+                <a16:creationId xmlns:a16="http://schemas.microsoft.com/office/drawing/2014/main" id="{D5847146-21AA-4FD7-B04C-12AD67DE5FB6}"/>
               </a:ext>
             </a:extLst>
           </p:cNvPr>
@@ -19586,7 +19505,7 @@
           <p:cNvPr id="26" name="">
             <a:extLst xmlns:a="http://schemas.openxmlformats.org/drawingml/2006/main">
               <a:ext uri="{FF2B5EF4-FFF2-40B4-BE49-F238E27FC236}">
-                <a16:creationId xmlns:a16="http://schemas.microsoft.com/office/drawing/2014/main" id="{4A6FE851-DAAC-482E-B3BB-8BD283D1BFD1}"/>
+                <a16:creationId xmlns:a16="http://schemas.microsoft.com/office/drawing/2014/main" id="{295513A3-DEA8-4B54-A8E8-67CD097CF4E0}"/>
               </a:ext>
             </a:extLst>
           </p:cNvPr>
@@ -19644,7 +19563,7 @@
           <p:cNvPr id="27" name="">
             <a:extLst xmlns:a="http://schemas.openxmlformats.org/drawingml/2006/main">
               <a:ext uri="{FF2B5EF4-FFF2-40B4-BE49-F238E27FC236}">
-                <a16:creationId xmlns:a16="http://schemas.microsoft.com/office/drawing/2014/main" id="{59277433-BB2E-42A0-A28B-B4CA792CC3F6}"/>
+                <a16:creationId xmlns:a16="http://schemas.microsoft.com/office/drawing/2014/main" id="{F574C215-DF99-4976-BBFF-B91E1D257CCD}"/>
               </a:ext>
             </a:extLst>
           </p:cNvPr>
@@ -19702,7 +19621,7 @@
           <p:cNvPr id="28" name="">
             <a:extLst xmlns:a="http://schemas.openxmlformats.org/drawingml/2006/main">
               <a:ext uri="{FF2B5EF4-FFF2-40B4-BE49-F238E27FC236}">
-                <a16:creationId xmlns:a16="http://schemas.microsoft.com/office/drawing/2014/main" id="{C0446CF5-52D1-46B3-829F-8D2C63CE2147}"/>
+                <a16:creationId xmlns:a16="http://schemas.microsoft.com/office/drawing/2014/main" id="{374B0F19-708B-4C4C-B70D-99CE6BE2838D}"/>
               </a:ext>
             </a:extLst>
           </p:cNvPr>
@@ -19760,7 +19679,7 @@
           <p:cNvPr id="29" name="">
             <a:extLst xmlns:a="http://schemas.openxmlformats.org/drawingml/2006/main">
               <a:ext uri="{FF2B5EF4-FFF2-40B4-BE49-F238E27FC236}">
-                <a16:creationId xmlns:a16="http://schemas.microsoft.com/office/drawing/2014/main" id="{514023FC-BDBA-431F-88C4-77854D7626AA}"/>
+                <a16:creationId xmlns:a16="http://schemas.microsoft.com/office/drawing/2014/main" id="{A8BCB0B9-6698-48A9-AE7E-14EE61187DCC}"/>
               </a:ext>
             </a:extLst>
           </p:cNvPr>
@@ -19818,7 +19737,7 @@
           <p:cNvPr id="30" name="">
             <a:extLst xmlns:a="http://schemas.openxmlformats.org/drawingml/2006/main">
               <a:ext uri="{FF2B5EF4-FFF2-40B4-BE49-F238E27FC236}">
-                <a16:creationId xmlns:a16="http://schemas.microsoft.com/office/drawing/2014/main" id="{8EE23208-3C55-41FD-B89F-B8A108B7F5B4}"/>
+                <a16:creationId xmlns:a16="http://schemas.microsoft.com/office/drawing/2014/main" id="{1B10E7E3-0D60-4DA6-8BB1-A178BB0801BF}"/>
               </a:ext>
             </a:extLst>
           </p:cNvPr>
@@ -19866,7 +19785,7 @@
                 <a:ea typeface="Aptos"/>
                 <a:cs typeface="Aptos"/>
               </a:rPr>
-              <a:t>SMARTCOURSE  /  FYP VIVA</a:t>
+              <a:t>SMARTCOURSE  /  PROJECT</a:t>
             </a:r>
           </a:p>
         </p:txBody>
@@ -19876,7 +19795,7 @@
           <p:cNvPr id="31" name="">
             <a:extLst xmlns:a="http://schemas.openxmlformats.org/drawingml/2006/main">
               <a:ext uri="{FF2B5EF4-FFF2-40B4-BE49-F238E27FC236}">
-                <a16:creationId xmlns:a16="http://schemas.microsoft.com/office/drawing/2014/main" id="{3C4244E2-D4C7-46DF-8AA7-8038ED635C51}"/>
+                <a16:creationId xmlns:a16="http://schemas.microsoft.com/office/drawing/2014/main" id="{E75CA460-A09C-47FF-8C19-C80FE93CAAA6}"/>
               </a:ext>
             </a:extLst>
           </p:cNvPr>
@@ -19932,7 +19851,7 @@
     </p:spTree>
     <p:extLst>
       <p:ext uri="{BB962C8B-B14F-4D97-AF65-F5344CB8AC3E}">
-        <p14:creationId xmlns:p14="http://schemas.microsoft.com/office/powerpoint/2010/main" val="785687576"/>
+        <p14:creationId xmlns:p14="http://schemas.microsoft.com/office/powerpoint/2010/main" val="719073366"/>
       </p:ext>
     </p:extLst>
   </p:cSld>
@@ -19963,7 +19882,7 @@
           <p:cNvPr id="13" name="kicker">
             <a:extLst xmlns:a="http://schemas.openxmlformats.org/drawingml/2006/main">
               <a:ext uri="{FF2B5EF4-FFF2-40B4-BE49-F238E27FC236}">
-                <a16:creationId xmlns:a16="http://schemas.microsoft.com/office/drawing/2014/main" id="{7997EB7F-87D0-4D1F-A083-F14EE579BBDA}"/>
+                <a16:creationId xmlns:a16="http://schemas.microsoft.com/office/drawing/2014/main" id="{6D1734A7-A4FB-4330-8692-41C698EAB7AF}"/>
               </a:ext>
             </a:extLst>
           </p:cNvPr>
@@ -20021,7 +19940,7 @@
           <p:cNvPr id="2" name="title">
             <a:extLst xmlns:a="http://schemas.openxmlformats.org/drawingml/2006/main">
               <a:ext uri="{FF2B5EF4-FFF2-40B4-BE49-F238E27FC236}">
-                <a16:creationId xmlns:a16="http://schemas.microsoft.com/office/drawing/2014/main" id="{27DE2D4F-B52E-4F8D-93DE-2F444BFC7BB4}"/>
+                <a16:creationId xmlns:a16="http://schemas.microsoft.com/office/drawing/2014/main" id="{E30EDB54-C19F-4EDC-A406-6676EDA7D4D4}"/>
               </a:ext>
             </a:extLst>
           </p:cNvPr>
@@ -20079,7 +19998,7 @@
           <p:cNvPr id="3" name="subtitle">
             <a:extLst xmlns:a="http://schemas.openxmlformats.org/drawingml/2006/main">
               <a:ext uri="{FF2B5EF4-FFF2-40B4-BE49-F238E27FC236}">
-                <a16:creationId xmlns:a16="http://schemas.microsoft.com/office/drawing/2014/main" id="{602991E0-8E51-40B3-9F84-41700E9098FB}"/>
+                <a16:creationId xmlns:a16="http://schemas.microsoft.com/office/drawing/2014/main" id="{89600BBD-E298-469F-8A9C-14B72655F7E4}"/>
               </a:ext>
             </a:extLst>
           </p:cNvPr>
@@ -20137,7 +20056,7 @@
           <p:cNvPr id="4" name="">
             <a:extLst xmlns:a="http://schemas.openxmlformats.org/drawingml/2006/main">
               <a:ext uri="{FF2B5EF4-FFF2-40B4-BE49-F238E27FC236}">
-                <a16:creationId xmlns:a16="http://schemas.microsoft.com/office/drawing/2014/main" id="{BB916ECF-6B3A-4DAC-86D7-486BA10B2C66}"/>
+                <a16:creationId xmlns:a16="http://schemas.microsoft.com/office/drawing/2014/main" id="{1592AE05-0219-469C-AEFC-267C552A1AC2}"/>
               </a:ext>
             </a:extLst>
           </p:cNvPr>
@@ -20168,7 +20087,7 @@
           <p:cNvPr id="5" name="">
             <a:extLst xmlns:a="http://schemas.openxmlformats.org/drawingml/2006/main">
               <a:ext uri="{FF2B5EF4-FFF2-40B4-BE49-F238E27FC236}">
-                <a16:creationId xmlns:a16="http://schemas.microsoft.com/office/drawing/2014/main" id="{9BB33319-1CF8-46A8-B996-B02038067F4B}"/>
+                <a16:creationId xmlns:a16="http://schemas.microsoft.com/office/drawing/2014/main" id="{8C6EBA0A-CC57-44A1-8886-8B5D3E1E2C41}"/>
               </a:ext>
             </a:extLst>
           </p:cNvPr>
@@ -20213,7 +20132,7 @@
           <p:nvPr/>
         </p:nvPicPr>
         <p:blipFill>
-          <a:blip xmlns:r="http://schemas.openxmlformats.org/officeDocument/2006/relationships" xmlns:a="http://schemas.openxmlformats.org/drawingml/2006/main" r:embed="R0d00dcc76c574810"/>
+          <a:blip xmlns:r="http://schemas.openxmlformats.org/officeDocument/2006/relationships" xmlns:a="http://schemas.openxmlformats.org/drawingml/2006/main" r:embed="Raf7ca18d713f4c70"/>
           <a:srcRect xmlns:a="http://schemas.openxmlformats.org/drawingml/2006/main" l="111" t="0" r="111" b="0"/>
           <a:stretch xmlns:a="http://schemas.openxmlformats.org/drawingml/2006/main">
             <a:fillRect l="0" t="0" r="0" b="0"/>
@@ -20236,7 +20155,7 @@
           <p:cNvPr id="7" name="">
             <a:extLst xmlns:a="http://schemas.openxmlformats.org/drawingml/2006/main">
               <a:ext uri="{FF2B5EF4-FFF2-40B4-BE49-F238E27FC236}">
-                <a16:creationId xmlns:a16="http://schemas.microsoft.com/office/drawing/2014/main" id="{28DBC748-32BC-48BE-97B5-33855111BE34}"/>
+                <a16:creationId xmlns:a16="http://schemas.microsoft.com/office/drawing/2014/main" id="{0FA35976-CB30-4B50-99C5-7913BDAFD86A}"/>
               </a:ext>
             </a:extLst>
           </p:cNvPr>
@@ -20294,7 +20213,7 @@
           <p:cNvPr id="8" name="">
             <a:extLst xmlns:a="http://schemas.openxmlformats.org/drawingml/2006/main">
               <a:ext uri="{FF2B5EF4-FFF2-40B4-BE49-F238E27FC236}">
-                <a16:creationId xmlns:a16="http://schemas.microsoft.com/office/drawing/2014/main" id="{A6E469B7-64B1-4A1D-9421-31A5441C8A17}"/>
+                <a16:creationId xmlns:a16="http://schemas.microsoft.com/office/drawing/2014/main" id="{4CCB6320-5F98-4982-B19B-44F29FA9B066}"/>
               </a:ext>
             </a:extLst>
           </p:cNvPr>
@@ -20339,7 +20258,7 @@
           <p:nvPr/>
         </p:nvPicPr>
         <p:blipFill>
-          <a:blip xmlns:r="http://schemas.openxmlformats.org/officeDocument/2006/relationships" xmlns:a="http://schemas.openxmlformats.org/drawingml/2006/main" r:embed="R13b325b3d1dc420c"/>
+          <a:blip xmlns:r="http://schemas.openxmlformats.org/officeDocument/2006/relationships" xmlns:a="http://schemas.openxmlformats.org/drawingml/2006/main" r:embed="R26247bca6c014808"/>
           <a:srcRect xmlns:a="http://schemas.openxmlformats.org/drawingml/2006/main" l="0" t="4720" r="0" b="4720"/>
           <a:stretch xmlns:a="http://schemas.openxmlformats.org/drawingml/2006/main">
             <a:fillRect l="0" t="0" r="0" b="0"/>
@@ -20362,7 +20281,7 @@
           <p:cNvPr id="10" name="">
             <a:extLst xmlns:a="http://schemas.openxmlformats.org/drawingml/2006/main">
               <a:ext uri="{FF2B5EF4-FFF2-40B4-BE49-F238E27FC236}">
-                <a16:creationId xmlns:a16="http://schemas.microsoft.com/office/drawing/2014/main" id="{73989BA6-B505-47D6-88E8-2E5B63CC3A64}"/>
+                <a16:creationId xmlns:a16="http://schemas.microsoft.com/office/drawing/2014/main" id="{B5672889-2630-4886-902B-FACBF793B5A0}"/>
               </a:ext>
             </a:extLst>
           </p:cNvPr>
@@ -20420,7 +20339,7 @@
           <p:cNvPr id="11" name="">
             <a:extLst xmlns:a="http://schemas.openxmlformats.org/drawingml/2006/main">
               <a:ext uri="{FF2B5EF4-FFF2-40B4-BE49-F238E27FC236}">
-                <a16:creationId xmlns:a16="http://schemas.microsoft.com/office/drawing/2014/main" id="{90B888FF-BA73-4DAA-B9AA-1771306B6779}"/>
+                <a16:creationId xmlns:a16="http://schemas.microsoft.com/office/drawing/2014/main" id="{F2A9B1D3-326F-47BE-ACC7-C70D384E3086}"/>
               </a:ext>
             </a:extLst>
           </p:cNvPr>
@@ -20468,7 +20387,7 @@
                 <a:ea typeface="Aptos"/>
                 <a:cs typeface="Aptos"/>
               </a:rPr>
-              <a:t>SMARTCOURSE  /  FYP VIVA</a:t>
+              <a:t>SMARTCOURSE  /  PROJECT</a:t>
             </a:r>
           </a:p>
         </p:txBody>
@@ -20478,7 +20397,7 @@
           <p:cNvPr id="12" name="">
             <a:extLst xmlns:a="http://schemas.openxmlformats.org/drawingml/2006/main">
               <a:ext uri="{FF2B5EF4-FFF2-40B4-BE49-F238E27FC236}">
-                <a16:creationId xmlns:a16="http://schemas.microsoft.com/office/drawing/2014/main" id="{540944E6-FC5A-4D2E-912A-2427A8DBBFCC}"/>
+                <a16:creationId xmlns:a16="http://schemas.microsoft.com/office/drawing/2014/main" id="{ED843E97-BF62-4558-91E0-2EC82476B5C6}"/>
               </a:ext>
             </a:extLst>
           </p:cNvPr>
@@ -20534,7 +20453,7 @@
     </p:spTree>
     <p:extLst>
       <p:ext uri="{BB962C8B-B14F-4D97-AF65-F5344CB8AC3E}">
-        <p14:creationId xmlns:p14="http://schemas.microsoft.com/office/powerpoint/2010/main" val="1303369513"/>
+        <p14:creationId xmlns:p14="http://schemas.microsoft.com/office/powerpoint/2010/main" val="944698672"/>
       </p:ext>
     </p:extLst>
   </p:cSld>
@@ -20565,7 +20484,7 @@
           <p:cNvPr id="10" name="kicker">
             <a:extLst xmlns:a="http://schemas.openxmlformats.org/drawingml/2006/main">
               <a:ext uri="{FF2B5EF4-FFF2-40B4-BE49-F238E27FC236}">
-                <a16:creationId xmlns:a16="http://schemas.microsoft.com/office/drawing/2014/main" id="{EB588A19-7BAB-4293-9F0C-54BFEC5BE3B2}"/>
+                <a16:creationId xmlns:a16="http://schemas.microsoft.com/office/drawing/2014/main" id="{C4670B94-FF56-47A3-8DA9-EBE06223E170}"/>
               </a:ext>
             </a:extLst>
           </p:cNvPr>
@@ -20623,7 +20542,7 @@
           <p:cNvPr id="2" name="title">
             <a:extLst xmlns:a="http://schemas.openxmlformats.org/drawingml/2006/main">
               <a:ext uri="{FF2B5EF4-FFF2-40B4-BE49-F238E27FC236}">
-                <a16:creationId xmlns:a16="http://schemas.microsoft.com/office/drawing/2014/main" id="{25286914-E39A-4C0F-A9A0-A47E010C17C8}"/>
+                <a16:creationId xmlns:a16="http://schemas.microsoft.com/office/drawing/2014/main" id="{39DD5444-8297-4847-9C6C-620FA87EAE54}"/>
               </a:ext>
             </a:extLst>
           </p:cNvPr>
@@ -20681,7 +20600,7 @@
           <p:cNvPr id="3" name="subtitle">
             <a:extLst xmlns:a="http://schemas.openxmlformats.org/drawingml/2006/main">
               <a:ext uri="{FF2B5EF4-FFF2-40B4-BE49-F238E27FC236}">
-                <a16:creationId xmlns:a16="http://schemas.microsoft.com/office/drawing/2014/main" id="{55C92963-F011-490F-A2FF-07A939C1BB60}"/>
+                <a16:creationId xmlns:a16="http://schemas.microsoft.com/office/drawing/2014/main" id="{2E695292-8D7D-43CA-ABF4-C9F1EEC2754D}"/>
               </a:ext>
             </a:extLst>
           </p:cNvPr>
@@ -20739,7 +20658,7 @@
           <p:cNvPr id="4" name="">
             <a:extLst xmlns:a="http://schemas.openxmlformats.org/drawingml/2006/main">
               <a:ext uri="{FF2B5EF4-FFF2-40B4-BE49-F238E27FC236}">
-                <a16:creationId xmlns:a16="http://schemas.microsoft.com/office/drawing/2014/main" id="{649C3125-0A8A-4893-97F1-75E788B91D6A}"/>
+                <a16:creationId xmlns:a16="http://schemas.microsoft.com/office/drawing/2014/main" id="{BC68E5C9-AB76-424B-90EE-B8CACE6ED9EC}"/>
               </a:ext>
             </a:extLst>
           </p:cNvPr>
@@ -20770,7 +20689,7 @@
           <p:cNvPr id="5" name="">
             <a:extLst xmlns:a="http://schemas.openxmlformats.org/drawingml/2006/main">
               <a:ext uri="{FF2B5EF4-FFF2-40B4-BE49-F238E27FC236}">
-                <a16:creationId xmlns:a16="http://schemas.microsoft.com/office/drawing/2014/main" id="{CEE5ECFE-09B7-45E0-8F51-3C1CDBEC3EFB}"/>
+                <a16:creationId xmlns:a16="http://schemas.microsoft.com/office/drawing/2014/main" id="{A0D3D23F-0359-4BE3-AB72-E144602C0BE0}"/>
               </a:ext>
             </a:extLst>
           </p:cNvPr>
@@ -20815,7 +20734,7 @@
           <p:nvPr/>
         </p:nvPicPr>
         <p:blipFill>
-          <a:blip xmlns:r="http://schemas.openxmlformats.org/officeDocument/2006/relationships" xmlns:a="http://schemas.openxmlformats.org/drawingml/2006/main" r:embed="R2f7fbd841ee64174"/>
+          <a:blip xmlns:r="http://schemas.openxmlformats.org/officeDocument/2006/relationships" xmlns:a="http://schemas.openxmlformats.org/drawingml/2006/main" r:embed="R130a896fd8354e95"/>
           <a:srcRect xmlns:a="http://schemas.openxmlformats.org/drawingml/2006/main" l="0" t="22010" r="0" b="22010"/>
           <a:stretch xmlns:a="http://schemas.openxmlformats.org/drawingml/2006/main">
             <a:fillRect l="0" t="0" r="0" b="0"/>
@@ -20838,7 +20757,7 @@
           <p:cNvPr id="7" name="">
             <a:extLst xmlns:a="http://schemas.openxmlformats.org/drawingml/2006/main">
               <a:ext uri="{FF2B5EF4-FFF2-40B4-BE49-F238E27FC236}">
-                <a16:creationId xmlns:a16="http://schemas.microsoft.com/office/drawing/2014/main" id="{6031B324-A12D-4804-B707-280CBAD87C45}"/>
+                <a16:creationId xmlns:a16="http://schemas.microsoft.com/office/drawing/2014/main" id="{9FA0ECE9-13F3-4B8E-8AE5-BEF6495AE4A6}"/>
               </a:ext>
             </a:extLst>
           </p:cNvPr>
@@ -20896,7 +20815,7 @@
           <p:cNvPr id="8" name="">
             <a:extLst xmlns:a="http://schemas.openxmlformats.org/drawingml/2006/main">
               <a:ext uri="{FF2B5EF4-FFF2-40B4-BE49-F238E27FC236}">
-                <a16:creationId xmlns:a16="http://schemas.microsoft.com/office/drawing/2014/main" id="{AC22ABED-F74B-4A70-A54A-A295EBC030E2}"/>
+                <a16:creationId xmlns:a16="http://schemas.microsoft.com/office/drawing/2014/main" id="{4DB639B4-0CEB-4E4E-8A8E-972DC1BB420D}"/>
               </a:ext>
             </a:extLst>
           </p:cNvPr>
@@ -20944,7 +20863,7 @@
                 <a:ea typeface="Aptos"/>
                 <a:cs typeface="Aptos"/>
               </a:rPr>
-              <a:t>SMARTCOURSE  /  FYP VIVA</a:t>
+              <a:t>SMARTCOURSE  /  PROJECT</a:t>
             </a:r>
           </a:p>
         </p:txBody>
@@ -20954,7 +20873,7 @@
           <p:cNvPr id="9" name="">
             <a:extLst xmlns:a="http://schemas.openxmlformats.org/drawingml/2006/main">
               <a:ext uri="{FF2B5EF4-FFF2-40B4-BE49-F238E27FC236}">
-                <a16:creationId xmlns:a16="http://schemas.microsoft.com/office/drawing/2014/main" id="{8B1CF63C-86AB-41BB-BE41-CBF3A3A61B8D}"/>
+                <a16:creationId xmlns:a16="http://schemas.microsoft.com/office/drawing/2014/main" id="{443E4933-5AC2-4B3A-8335-0A87898B4624}"/>
               </a:ext>
             </a:extLst>
           </p:cNvPr>
@@ -21010,7 +20929,7 @@
     </p:spTree>
     <p:extLst>
       <p:ext uri="{BB962C8B-B14F-4D97-AF65-F5344CB8AC3E}">
-        <p14:creationId xmlns:p14="http://schemas.microsoft.com/office/powerpoint/2010/main" val="2036075059"/>
+        <p14:creationId xmlns:p14="http://schemas.microsoft.com/office/powerpoint/2010/main" val="428682518"/>
       </p:ext>
     </p:extLst>
   </p:cSld>

</xml_diff>